<commit_message>
Update pitch and document verified live Gemini investigation
</commit_message>
<xml_diff>
--- a/docs/submission/BatchLens-Pitch-Review.pptx
+++ b/docs/submission/BatchLens-Pitch-Review.pptx
@@ -7272,7 +7272,7 @@
                 <a:cs typeface="Google Sans Flex"/>
                 <a:sym typeface="Google Sans Flex"/>
               </a:rPr>
-              <a:t>Saved scope, reviewer rationale and source references, exportable as HTML or CSV.</a:t>
+              <a:t>Real Gemini tool calls and cited findings. Operator approval controls the final scope.</a:t>
             </a:r>
             <a:endParaRPr sz="1600">
               <a:solidFill>
@@ -7302,8 +7302,8 @@
         </p:blipFill>
         <p:spPr>
           <a:xfrm>
-            <a:off x="700799" y="1295400"/>
-            <a:ext cx="2675100" cy="3111499"/>
+            <a:off x="700799" y="1781558"/>
+            <a:ext cx="2675100" cy="2139183"/>
           </a:xfrm>
           <a:prstGeom prst="rect">
             <a:avLst/>
@@ -7361,7 +7361,7 @@
                 <a:cs typeface="Google Sans Flex"/>
                 <a:sym typeface="Google Sans Flex"/>
               </a:rPr>
-              <a:t>1,500 units</a:t>
+              <a:t>Pip investigates.</a:t>
             </a:r>
             <a:endParaRPr b="1" sz="3000">
               <a:solidFill>
@@ -7396,7 +7396,7 @@
                 <a:cs typeface="Google Sans Flex"/>
                 <a:sym typeface="Google Sans Flex"/>
               </a:rPr>
-              <a:t>Zero unresolved</a:t>
+              <a:t>You review.</a:t>
             </a:r>
             <a:endParaRPr b="1" sz="3000">
               <a:solidFill>
@@ -7457,7 +7457,7 @@
                 <a:cs typeface="Google Sans Flex"/>
                 <a:sym typeface="Google Sans Flex"/>
               </a:rPr>
-              <a:t>A saved decision.</a:t>
+              <a:t>Source-cited findings.</a:t>
             </a:r>
             <a:endParaRPr b="1" sz="3000">
               <a:solidFill>
@@ -7492,7 +7492,7 @@
                 <a:cs typeface="Google Sans Flex"/>
                 <a:sym typeface="Google Sans Flex"/>
               </a:rPr>
-              <a:t>With its paper trail.</a:t>
+              <a:t>A clear handover.</a:t>
             </a:r>
             <a:endParaRPr b="1" sz="3000">
               <a:solidFill>
@@ -7898,7 +7898,7 @@
                 <a:cs typeface="Google Sans Flex"/>
                 <a:sym typeface="Google Sans Flex"/>
               </a:rPr>
-              <a:t>REAL GEMINI, VERIFIED</a:t>
+              <a:t>REAL GEMINI TOOL CALLING</a:t>
             </a:r>
             <a:endParaRPr sz="1900">
               <a:solidFill>
@@ -7933,7 +7933,7 @@
                 <a:cs typeface="Google Sans Flex"/>
                 <a:sym typeface="Google Sans Flex"/>
               </a:rPr>
-              <a:t>B101 / CAP-17 / null / B104</a:t>
+              <a:t>12 tool actions / 4 cited findings</a:t>
             </a:r>
             <a:endParaRPr sz="1900">
               <a:solidFill>
@@ -7994,7 +7994,7 @@
                 <a:cs typeface="Google Sans Flex"/>
                 <a:sym typeface="Google Sans Flex"/>
               </a:rPr>
-              <a:t>10 backend tests passed</a:t>
+              <a:t>14 backend tests passed</a:t>
             </a:r>
             <a:endParaRPr sz="1900">
               <a:solidFill>
@@ -8029,7 +8029,7 @@
                 <a:cs typeface="Google Sans Flex"/>
                 <a:sym typeface="Google Sans Flex"/>
               </a:rPr>
-              <a:t>Exports and saved reload passed</a:t>
+              <a:t>Human approval gates verified</a:t>
             </a:r>
             <a:endParaRPr sz="1900">
               <a:solidFill>
@@ -8090,7 +8090,7 @@
                 <a:cs typeface="Google Sans Flex"/>
                 <a:sym typeface="Google Sans Flex"/>
               </a:rPr>
-              <a:t>Observed in one synthetic case: first scan 26.9 s, later scans 1.6–1.8 s.</a:t>
+              <a:t>Observed in one synthetic investigation. Gemini chose the tools and archive query.</a:t>
             </a:r>
             <a:endParaRPr>
               <a:solidFill>
@@ -8125,7 +8125,7 @@
                 <a:cs typeface="Google Sans Flex"/>
                 <a:sym typeface="Google Sans Flex"/>
               </a:rPr>
-              <a:t>Workflow evidence, not a production accuracy or savings claim.</a:t>
+              <a:t>Draft findings did not approve the baseline, S4 mapping or inspection proposal.</a:t>
             </a:r>
             <a:endParaRPr>
               <a:solidFill>
@@ -8496,7 +8496,7 @@
                 <a:cs typeface="Google Sans Flex"/>
                 <a:sym typeface="Google Sans Flex"/>
               </a:rPr>
-              <a:t>Measure review time, mapping errors and reviewer confidence.</a:t>
+              <a:t>Measure evidence coverage, review time and mapping errors.</a:t>
             </a:r>
             <a:endParaRPr sz="1900">
               <a:solidFill>
@@ -8557,7 +8557,7 @@
                 <a:cs typeface="Google Sans Flex"/>
                 <a:sym typeface="Google Sans Flex"/>
               </a:rPr>
-              <a:t>Then expand to controlled uploads, multiple cases and ERP integration.</a:t>
+              <a:t>Next: controlled uploads, external ERP tools and multi-case evaluation.</a:t>
             </a:r>
             <a:endParaRPr sz="1900">
               <a:solidFill>
@@ -9466,7 +9466,7 @@
                 <a:cs typeface="Google Sans Flex"/>
                 <a:sym typeface="Google Sans Flex"/>
               </a:rPr>
-              <a:t>A quality reviewer must decide what to inspect.</a:t>
+              <a:t>Gemini investigates.</a:t>
             </a:r>
             <a:endParaRPr sz="2000">
               <a:solidFill>
@@ -9487,7 +9487,7 @@
                 <a:spcPts val="400"/>
               </a:spcBef>
               <a:spcAft>
-                <a:spcPts val="400"/>
+                <a:spcPts val="0"/>
               </a:spcAft>
               <a:buNone/>
             </a:pPr>
@@ -9501,7 +9501,42 @@
                 <a:cs typeface="Google Sans Flex"/>
                 <a:sym typeface="Google Sans Flex"/>
               </a:rPr>
-              <a:t>The answer is scattered across factory records.</a:t>
+              <a:t>You review the evidence</a:t>
+            </a:r>
+            <a:endParaRPr sz="2000">
+              <a:solidFill>
+                <a:srgbClr val="B4C8BE"/>
+              </a:solidFill>
+              <a:latin typeface="Google Sans Flex"/>
+              <a:ea typeface="Google Sans Flex"/>
+              <a:cs typeface="Google Sans Flex"/>
+              <a:sym typeface="Google Sans Flex"/>
+            </a:endParaRPr>
+          </a:p>
+          <a:p>
+            <a:pPr indent="0" lvl="0" marL="0" rtl="0" algn="l">
+              <a:lnSpc>
+                <a:spcPct val="105000"/>
+              </a:lnSpc>
+              <a:spcBef>
+                <a:spcPts val="400"/>
+              </a:spcBef>
+              <a:spcAft>
+                <a:spcPts val="400"/>
+              </a:spcAft>
+              <a:buNone/>
+            </a:pPr>
+            <a:r>
+              <a:rPr lang="en-GB" sz="2000">
+                <a:solidFill>
+                  <a:srgbClr val="B4C8BE"/>
+                </a:solidFill>
+                <a:latin typeface="Google Sans Flex"/>
+                <a:ea typeface="Google Sans Flex"/>
+                <a:cs typeface="Google Sans Flex"/>
+                <a:sym typeface="Google Sans Flex"/>
+              </a:rPr>
+              <a:t>and approve decisions.</a:t>
             </a:r>
             <a:endParaRPr sz="2000">
               <a:solidFill>
@@ -9833,7 +9868,7 @@
                 <a:cs typeface="Google Sans Flex Medium"/>
                 <a:sym typeface="Google Sans Flex Medium"/>
               </a:rPr>
-              <a:t>DIFFERENCE: Source review links AI readings to shipment decisions.</a:t>
+              <a:t>DIFFERENCE: Gemini selects investigative tools, not just OCR.</a:t>
             </a:r>
             <a:endParaRPr sz="1600">
               <a:solidFill>
@@ -9865,7 +9900,7 @@
                 <a:cs typeface="Google Sans Flex Medium"/>
                 <a:sym typeface="Google Sans Flex Medium"/>
               </a:rPr>
-              <a:t>SOLUTION: Keep unknown mappings in conservative inspection scope.</a:t>
+              <a:t>SOLUTION: Read sources, trace exposure and seek missing records.</a:t>
             </a:r>
             <a:endParaRPr sz="1600">
               <a:solidFill>
@@ -9897,7 +9932,7 @@
                 <a:cs typeface="Google Sans Flex Medium"/>
                 <a:sym typeface="Google Sans Flex Medium"/>
               </a:rPr>
-              <a:t>USP: A playable factory investigation with a verifiable paper trail.</a:t>
+              <a:t>USP: A playable factory with an auditable agent journal.</a:t>
             </a:r>
             <a:endParaRPr sz="1600">
               <a:solidFill>
@@ -9958,7 +9993,7 @@
                 <a:cs typeface="Google Sans Flex"/>
                 <a:sym typeface="Google Sans Flex"/>
               </a:rPr>
-              <a:t>The AI reads.</a:t>
+              <a:t>Pip investigates.</a:t>
             </a:r>
             <a:endParaRPr b="1" sz="3900">
               <a:solidFill>
@@ -10054,7 +10089,7 @@
                 <a:cs typeface="Google Sans Flex"/>
                 <a:sym typeface="Google Sans Flex"/>
               </a:rPr>
-              <a:t>Source quotations, visible uncertainty and a reproducible trace.</a:t>
+              <a:t>Tool actions, source-cited findings and visible uncertainty.</a:t>
             </a:r>
             <a:endParaRPr sz="2000">
               <a:solidFill>
@@ -10089,7 +10124,7 @@
                 <a:cs typeface="Google Sans Flex"/>
                 <a:sym typeface="Google Sans Flex"/>
               </a:rPr>
-              <a:t>Every accepted connection has a paper trail.</a:t>
+              <a:t>Confirmed records control the inspection scope.</a:t>
             </a:r>
             <a:endParaRPr sz="2000">
               <a:solidFill>
@@ -10399,7 +10434,7 @@
                 <a:cs typeface="Google Sans Flex"/>
                 <a:sym typeface="Google Sans Flex"/>
               </a:rPr>
-              <a:t>Read source images with Gemini. Compare quotes, correct candidates and confirm the baseline.</a:t>
+              <a:t>Gemini reads source images. Review quotations and pending identifiers before confirming the baseline.</a:t>
             </a:r>
             <a:endParaRPr sz="1600">
               <a:solidFill>
@@ -10521,7 +10556,7 @@
                 <a:cs typeface="Google Sans Flex"/>
                 <a:sym typeface="Google Sans Flex"/>
               </a:rPr>
-              <a:t>Follow CAP-17 through finished batches to shipments. Keep missing mappings unresolved.</a:t>
+              <a:t>Pip calls the trace tool. Deterministic scope keeps unknown shipment mappings unresolved.</a:t>
             </a:r>
             <a:endParaRPr sz="1600">
               <a:solidFill>
@@ -10582,7 +10617,7 @@
                 <a:cs typeface="Google Sans Flex"/>
                 <a:sym typeface="Google Sans Flex"/>
               </a:rPr>
-              <a:t>Pip’s dispatch office</a:t>
+              <a:t>Pip’s investigation</a:t>
             </a:r>
             <a:endParaRPr b="1" sz="2000">
               <a:solidFill>
@@ -10643,7 +10678,7 @@
                 <a:cs typeface="Google Sans Flex"/>
                 <a:sym typeface="Google Sans Flex"/>
               </a:rPr>
-              <a:t>Review the recovered slip. Save an inspection snapshot and export HTML or CSV.</a:t>
+              <a:t>Autonomous tool calls, archive search and cited findings. Human-approved handover with an AI draft.</a:t>
             </a:r>
             <a:endParaRPr sz="1600">
               <a:solidFill>
@@ -10976,7 +11011,7 @@
                 <a:cs typeface="Google Sans Flex"/>
                 <a:sym typeface="Google Sans Flex"/>
               </a:rPr>
-              <a:t>01  MIRA</a:t>
+              <a:t>01  INVESTIGATE</a:t>
             </a:r>
             <a:endParaRPr b="1" sz="2200">
               <a:solidFill>
@@ -11011,7 +11046,7 @@
                 <a:cs typeface="Google Sans Flex"/>
                 <a:sym typeface="Google Sans Flex"/>
               </a:rPr>
-              <a:t>Read the evidence</a:t>
+              <a:t>Pip chooses tools</a:t>
             </a:r>
             <a:endParaRPr b="1" sz="2200">
               <a:solidFill>
@@ -11072,7 +11107,7 @@
                 <a:cs typeface="Google Sans Flex"/>
                 <a:sym typeface="Google Sans Flex"/>
               </a:rPr>
-              <a:t>Complaint and product label</a:t>
+              <a:t>Index and read the evidence</a:t>
             </a:r>
             <a:endParaRPr sz="1600">
               <a:solidFill>
@@ -11107,7 +11142,7 @@
                 <a:cs typeface="Google Sans Flex"/>
                 <a:sym typeface="Google Sans Flex"/>
               </a:rPr>
-              <a:t>Supplier inspection report</a:t>
+              <a:t>Search the supplied archive</a:t>
             </a:r>
             <a:endParaRPr sz="1600">
               <a:solidFill>
@@ -11142,7 +11177,7 @@
                 <a:cs typeface="Google Sans Flex"/>
                 <a:sym typeface="Google Sans Flex"/>
               </a:rPr>
-              <a:t>Production and shipment ledgers</a:t>
+              <a:t>Trace component exposure</a:t>
             </a:r>
             <a:endParaRPr sz="1600">
               <a:solidFill>
@@ -11203,7 +11238,7 @@
                 <a:cs typeface="Google Sans Flex"/>
                 <a:sym typeface="Google Sans Flex"/>
               </a:rPr>
-              <a:t>02  SOL</a:t>
+              <a:t>02  REVIEW</a:t>
             </a:r>
             <a:endParaRPr b="1" sz="2200">
               <a:solidFill>
@@ -11238,7 +11273,7 @@
                 <a:cs typeface="Google Sans Flex"/>
                 <a:sym typeface="Google Sans Flex"/>
               </a:rPr>
-              <a:t>Follow the lot</a:t>
+              <a:t>Inspect findings</a:t>
             </a:r>
             <a:endParaRPr b="1" sz="2200">
               <a:solidFill>
@@ -11299,7 +11334,7 @@
                 <a:cs typeface="Google Sans Flex"/>
                 <a:sym typeface="Google Sans Flex"/>
               </a:rPr>
-              <a:t>Gemini proposes identifiers</a:t>
+              <a:t>Journal shows tool results</a:t>
             </a:r>
             <a:endParaRPr sz="1600">
               <a:solidFill>
@@ -11334,7 +11369,7 @@
                 <a:cs typeface="Google Sans Flex"/>
                 <a:sym typeface="Google Sans Flex"/>
               </a:rPr>
-              <a:t>Reviewer confirms baseline</a:t>
+              <a:t>Open original source citations</a:t>
             </a:r>
             <a:endParaRPr sz="1600">
               <a:solidFill>
@@ -11369,7 +11404,7 @@
                 <a:cs typeface="Google Sans Flex"/>
                 <a:sym typeface="Google Sans Flex"/>
               </a:rPr>
-              <a:t>Engine exposes the missing link</a:t>
+              <a:t>Approve or correct candidates</a:t>
             </a:r>
             <a:endParaRPr sz="1600">
               <a:solidFill>
@@ -11430,7 +11465,7 @@
                 <a:cs typeface="Google Sans Flex"/>
                 <a:sym typeface="Google Sans Flex"/>
               </a:rPr>
-              <a:t>03  PIP</a:t>
+              <a:t>03  HAND OVER</a:t>
             </a:r>
             <a:endParaRPr b="1" sz="2200">
               <a:solidFill>
@@ -11465,7 +11500,7 @@
                 <a:cs typeface="Google Sans Flex"/>
                 <a:sym typeface="Google Sans Flex"/>
               </a:rPr>
-              <a:t>Close the gap</a:t>
+              <a:t>Save the decision</a:t>
             </a:r>
             <a:endParaRPr b="1" sz="2200">
               <a:solidFill>
@@ -11526,7 +11561,7 @@
                 <a:cs typeface="Google Sans Flex"/>
                 <a:sym typeface="Google Sans Flex"/>
               </a:rPr>
-              <a:t>Recover the supplied S4 slip</a:t>
+              <a:t>Confirm baseline and S4 link</a:t>
             </a:r>
             <a:endParaRPr sz="1600">
               <a:solidFill>
@@ -11561,7 +11596,7 @@
                 <a:cs typeface="Google Sans Flex"/>
                 <a:sym typeface="Google Sans Flex"/>
               </a:rPr>
-              <a:t>Confirm B104 from its source</a:t>
+              <a:t>Compute deterministic scope</a:t>
             </a:r>
             <a:endParaRPr sz="1600">
               <a:solidFill>
@@ -11596,7 +11631,7 @@
                 <a:cs typeface="Google Sans Flex"/>
                 <a:sym typeface="Google Sans Flex"/>
               </a:rPr>
-              <a:t>Save proposal and export report</a:t>
+              <a:t>Save and export reviewed report</a:t>
             </a:r>
             <a:endParaRPr sz="1600">
               <a:solidFill>
@@ -11657,7 +11692,7 @@
                 <a:cs typeface="Google Sans Flex"/>
                 <a:sym typeface="Google Sans Flex"/>
               </a:rPr>
-              <a:t>1,000 connected + 500 unresolved becomes 1,500 connected.</a:t>
+              <a:t>Gemini proposes checks and explains evidence. Humans approve facts.</a:t>
             </a:r>
             <a:endParaRPr b="1" sz="1600">
               <a:solidFill>
@@ -11692,7 +11727,7 @@
                 <a:cs typeface="Google Sans Flex"/>
                 <a:sym typeface="Google Sans Flex"/>
               </a:rPr>
-              <a:t>The conservative inspection scope stays at 1,500.</a:t>
+              <a:t>No autonomous shipment release, recall or physical inspection.</a:t>
             </a:r>
             <a:endParaRPr b="1" sz="1600">
               <a:solidFill>
@@ -12270,7 +12305,7 @@
                 <a:cs typeface="Google Sans Flex"/>
                 <a:sym typeface="Google Sans Flex"/>
               </a:rPr>
-              <a:t>The factory you explore</a:t>
+              <a:t>Playable factory + investigation journal</a:t>
             </a:r>
             <a:endParaRPr b="1" sz="2500">
               <a:solidFill>
@@ -12331,7 +12366,7 @@
                 <a:cs typeface="Google Sans Flex"/>
                 <a:sym typeface="Google Sans Flex"/>
               </a:rPr>
-              <a:t>The review system behind it</a:t>
+              <a:t>Bounded Gemini tool loop</a:t>
             </a:r>
             <a:endParaRPr b="1" sz="2300">
               <a:solidFill>
@@ -12427,7 +12462,7 @@
                 <a:cs typeface="Google Sans Flex"/>
                 <a:sym typeface="Google Sans Flex"/>
               </a:rPr>
-              <a:t>Reads source images</a:t>
+              <a:t>Chooses tool + arguments</a:t>
             </a:r>
             <a:endParaRPr sz="1700">
               <a:solidFill>
@@ -12462,7 +12497,7 @@
                 <a:cs typeface="Google Sans Flex"/>
                 <a:sym typeface="Google Sans Flex"/>
               </a:rPr>
-              <a:t>Returns candidate + quote</a:t>
+              <a:t>Reads images; drafts findings</a:t>
             </a:r>
             <a:endParaRPr sz="1700">
               <a:solidFill>
@@ -12523,7 +12558,7 @@
                 <a:cs typeface="Google Sans Flex"/>
                 <a:sym typeface="Google Sans Flex"/>
               </a:rPr>
-              <a:t>FASTAPI / CLOUD RUN</a:t>
+              <a:t>VALIDATED SERVER TOOLS</a:t>
             </a:r>
             <a:endParaRPr sz="1700">
               <a:solidFill>
@@ -12558,7 +12593,7 @@
                 <a:cs typeface="Google Sans Flex"/>
                 <a:sym typeface="Google Sans Flex"/>
               </a:rPr>
-              <a:t>Human confirmation</a:t>
+              <a:t>Read / search / trace</a:t>
             </a:r>
             <a:endParaRPr sz="1700">
               <a:solidFill>
@@ -12593,7 +12628,7 @@
                 <a:cs typeface="Google Sans Flex"/>
                 <a:sym typeface="Google Sans Flex"/>
               </a:rPr>
-              <a:t>Deterministic trace engine</a:t>
+              <a:t>Separate human approvals</a:t>
             </a:r>
             <a:endParaRPr sz="1700">
               <a:solidFill>
@@ -12689,7 +12724,7 @@
                 <a:cs typeface="Google Sans Flex"/>
                 <a:sym typeface="Google Sans Flex"/>
               </a:rPr>
-              <a:t>Case and review history</a:t>
+              <a:t>Tool journal + candidates</a:t>
             </a:r>
             <a:endParaRPr sz="1700">
               <a:solidFill>
@@ -12724,7 +12759,7 @@
                 <a:cs typeface="Google Sans Flex"/>
                 <a:sym typeface="Google Sans Flex"/>
               </a:rPr>
-              <a:t>Inspection snapshots</a:t>
+              <a:t>Reviewed snapshots</a:t>
             </a:r>
             <a:endParaRPr sz="1700">
               <a:solidFill>
@@ -13199,7 +13234,7 @@
                 <a:cs typeface="Google Sans Flex"/>
                 <a:sym typeface="Google Sans Flex"/>
               </a:rPr>
-              <a:t>Reads images into validated identifiers and source quotations.</a:t>
+              <a:t>Function calling, image reading and source-cited findings.</a:t>
             </a:r>
             <a:endParaRPr sz="2000">
               <a:solidFill>
@@ -13295,7 +13330,7 @@
                 <a:cs typeface="Google Sans Flex"/>
                 <a:sym typeface="Google Sans Flex"/>
               </a:rPr>
-              <a:t>Hosts the application and persists browser-owned cases.</a:t>
+              <a:t>Bounded tool execution, persistent journal and case ownership.</a:t>
             </a:r>
             <a:endParaRPr sz="2000">
               <a:solidFill>
@@ -13391,7 +13426,7 @@
                 <a:cs typeface="Google Sans Flex"/>
                 <a:sym typeface="Google Sans Flex"/>
               </a:rPr>
-              <a:t>Animated factory rooms, review controls and deterministic tracing.</a:t>
+              <a:t>Walkable factory, operator review and deterministic tracing.</a:t>
             </a:r>
             <a:endParaRPr sz="2000">
               <a:solidFill>
@@ -13736,7 +13771,7 @@
                 <a:cs typeface="Google Sans Flex"/>
                 <a:sym typeface="Google Sans Flex"/>
               </a:rPr>
-              <a:t>100 model attempts per day across cases</a:t>
+              <a:t>100 model attempts/day shared across all cases</a:t>
             </a:r>
             <a:endParaRPr sz="2000">
               <a:solidFill>
@@ -13771,7 +13806,7 @@
                 <a:cs typeface="Google Sans Flex"/>
                 <a:sym typeface="Google Sans Flex"/>
               </a:rPr>
-              <a:t>8 extraction attempts per case</a:t>
+              <a:t>Per case: 12 agent calls + 8 image-scan attempts</a:t>
             </a:r>
             <a:endParaRPr sz="2000">
               <a:solidFill>
@@ -13806,7 +13841,7 @@
                 <a:cs typeface="Google Sans Flex"/>
                 <a:sym typeface="Google Sans Flex"/>
               </a:rPr>
-              <a:t>24-hour case access, with Firestore TTL cleanup</a:t>
+              <a:t>Per run: 6 model turns / 14 tools / 95 seconds</a:t>
             </a:r>
             <a:endParaRPr sz="2000">
               <a:solidFill>

</xml_diff>

<commit_message>
Update pitch deck export for adaptive Gemini factory demo
</commit_message>
<xml_diff>
--- a/docs/submission/BatchLens-Pitch-Review.pptx
+++ b/docs/submission/BatchLens-Pitch-Review.pptx
@@ -7272,7 +7272,7 @@
                 <a:cs typeface="Google Sans Flex"/>
                 <a:sym typeface="Google Sans Flex"/>
               </a:rPr>
-              <a:t>Real Gemini tool calls and cited findings. Operator approval controls the final scope.</a:t>
+              <a:t>Cause comparisons, inspection missions and operational chat with real Gemini.</a:t>
             </a:r>
             <a:endParaRPr sz="1600">
               <a:solidFill>
@@ -7302,8 +7302,8 @@
         </p:blipFill>
         <p:spPr>
           <a:xfrm>
-            <a:off x="700799" y="1781558"/>
-            <a:ext cx="2675100" cy="2139183"/>
+            <a:off x="921669" y="1781558"/>
+            <a:ext cx="2233361" cy="2139183"/>
           </a:xfrm>
           <a:prstGeom prst="rect">
             <a:avLst/>
@@ -7361,7 +7361,7 @@
                 <a:cs typeface="Google Sans Flex"/>
                 <a:sym typeface="Google Sans Flex"/>
               </a:rPr>
-              <a:t>Pip investigates.</a:t>
+              <a:t>Pip proposes.</a:t>
             </a:r>
             <a:endParaRPr b="1" sz="3000">
               <a:solidFill>
@@ -7396,7 +7396,7 @@
                 <a:cs typeface="Google Sans Flex"/>
                 <a:sym typeface="Google Sans Flex"/>
               </a:rPr>
-              <a:t>You review.</a:t>
+              <a:t>Operators inspect.</a:t>
             </a:r>
             <a:endParaRPr b="1" sz="3000">
               <a:solidFill>
@@ -7457,7 +7457,7 @@
                 <a:cs typeface="Google Sans Flex"/>
                 <a:sym typeface="Google Sans Flex"/>
               </a:rPr>
-              <a:t>Source-cited findings.</a:t>
+              <a:t>Gemini reassesses.</a:t>
             </a:r>
             <a:endParaRPr b="1" sz="3000">
               <a:solidFill>
@@ -7492,7 +7492,7 @@
                 <a:cs typeface="Google Sans Flex"/>
                 <a:sym typeface="Google Sans Flex"/>
               </a:rPr>
-              <a:t>A clear handover.</a:t>
+              <a:t>Humans decide.</a:t>
             </a:r>
             <a:endParaRPr b="1" sz="3000">
               <a:solidFill>
@@ -7898,7 +7898,7 @@
                 <a:cs typeface="Google Sans Flex"/>
                 <a:sym typeface="Google Sans Flex"/>
               </a:rPr>
-              <a:t>REAL GEMINI TOOL CALLING</a:t>
+              <a:t>ADAPTIVE QUALITY INVESTIGATION</a:t>
             </a:r>
             <a:endParaRPr sz="1900">
               <a:solidFill>
@@ -7933,7 +7933,7 @@
                 <a:cs typeface="Google Sans Flex"/>
                 <a:sym typeface="Google Sans Flex"/>
               </a:rPr>
-              <a:t>12 tool actions / 4 cited findings</a:t>
+              <a:t>Cause comparison and missions</a:t>
             </a:r>
             <a:endParaRPr sz="1900">
               <a:solidFill>
@@ -7994,7 +7994,7 @@
                 <a:cs typeface="Google Sans Flex"/>
                 <a:sym typeface="Google Sans Flex"/>
               </a:rPr>
-              <a:t>14 backend tests passed</a:t>
+              <a:t>22 backend tests passed</a:t>
             </a:r>
             <a:endParaRPr sz="1900">
               <a:solidFill>
@@ -8090,7 +8090,7 @@
                 <a:cs typeface="Google Sans Flex"/>
                 <a:sym typeface="Google Sans Flex"/>
               </a:rPr>
-              <a:t>Observed in one synthetic investigation. Gemini chose the tools and archive query.</a:t>
+              <a:t>Synthetic case and operator-entered demo results. No production accuracy claim.</a:t>
             </a:r>
             <a:endParaRPr>
               <a:solidFill>
@@ -8125,7 +8125,7 @@
                 <a:cs typeface="Google Sans Flex"/>
                 <a:sym typeface="Google Sans Flex"/>
               </a:rPr>
-              <a:t>Draft findings did not approve the baseline, S4 mapping or inspection proposal.</a:t>
+              <a:t>Gemini recommendations cannot approve scope, release stock or operate equipment.</a:t>
             </a:r>
             <a:endParaRPr>
               <a:solidFill>
@@ -8496,7 +8496,7 @@
                 <a:cs typeface="Google Sans Flex"/>
                 <a:sym typeface="Google Sans Flex"/>
               </a:rPr>
-              <a:t>Measure evidence coverage, review time and mapping errors.</a:t>
+              <a:t>Measure evidence coverage, review time and decision errors.</a:t>
             </a:r>
             <a:endParaRPr sz="1900">
               <a:solidFill>
@@ -8557,7 +8557,7 @@
                 <a:cs typeface="Google Sans Flex"/>
                 <a:sym typeface="Google Sans Flex"/>
               </a:rPr>
-              <a:t>Next: controlled uploads, external ERP tools and multi-case evaluation.</a:t>
+              <a:t>Next: approved real procedures, controlled uploads and ERP integration.</a:t>
             </a:r>
             <a:endParaRPr sz="1900">
               <a:solidFill>
@@ -8998,7 +8998,7 @@
                 <a:cs typeface="Google Sans Flex"/>
                 <a:sym typeface="Google Sans Flex"/>
               </a:rPr>
-              <a:t>Inspect the evidence.</a:t>
+              <a:t>Complete a mission.</a:t>
             </a:r>
             <a:endParaRPr b="1" sz="3400">
               <a:solidFill>
@@ -9033,7 +9033,7 @@
                 <a:cs typeface="Google Sans Flex"/>
                 <a:sym typeface="Google Sans Flex"/>
               </a:rPr>
-              <a:t>Review the handover.</a:t>
+              <a:t>Challenge Pip.</a:t>
             </a:r>
             <a:endParaRPr b="1" sz="3400">
               <a:solidFill>
@@ -9370,7 +9370,7 @@
                 <a:cs typeface="Google Sans Flex"/>
                 <a:sym typeface="Google Sans Flex"/>
               </a:rPr>
-              <a:t>Four shipments.</a:t>
+              <a:t>Possible causes.</a:t>
             </a:r>
             <a:endParaRPr b="1" sz="3100">
               <a:solidFill>
@@ -9405,7 +9405,7 @@
                 <a:cs typeface="Google Sans Flex"/>
                 <a:sym typeface="Google Sans Flex"/>
               </a:rPr>
-              <a:t>One missing link.</a:t>
+              <a:t>One next check.</a:t>
             </a:r>
             <a:endParaRPr b="1" sz="3100">
               <a:solidFill>
@@ -9466,7 +9466,7 @@
                 <a:cs typeface="Google Sans Flex"/>
                 <a:sym typeface="Google Sans Flex"/>
               </a:rPr>
-              <a:t>Gemini investigates.</a:t>
+              <a:t>Pip investigates.</a:t>
             </a:r>
             <a:endParaRPr sz="2000">
               <a:solidFill>
@@ -9501,7 +9501,7 @@
                 <a:cs typeface="Google Sans Flex"/>
                 <a:sym typeface="Google Sans Flex"/>
               </a:rPr>
-              <a:t>You review the evidence</a:t>
+              <a:t>Operators test and review.</a:t>
             </a:r>
             <a:endParaRPr sz="2000">
               <a:solidFill>
@@ -9536,7 +9536,7 @@
                 <a:cs typeface="Google Sans Flex"/>
                 <a:sym typeface="Google Sans Flex"/>
               </a:rPr>
-              <a:t>and approve decisions.</a:t>
+              <a:t>Gemini reassesses.</a:t>
             </a:r>
             <a:endParaRPr sz="2000">
               <a:solidFill>
@@ -9868,7 +9868,7 @@
                 <a:cs typeface="Google Sans Flex Medium"/>
                 <a:sym typeface="Google Sans Flex Medium"/>
               </a:rPr>
-              <a:t>DIFFERENCE: Gemini selects investigative tools, not just OCR.</a:t>
+              <a:t>DIFFERENCE: Gemini revises hypotheses after operator results.</a:t>
             </a:r>
             <a:endParaRPr sz="1600">
               <a:solidFill>
@@ -9900,7 +9900,7 @@
                 <a:cs typeface="Google Sans Flex Medium"/>
                 <a:sym typeface="Google Sans Flex Medium"/>
               </a:rPr>
-              <a:t>SOLUTION: Read sources, trace exposure and seek missing records.</a:t>
+              <a:t>SOLUTION: Evidence, inspection missions and reviewed actions.</a:t>
             </a:r>
             <a:endParaRPr sz="1600">
               <a:solidFill>
@@ -9993,7 +9993,7 @@
                 <a:cs typeface="Google Sans Flex"/>
                 <a:sym typeface="Google Sans Flex"/>
               </a:rPr>
-              <a:t>Pip investigates.</a:t>
+              <a:t>An investigation</a:t>
             </a:r>
             <a:endParaRPr b="1" sz="3900">
               <a:solidFill>
@@ -10028,7 +10028,7 @@
                 <a:cs typeface="Google Sans Flex"/>
                 <a:sym typeface="Google Sans Flex"/>
               </a:rPr>
-              <a:t>You make the call.</a:t>
+              <a:t>that learns from results.</a:t>
             </a:r>
             <a:endParaRPr b="1" sz="3900">
               <a:solidFill>
@@ -10089,7 +10089,7 @@
                 <a:cs typeface="Google Sans Flex"/>
                 <a:sym typeface="Google Sans Flex"/>
               </a:rPr>
-              <a:t>Tool actions, source-cited findings and visible uncertainty.</a:t>
+              <a:t>Pip proposes missions and revises evidence-backed hypotheses.</a:t>
             </a:r>
             <a:endParaRPr sz="2000">
               <a:solidFill>
@@ -10124,7 +10124,7 @@
                 <a:cs typeface="Google Sans Flex"/>
                 <a:sym typeface="Google Sans Flex"/>
               </a:rPr>
-              <a:t>Confirmed records control the inspection scope.</a:t>
+              <a:t>Operators approve checks, facts and the final handover.</a:t>
             </a:r>
             <a:endParaRPr sz="2000">
               <a:solidFill>
@@ -10434,7 +10434,7 @@
                 <a:cs typeface="Google Sans Flex"/>
                 <a:sym typeface="Google Sans Flex"/>
               </a:rPr>
-              <a:t>Gemini reads source images. Review quotations and pending identifiers before confirming the baseline.</a:t>
+              <a:t>Read evidence. Compare causes. Approve a demo inspection mission and record its result.</a:t>
             </a:r>
             <a:endParaRPr sz="1600">
               <a:solidFill>
@@ -10556,7 +10556,7 @@
                 <a:cs typeface="Google Sans Flex"/>
                 <a:sym typeface="Google Sans Flex"/>
               </a:rPr>
-              <a:t>Pip calls the trace tool. Deterministic scope keeps unknown shipment mappings unresolved.</a:t>
+              <a:t>Review assembly records. Compare inspection scopes with explicit workload assumptions.</a:t>
             </a:r>
             <a:endParaRPr sz="1600">
               <a:solidFill>
@@ -10678,7 +10678,7 @@
                 <a:cs typeface="Google Sans Flex"/>
                 <a:sym typeface="Google Sans Flex"/>
               </a:rPr>
-              <a:t>Autonomous tool calls, archive search and cited findings. Human-approved handover with an AI draft.</a:t>
+              <a:t>Reassess results with Gemini. Ask operational questions. Review corrective-action drafts.</a:t>
             </a:r>
             <a:endParaRPr sz="1600">
               <a:solidFill>
@@ -11046,7 +11046,7 @@
                 <a:cs typeface="Google Sans Flex"/>
                 <a:sym typeface="Google Sans Flex"/>
               </a:rPr>
-              <a:t>Pip chooses tools</a:t>
+              <a:t>Compare causes</a:t>
             </a:r>
             <a:endParaRPr b="1" sz="2200">
               <a:solidFill>
@@ -11107,7 +11107,7 @@
                 <a:cs typeface="Google Sans Flex"/>
                 <a:sym typeface="Google Sans Flex"/>
               </a:rPr>
-              <a:t>Index and read the evidence</a:t>
+              <a:t>Read evidence and procedures</a:t>
             </a:r>
             <a:endParaRPr sz="1600">
               <a:solidFill>
@@ -11142,7 +11142,7 @@
                 <a:cs typeface="Google Sans Flex"/>
                 <a:sym typeface="Google Sans Flex"/>
               </a:rPr>
-              <a:t>Search the supplied archive</a:t>
+              <a:t>Find gaps and contradictions</a:t>
             </a:r>
             <a:endParaRPr sz="1600">
               <a:solidFill>
@@ -11177,7 +11177,7 @@
                 <a:cs typeface="Google Sans Flex"/>
                 <a:sym typeface="Google Sans Flex"/>
               </a:rPr>
-              <a:t>Trace component exposure</a:t>
+              <a:t>Propose inspection missions</a:t>
             </a:r>
             <a:endParaRPr sz="1600">
               <a:solidFill>
@@ -11238,7 +11238,7 @@
                 <a:cs typeface="Google Sans Flex"/>
                 <a:sym typeface="Google Sans Flex"/>
               </a:rPr>
-              <a:t>02  REVIEW</a:t>
+              <a:t>02  INSPECT</a:t>
             </a:r>
             <a:endParaRPr b="1" sz="2200">
               <a:solidFill>
@@ -11273,7 +11273,7 @@
                 <a:cs typeface="Google Sans Flex"/>
                 <a:sym typeface="Google Sans Flex"/>
               </a:rPr>
-              <a:t>Inspect findings</a:t>
+              <a:t>Operator checkpoint</a:t>
             </a:r>
             <a:endParaRPr b="1" sz="2200">
               <a:solidFill>
@@ -11334,7 +11334,7 @@
                 <a:cs typeface="Google Sans Flex"/>
                 <a:sym typeface="Google Sans Flex"/>
               </a:rPr>
-              <a:t>Journal shows tool results</a:t>
+              <a:t>Approve a demo mission</a:t>
             </a:r>
             <a:endParaRPr sz="1600">
               <a:solidFill>
@@ -11369,7 +11369,7 @@
                 <a:cs typeface="Google Sans Flex"/>
                 <a:sym typeface="Google Sans Flex"/>
               </a:rPr>
-              <a:t>Open original source citations</a:t>
+              <a:t>Record a synthetic result</a:t>
             </a:r>
             <a:endParaRPr sz="1600">
               <a:solidFill>
@@ -11404,7 +11404,7 @@
                 <a:cs typeface="Google Sans Flex"/>
                 <a:sym typeface="Google Sans Flex"/>
               </a:rPr>
-              <a:t>Approve or correct candidates</a:t>
+              <a:t>Gemini revises its findings</a:t>
             </a:r>
             <a:endParaRPr sz="1600">
               <a:solidFill>
@@ -11500,7 +11500,7 @@
                 <a:cs typeface="Google Sans Flex"/>
                 <a:sym typeface="Google Sans Flex"/>
               </a:rPr>
-              <a:t>Save the decision</a:t>
+              <a:t>Review next steps</a:t>
             </a:r>
             <a:endParaRPr b="1" sz="2200">
               <a:solidFill>
@@ -11561,7 +11561,7 @@
                 <a:cs typeface="Google Sans Flex"/>
                 <a:sym typeface="Google Sans Flex"/>
               </a:rPr>
-              <a:t>Confirm baseline and S4 link</a:t>
+              <a:t>Compare inspection scopes</a:t>
             </a:r>
             <a:endParaRPr sz="1600">
               <a:solidFill>
@@ -11596,7 +11596,7 @@
                 <a:cs typeface="Google Sans Flex"/>
                 <a:sym typeface="Google Sans Flex"/>
               </a:rPr>
-              <a:t>Compute deterministic scope</a:t>
+              <a:t>Approve action drafts</a:t>
             </a:r>
             <a:endParaRPr sz="1600">
               <a:solidFill>
@@ -11631,7 +11631,7 @@
                 <a:cs typeface="Google Sans Flex"/>
                 <a:sym typeface="Google Sans Flex"/>
               </a:rPr>
-              <a:t>Save and export reviewed report</a:t>
+              <a:t>Export a reviewed snapshot</a:t>
             </a:r>
             <a:endParaRPr sz="1600">
               <a:solidFill>
@@ -11692,7 +11692,7 @@
                 <a:cs typeface="Google Sans Flex"/>
                 <a:sym typeface="Google Sans Flex"/>
               </a:rPr>
-              <a:t>Gemini proposes checks and explains evidence. Humans approve facts.</a:t>
+              <a:t>Operational chat clarifies the case using cited evidence.</a:t>
             </a:r>
             <a:endParaRPr b="1" sz="1600">
               <a:solidFill>
@@ -11727,7 +11727,7 @@
                 <a:cs typeface="Google Sans Flex"/>
                 <a:sym typeface="Google Sans Flex"/>
               </a:rPr>
-              <a:t>No autonomous shipment release, recall or physical inspection.</a:t>
+              <a:t>Humans approve decisions. Demo results are explicitly synthetic.</a:t>
             </a:r>
             <a:endParaRPr b="1" sz="1600">
               <a:solidFill>
@@ -12305,7 +12305,7 @@
                 <a:cs typeface="Google Sans Flex"/>
                 <a:sym typeface="Google Sans Flex"/>
               </a:rPr>
-              <a:t>Playable factory + investigation journal</a:t>
+              <a:t>Playable factory + adaptive mission journal</a:t>
             </a:r>
             <a:endParaRPr b="1" sz="2500">
               <a:solidFill>
@@ -12462,7 +12462,7 @@
                 <a:cs typeface="Google Sans Flex"/>
                 <a:sym typeface="Google Sans Flex"/>
               </a:rPr>
-              <a:t>Chooses tool + arguments</a:t>
+              <a:t>Compare causes</a:t>
             </a:r>
             <a:endParaRPr sz="1700">
               <a:solidFill>
@@ -12497,7 +12497,7 @@
                 <a:cs typeface="Google Sans Flex"/>
                 <a:sym typeface="Google Sans Flex"/>
               </a:rPr>
-              <a:t>Reads images; drafts findings</a:t>
+              <a:t>Reassess operator results</a:t>
             </a:r>
             <a:endParaRPr sz="1700">
               <a:solidFill>
@@ -12558,7 +12558,7 @@
                 <a:cs typeface="Google Sans Flex"/>
                 <a:sym typeface="Google Sans Flex"/>
               </a:rPr>
-              <a:t>VALIDATED SERVER TOOLS</a:t>
+              <a:t>VALIDATED TOOLS</a:t>
             </a:r>
             <a:endParaRPr sz="1700">
               <a:solidFill>
@@ -12593,7 +12593,7 @@
                 <a:cs typeface="Google Sans Flex"/>
                 <a:sym typeface="Google Sans Flex"/>
               </a:rPr>
-              <a:t>Read / search / trace</a:t>
+              <a:t>Procedures, missions, scope</a:t>
             </a:r>
             <a:endParaRPr sz="1700">
               <a:solidFill>
@@ -12628,7 +12628,7 @@
                 <a:cs typeface="Google Sans Flex"/>
                 <a:sym typeface="Google Sans Flex"/>
               </a:rPr>
-              <a:t>Separate human approvals</a:t>
+              <a:t>Human approval gates</a:t>
             </a:r>
             <a:endParaRPr sz="1700">
               <a:solidFill>
@@ -12724,7 +12724,7 @@
                 <a:cs typeface="Google Sans Flex"/>
                 <a:sym typeface="Google Sans Flex"/>
               </a:rPr>
-              <a:t>Tool journal + candidates</a:t>
+              <a:t>Evidence + result records</a:t>
             </a:r>
             <a:endParaRPr sz="1700">
               <a:solidFill>
@@ -12759,7 +12759,7 @@
                 <a:cs typeface="Google Sans Flex"/>
                 <a:sym typeface="Google Sans Flex"/>
               </a:rPr>
-              <a:t>Reviewed snapshots</a:t>
+              <a:t>Frozen handovers</a:t>
             </a:r>
             <a:endParaRPr sz="1700">
               <a:solidFill>
@@ -12820,7 +12820,7 @@
                 <a:cs typeface="Google Sans Flex"/>
                 <a:sym typeface="Google Sans Flex"/>
               </a:rPr>
-              <a:t>React + Three.js in the browser. Cloud credentials stay on the server.</a:t>
+              <a:t>Operations-only Gemini chat uses a separate scope gate and has no mutation tools.</a:t>
             </a:r>
             <a:endParaRPr sz="1500">
               <a:solidFill>
@@ -13234,7 +13234,7 @@
                 <a:cs typeface="Google Sans Flex"/>
                 <a:sym typeface="Google Sans Flex"/>
               </a:rPr>
-              <a:t>Function calling, image reading and source-cited findings.</a:t>
+              <a:t>Tool calling, cause comparison and grounded operational chat.</a:t>
             </a:r>
             <a:endParaRPr sz="2000">
               <a:solidFill>
@@ -13330,7 +13330,7 @@
                 <a:cs typeface="Google Sans Flex"/>
                 <a:sym typeface="Google Sans Flex"/>
               </a:rPr>
-              <a:t>Bounded tool execution, persistent journal and case ownership.</a:t>
+              <a:t>Bounded execution, mission results and persistent case journals.</a:t>
             </a:r>
             <a:endParaRPr sz="2000">
               <a:solidFill>
@@ -13426,7 +13426,7 @@
                 <a:cs typeface="Google Sans Flex"/>
                 <a:sym typeface="Google Sans Flex"/>
               </a:rPr>
-              <a:t>Walkable factory, operator review and deterministic tracing.</a:t>
+              <a:t>Playable factory, human approvals and deterministic scope.</a:t>
             </a:r>
             <a:endParaRPr sz="2000">
               <a:solidFill>
@@ -13771,7 +13771,7 @@
                 <a:cs typeface="Google Sans Flex"/>
                 <a:sym typeface="Google Sans Flex"/>
               </a:rPr>
-              <a:t>100 model attempts/day shared across all cases</a:t>
+              <a:t>100 model attempts/day across cases</a:t>
             </a:r>
             <a:endParaRPr sz="2000">
               <a:solidFill>
@@ -13806,7 +13806,7 @@
                 <a:cs typeface="Google Sans Flex"/>
                 <a:sym typeface="Google Sans Flex"/>
               </a:rPr>
-              <a:t>Per case: 12 agent calls + 8 image-scan attempts</a:t>
+              <a:t>Per case: 12 investigator + 8 scans + 12 chat calls</a:t>
             </a:r>
             <a:endParaRPr sz="2000">
               <a:solidFill>
@@ -13841,7 +13841,7 @@
                 <a:cs typeface="Google Sans Flex"/>
                 <a:sym typeface="Google Sans Flex"/>
               </a:rPr>
-              <a:t>Per run: 6 model turns / 14 tools / 95 seconds</a:t>
+              <a:t>Per run: 6 turns / 24 tools / 95 seconds</a:t>
             </a:r>
             <a:endParaRPr sz="2000">
               <a:solidFill>

</xml_diff>

<commit_message>
Refresh pitch exports with measured AI usage and cloud cost estimates
</commit_message>
<xml_diff>
--- a/docs/submission/BatchLens-Pitch-Review.pptx
+++ b/docs/submission/BatchLens-Pitch-Review.pptx
@@ -2,39 +2,39 @@
 <file path=ppt/presentation.xml><?xml version="1.0" encoding="utf-8"?>
 <p:presentation xmlns:a="http://schemas.openxmlformats.org/drawingml/2006/main" xmlns:r="http://schemas.openxmlformats.org/officeDocument/2006/relationships" xmlns:mc="http://schemas.openxmlformats.org/markup-compatibility/2006" xmlns:mv="urn:schemas-microsoft-com:mac:vml" xmlns:p="http://schemas.openxmlformats.org/presentationml/2006/main" xmlns:c="http://schemas.openxmlformats.org/drawingml/2006/chart" xmlns:dgm="http://schemas.openxmlformats.org/drawingml/2006/diagram" xmlns:o="urn:schemas-microsoft-com:office:office" xmlns:v="urn:schemas-microsoft-com:vml" xmlns:pvml="urn:schemas-microsoft-com:office:powerpoint" xmlns:com="http://schemas.openxmlformats.org/drawingml/2006/compatibility" xmlns:p14="http://schemas.microsoft.com/office/powerpoint/2010/main" xmlns:p15="http://schemas.microsoft.com/office/powerpoint/2012/main" xmlns:ahyp="http://schemas.microsoft.com/office/drawing/2018/hyperlinkcolor" autoCompressPictures="0" embedTrueTypeFonts="1" strictFirstAndLastChars="0" saveSubsetFonts="1">
   <p:sldMasterIdLst>
-    <p:sldMasterId id="2147483659" r:id="rId4"/>
+    <p:sldMasterId id="2147483659" r:id="rId5"/>
   </p:sldMasterIdLst>
   <p:notesMasterIdLst>
-    <p:notesMasterId r:id="rId5"/>
+    <p:notesMasterId r:id="rId6"/>
   </p:notesMasterIdLst>
   <p:sldIdLst>
-    <p:sldId id="256" r:id="rId6"/>
-    <p:sldId id="257" r:id="rId7"/>
-    <p:sldId id="258" r:id="rId8"/>
-    <p:sldId id="259" r:id="rId9"/>
-    <p:sldId id="260" r:id="rId10"/>
-    <p:sldId id="261" r:id="rId11"/>
-    <p:sldId id="262" r:id="rId12"/>
-    <p:sldId id="263" r:id="rId13"/>
-    <p:sldId id="264" r:id="rId14"/>
-    <p:sldId id="265" r:id="rId15"/>
-    <p:sldId id="266" r:id="rId16"/>
-    <p:sldId id="267" r:id="rId17"/>
-    <p:sldId id="268" r:id="rId18"/>
-    <p:sldId id="269" r:id="rId19"/>
+    <p:sldId id="256" r:id="rId7"/>
+    <p:sldId id="257" r:id="rId8"/>
+    <p:sldId id="258" r:id="rId9"/>
+    <p:sldId id="259" r:id="rId10"/>
+    <p:sldId id="260" r:id="rId11"/>
+    <p:sldId id="261" r:id="rId12"/>
+    <p:sldId id="262" r:id="rId13"/>
+    <p:sldId id="263" r:id="rId14"/>
+    <p:sldId id="264" r:id="rId15"/>
+    <p:sldId id="265" r:id="rId16"/>
+    <p:sldId id="266" r:id="rId17"/>
+    <p:sldId id="267" r:id="rId18"/>
+    <p:sldId id="268" r:id="rId19"/>
+    <p:sldId id="269" r:id="rId20"/>
   </p:sldIdLst>
   <p:sldSz cy="5143500" cx="9144000"/>
   <p:notesSz cx="6858000" cy="9144000"/>
   <p:embeddedFontLst>
     <p:embeddedFont>
       <p:font typeface="Google Sans Flex Medium"/>
-      <p:regular r:id="rId20"/>
-      <p:bold r:id="rId21"/>
+      <p:regular r:id="rId21"/>
+      <p:bold r:id="rId22"/>
     </p:embeddedFont>
     <p:embeddedFont>
       <p:font typeface="Google Sans Flex"/>
-      <p:regular r:id="rId22"/>
-      <p:bold r:id="rId23"/>
+      <p:regular r:id="rId23"/>
+      <p:bold r:id="rId24"/>
     </p:embeddedFont>
   </p:embeddedFontLst>
   <p:defaultTextStyle>
@@ -816,7 +816,7 @@
   <p:cSld>
     <p:spTree>
       <p:nvGrpSpPr>
-        <p:cNvPr id="161" name="Shape 161"/>
+        <p:cNvPr id="180" name="Shape 180"/>
         <p:cNvGrpSpPr/>
         <p:nvPr/>
       </p:nvGrpSpPr>
@@ -830,7 +830,7 @@
       </p:grpSpPr>
       <p:sp>
         <p:nvSpPr>
-          <p:cNvPr id="162" name="Google Shape;162;g3fb085bff3c_0_46:notes"/>
+          <p:cNvPr id="181" name="Google Shape;181;g3fb085bff3c_0_46:notes"/>
           <p:cNvSpPr/>
           <p:nvPr>
             <p:ph idx="2" type="sldImg"/>
@@ -865,7 +865,7 @@
       </p:sp>
       <p:sp>
         <p:nvSpPr>
-          <p:cNvPr id="163" name="Google Shape;163;g3fb085bff3c_0_46:notes"/>
+          <p:cNvPr id="182" name="Google Shape;182;g3fb085bff3c_0_46:notes"/>
           <p:cNvSpPr txBox="1"/>
           <p:nvPr>
             <p:ph idx="1" type="body"/>
@@ -916,7 +916,7 @@
   <p:cSld>
     <p:spTree>
       <p:nvGrpSpPr>
-        <p:cNvPr id="172" name="Shape 172"/>
+        <p:cNvPr id="191" name="Shape 191"/>
         <p:cNvGrpSpPr/>
         <p:nvPr/>
       </p:nvGrpSpPr>
@@ -930,7 +930,7 @@
       </p:grpSpPr>
       <p:sp>
         <p:nvSpPr>
-          <p:cNvPr id="173" name="Google Shape;173;g3fb085bff3c_0_51:notes"/>
+          <p:cNvPr id="192" name="Google Shape;192;g3fb085bff3c_0_51:notes"/>
           <p:cNvSpPr/>
           <p:nvPr>
             <p:ph idx="2" type="sldImg"/>
@@ -965,7 +965,7 @@
       </p:sp>
       <p:sp>
         <p:nvSpPr>
-          <p:cNvPr id="174" name="Google Shape;174;g3fb085bff3c_0_51:notes"/>
+          <p:cNvPr id="193" name="Google Shape;193;g3fb085bff3c_0_51:notes"/>
           <p:cNvSpPr txBox="1"/>
           <p:nvPr>
             <p:ph idx="1" type="body"/>
@@ -1016,7 +1016,7 @@
   <p:cSld>
     <p:spTree>
       <p:nvGrpSpPr>
-        <p:cNvPr id="184" name="Shape 184"/>
+        <p:cNvPr id="203" name="Shape 203"/>
         <p:cNvGrpSpPr/>
         <p:nvPr/>
       </p:nvGrpSpPr>
@@ -1030,7 +1030,7 @@
       </p:grpSpPr>
       <p:sp>
         <p:nvSpPr>
-          <p:cNvPr id="185" name="Google Shape;185;g3fb085bff3c_0_56:notes"/>
+          <p:cNvPr id="204" name="Google Shape;204;g3fb085bff3c_0_56:notes"/>
           <p:cNvSpPr/>
           <p:nvPr>
             <p:ph idx="2" type="sldImg"/>
@@ -1065,7 +1065,7 @@
       </p:sp>
       <p:sp>
         <p:nvSpPr>
-          <p:cNvPr id="186" name="Google Shape;186;g3fb085bff3c_0_56:notes"/>
+          <p:cNvPr id="205" name="Google Shape;205;g3fb085bff3c_0_56:notes"/>
           <p:cNvSpPr txBox="1"/>
           <p:nvPr>
             <p:ph idx="1" type="body"/>
@@ -1116,7 +1116,7 @@
   <p:cSld>
     <p:spTree>
       <p:nvGrpSpPr>
-        <p:cNvPr id="195" name="Shape 195"/>
+        <p:cNvPr id="214" name="Shape 214"/>
         <p:cNvGrpSpPr/>
         <p:nvPr/>
       </p:nvGrpSpPr>
@@ -1130,7 +1130,7 @@
       </p:grpSpPr>
       <p:sp>
         <p:nvSpPr>
-          <p:cNvPr id="196" name="Google Shape;196;g3fb085bff3c_0_61:notes"/>
+          <p:cNvPr id="215" name="Google Shape;215;g3fb085bff3c_0_61:notes"/>
           <p:cNvSpPr/>
           <p:nvPr>
             <p:ph idx="2" type="sldImg"/>
@@ -1165,7 +1165,7 @@
       </p:sp>
       <p:sp>
         <p:nvSpPr>
-          <p:cNvPr id="197" name="Google Shape;197;g3fb085bff3c_0_61:notes"/>
+          <p:cNvPr id="216" name="Google Shape;216;g3fb085bff3c_0_61:notes"/>
           <p:cNvSpPr txBox="1"/>
           <p:nvPr>
             <p:ph idx="1" type="body"/>
@@ -1216,7 +1216,7 @@
   <p:cSld>
     <p:spTree>
       <p:nvGrpSpPr>
-        <p:cNvPr id="204" name="Shape 204"/>
+        <p:cNvPr id="223" name="Shape 223"/>
         <p:cNvGrpSpPr/>
         <p:nvPr/>
       </p:nvGrpSpPr>
@@ -1230,7 +1230,7 @@
       </p:grpSpPr>
       <p:sp>
         <p:nvSpPr>
-          <p:cNvPr id="205" name="Google Shape;205;g3fb085bff3c_0_66:notes"/>
+          <p:cNvPr id="224" name="Google Shape;224;g3fb085bff3c_0_66:notes"/>
           <p:cNvSpPr/>
           <p:nvPr>
             <p:ph idx="2" type="sldImg"/>
@@ -1265,7 +1265,7 @@
       </p:sp>
       <p:sp>
         <p:nvSpPr>
-          <p:cNvPr id="206" name="Google Shape;206;g3fb085bff3c_0_66:notes"/>
+          <p:cNvPr id="225" name="Google Shape;225;g3fb085bff3c_0_66:notes"/>
           <p:cNvSpPr txBox="1"/>
           <p:nvPr>
             <p:ph idx="1" type="body"/>
@@ -2096,7 +2096,433 @@
             </a:pPr>
             <a:r>
               <a:rPr lang="en-GB"/>
-              <a:t>Source: https://github.com/mk-tdev/BatchLens/tree/main/research/BatchLens . Screenshots show the implemented prototype. Mira, Sol and Pip are authored guides. Gemini performs image extraction; a human confirms relationships.</a:t>
+              <a:t>Pilot estimate updated 18 October 2026. This is an engineering budget, not a measured customer pilot or billing invoice.</a:t>
+            </a:r>
+            <a:endParaRPr/>
+          </a:p>
+          <a:p>
+            <a:pPr indent="0" lvl="0" marL="0" rtl="0" algn="l">
+              <a:spcBef>
+                <a:spcPts val="0"/>
+              </a:spcBef>
+              <a:spcAft>
+                <a:spcPts val="0"/>
+              </a:spcAft>
+              <a:buNone/>
+            </a:pPr>
+            <a:r>
+              <a:t/>
+            </a:r>
+            <a:endParaRPr/>
+          </a:p>
+          <a:p>
+            <a:pPr indent="0" lvl="0" marL="0" rtl="0" algn="l">
+              <a:spcBef>
+                <a:spcPts val="0"/>
+              </a:spcBef>
+              <a:spcAft>
+                <a:spcPts val="0"/>
+              </a:spcAft>
+              <a:buNone/>
+            </a:pPr>
+            <a:r>
+              <a:rPr lang="en-GB"/>
+              <a:t>Measured fresh synthetic demo case bf90a81d-a7bd-4750-ad41-d747f8f1d310: Pip investigated, human approved mission, operator entered labelled synthetic R1, Gemini reassessed, and answered three operational chat questions. Baseline/S4 approvals, handover save and reload followed. No physical inspection was performed. Vertex AI Cloud Monitoring showed 66,308 input tokens, 3,087 output tokens, 19 HTTP-200 model invocations. Case counters: 4 image scans, 9 investigator calls, 6 chat calls. Quiet window and matching daily count support attribution. AI activity 18 Oct 2026 14:00:47–14:02:21 SGT.</a:t>
+            </a:r>
+            <a:endParaRPr/>
+          </a:p>
+          <a:p>
+            <a:pPr indent="0" lvl="0" marL="0" rtl="0" algn="l">
+              <a:spcBef>
+                <a:spcPts val="0"/>
+              </a:spcBef>
+              <a:spcAft>
+                <a:spcPts val="0"/>
+              </a:spcAft>
+              <a:buNone/>
+            </a:pPr>
+            <a:r>
+              <a:t/>
+            </a:r>
+            <a:endParaRPr/>
+          </a:p>
+          <a:p>
+            <a:pPr indent="0" lvl="0" marL="0" rtl="0" algn="l">
+              <a:spcBef>
+                <a:spcPts val="0"/>
+              </a:spcBef>
+              <a:spcAft>
+                <a:spcPts val="0"/>
+              </a:spcAft>
+              <a:buNone/>
+            </a:pPr>
+            <a:r>
+              <a:rPr lang="en-GB"/>
+              <a:t>Model gemini-3.5-flash-lite, standard global Vertex AI. Rates US$0.30/million input and US$2.50/million output. Calculation: 66,308 * 0.30/1,000,000 + 3,087 * 2.50/1,000,000 = US$0.0276099 per case. 19 calls already included.</a:t>
+            </a:r>
+            <a:endParaRPr/>
+          </a:p>
+          <a:p>
+            <a:pPr indent="0" lvl="0" marL="0" rtl="0" algn="l">
+              <a:spcBef>
+                <a:spcPts val="0"/>
+              </a:spcBef>
+              <a:spcAft>
+                <a:spcPts val="0"/>
+              </a:spcAft>
+              <a:buNone/>
+            </a:pPr>
+            <a:r>
+              <a:t/>
+            </a:r>
+            <a:endParaRPr/>
+          </a:p>
+          <a:p>
+            <a:pPr indent="0" lvl="0" marL="0" rtl="0" algn="l">
+              <a:spcBef>
+                <a:spcPts val="0"/>
+              </a:spcBef>
+              <a:spcAft>
+                <a:spcPts val="0"/>
+              </a:spcAft>
+              <a:buNone/>
+            </a:pPr>
+            <a:r>
+              <a:rPr lang="en-GB"/>
+              <a:t>Monthly planning allowances at 100 / 1,000 cases:</a:t>
+            </a:r>
+            <a:endParaRPr/>
+          </a:p>
+          <a:p>
+            <a:pPr indent="0" lvl="0" marL="0" rtl="0" algn="l">
+              <a:spcBef>
+                <a:spcPts val="0"/>
+              </a:spcBef>
+              <a:spcAft>
+                <a:spcPts val="0"/>
+              </a:spcAft>
+              <a:buNone/>
+            </a:pPr>
+            <a:r>
+              <a:rPr lang="en-GB"/>
+              <a:t>Gemini: $2.76 / $27.61</a:t>
+            </a:r>
+            <a:endParaRPr/>
+          </a:p>
+          <a:p>
+            <a:pPr indent="0" lvl="0" marL="0" rtl="0" algn="l">
+              <a:spcBef>
+                <a:spcPts val="0"/>
+              </a:spcBef>
+              <a:spcAft>
+                <a:spcPts val="0"/>
+              </a:spcAft>
+              <a:buNone/>
+            </a:pPr>
+            <a:r>
+              <a:rPr lang="en-GB"/>
+              <a:t>Cloud Run: $0.50 / $5.00</a:t>
+            </a:r>
+            <a:endParaRPr/>
+          </a:p>
+          <a:p>
+            <a:pPr indent="0" lvl="0" marL="0" rtl="0" algn="l">
+              <a:spcBef>
+                <a:spcPts val="0"/>
+              </a:spcBef>
+              <a:spcAft>
+                <a:spcPts val="0"/>
+              </a:spcAft>
+              <a:buNone/>
+            </a:pPr>
+            <a:r>
+              <a:rPr lang="en-GB"/>
+              <a:t>Firestore operations and case storage: $0.10 / $1.00</a:t>
+            </a:r>
+            <a:endParaRPr/>
+          </a:p>
+          <a:p>
+            <a:pPr indent="0" lvl="0" marL="0" rtl="0" algn="l">
+              <a:spcBef>
+                <a:spcPts val="0"/>
+              </a:spcBef>
+              <a:spcAft>
+                <a:spcPts val="0"/>
+              </a:spcAft>
+              <a:buNone/>
+            </a:pPr>
+            <a:r>
+              <a:rPr lang="en-GB"/>
+              <a:t>Artifact Registry and build-source storage: $0.60 / $0.60</a:t>
+            </a:r>
+            <a:endParaRPr/>
+          </a:p>
+          <a:p>
+            <a:pPr indent="0" lvl="0" marL="0" rtl="0" algn="l">
+              <a:spcBef>
+                <a:spcPts val="0"/>
+              </a:spcBef>
+              <a:spcAft>
+                <a:spcPts val="0"/>
+              </a:spcAft>
+              <a:buNone/>
+            </a:pPr>
+            <a:r>
+              <a:rPr lang="en-GB"/>
+              <a:t>Cloud Build: $1.00 / $1.00</a:t>
+            </a:r>
+            <a:endParaRPr/>
+          </a:p>
+          <a:p>
+            <a:pPr indent="0" lvl="0" marL="0" rtl="0" algn="l">
+              <a:spcBef>
+                <a:spcPts val="0"/>
+              </a:spcBef>
+              <a:spcAft>
+                <a:spcPts val="0"/>
+              </a:spcAft>
+              <a:buNone/>
+            </a:pPr>
+            <a:r>
+              <a:rPr lang="en-GB"/>
+              <a:t>Internet transfer: $0.25 / $2.50</a:t>
+            </a:r>
+            <a:endParaRPr/>
+          </a:p>
+          <a:p>
+            <a:pPr indent="0" lvl="0" marL="0" rtl="0" algn="l">
+              <a:spcBef>
+                <a:spcPts val="0"/>
+              </a:spcBef>
+              <a:spcAft>
+                <a:spcPts val="0"/>
+              </a:spcAft>
+              <a:buNone/>
+            </a:pPr>
+            <a:r>
+              <a:rPr lang="en-GB"/>
+              <a:t>Subtotal: $5.21 / $37.71</a:t>
+            </a:r>
+            <a:endParaRPr/>
+          </a:p>
+          <a:p>
+            <a:pPr indent="0" lvl="0" marL="0" rtl="0" algn="l">
+              <a:spcBef>
+                <a:spcPts val="0"/>
+              </a:spcBef>
+              <a:spcAft>
+                <a:spcPts val="0"/>
+              </a:spcAft>
+              <a:buNone/>
+            </a:pPr>
+            <a:r>
+              <a:rPr lang="en-GB"/>
+              <a:t>Recommended budget including headroom: $6 / $40.</a:t>
+            </a:r>
+            <a:endParaRPr/>
+          </a:p>
+          <a:p>
+            <a:pPr indent="0" lvl="0" marL="0" rtl="0" algn="l">
+              <a:spcBef>
+                <a:spcPts val="0"/>
+              </a:spcBef>
+              <a:spcAft>
+                <a:spcPts val="0"/>
+              </a:spcAft>
+              <a:buNone/>
+            </a:pPr>
+            <a:r>
+              <a:t/>
+            </a:r>
+            <a:endParaRPr/>
+          </a:p>
+          <a:p>
+            <a:pPr indent="0" lvl="0" marL="0" rtl="0" algn="l">
+              <a:spcBef>
+                <a:spcPts val="0"/>
+              </a:spcBef>
+              <a:spcAft>
+                <a:spcPts val="0"/>
+              </a:spcAft>
+              <a:buNone/>
+            </a:pPr>
+            <a:r>
+              <a:rPr lang="en-GB"/>
+              <a:t>Assumptions: Cloud Run in Singapore with request-based billing, minimum zero instances, 1 vCPU/512 MiB, about 180 billable instance-seconds and 200 requests per case. Approximately 500 Firestore reads and 200 writes per case, 24-hour case expiry. Named Firestore database has no standard free quota. Around 5 GiB retained container images and 1 GiB build-source files. Twenty five-minute builds/month, about 10 MiB internet traffic/case. Light logs/monitoring assumed within normal free allowance; budget headroom covers small variation. Infrastructure figures are estimates and rounded allowances, not observed billing. No promotional credits or available free-tier discounts subtracted. USD before taxes. More public visits, retained images, longer investigations or builds increase cost. Budget is not a spending cap.</a:t>
+            </a:r>
+            <a:endParaRPr/>
+          </a:p>
+          <a:p>
+            <a:pPr indent="0" lvl="0" marL="0" rtl="0" algn="l">
+              <a:spcBef>
+                <a:spcPts val="0"/>
+              </a:spcBef>
+              <a:spcAft>
+                <a:spcPts val="0"/>
+              </a:spcAft>
+              <a:buNone/>
+            </a:pPr>
+            <a:r>
+              <a:t/>
+            </a:r>
+            <a:endParaRPr/>
+          </a:p>
+          <a:p>
+            <a:pPr indent="0" lvl="0" marL="0" rtl="0" algn="l">
+              <a:spcBef>
+                <a:spcPts val="0"/>
+              </a:spcBef>
+              <a:spcAft>
+                <a:spcPts val="0"/>
+              </a:spcAft>
+              <a:buNone/>
+            </a:pPr>
+            <a:r>
+              <a:rPr lang="en-GB"/>
+              <a:t>At 19 calls/case, the current 100-attempt/day safeguard allows roughly five full cases/day. The 1,000-case monthly scenario requires an explicitly approved increase to that limit. No deployed limit was changed.</a:t>
+            </a:r>
+            <a:endParaRPr/>
+          </a:p>
+          <a:p>
+            <a:pPr indent="0" lvl="0" marL="0" rtl="0" algn="l">
+              <a:spcBef>
+                <a:spcPts val="0"/>
+              </a:spcBef>
+              <a:spcAft>
+                <a:spcPts val="0"/>
+              </a:spcAft>
+              <a:buNone/>
+            </a:pPr>
+            <a:r>
+              <a:t/>
+            </a:r>
+            <a:endParaRPr/>
+          </a:p>
+          <a:p>
+            <a:pPr indent="0" lvl="0" marL="0" rtl="0" algn="l">
+              <a:spcBef>
+                <a:spcPts val="0"/>
+              </a:spcBef>
+              <a:spcAft>
+                <a:spcPts val="0"/>
+              </a:spcAft>
+              <a:buNone/>
+            </a:pPr>
+            <a:r>
+              <a:rPr lang="en-GB"/>
+              <a:t>Official price sources checked 18 Oct 2026:</a:t>
+            </a:r>
+            <a:endParaRPr/>
+          </a:p>
+          <a:p>
+            <a:pPr indent="0" lvl="0" marL="0" rtl="0" algn="l">
+              <a:spcBef>
+                <a:spcPts val="0"/>
+              </a:spcBef>
+              <a:spcAft>
+                <a:spcPts val="0"/>
+              </a:spcAft>
+              <a:buNone/>
+            </a:pPr>
+            <a:r>
+              <a:rPr lang="en-GB"/>
+              <a:t>https://cloud.google.com/gemini-enterprise-agent-platform/generative-ai/pricing</a:t>
+            </a:r>
+            <a:endParaRPr/>
+          </a:p>
+          <a:p>
+            <a:pPr indent="0" lvl="0" marL="0" rtl="0" algn="l">
+              <a:spcBef>
+                <a:spcPts val="0"/>
+              </a:spcBef>
+              <a:spcAft>
+                <a:spcPts val="0"/>
+              </a:spcAft>
+              <a:buNone/>
+            </a:pPr>
+            <a:r>
+              <a:rPr lang="en-GB"/>
+              <a:t>https://cloud.google.com/run/pricing</a:t>
+            </a:r>
+            <a:endParaRPr/>
+          </a:p>
+          <a:p>
+            <a:pPr indent="0" lvl="0" marL="0" rtl="0" algn="l">
+              <a:spcBef>
+                <a:spcPts val="0"/>
+              </a:spcBef>
+              <a:spcAft>
+                <a:spcPts val="0"/>
+              </a:spcAft>
+              <a:buNone/>
+            </a:pPr>
+            <a:r>
+              <a:rPr lang="en-GB"/>
+              <a:t>https://cloud.google.com/firestore/pricing</a:t>
+            </a:r>
+            <a:endParaRPr/>
+          </a:p>
+          <a:p>
+            <a:pPr indent="0" lvl="0" marL="0" rtl="0" algn="l">
+              <a:spcBef>
+                <a:spcPts val="0"/>
+              </a:spcBef>
+              <a:spcAft>
+                <a:spcPts val="0"/>
+              </a:spcAft>
+              <a:buNone/>
+            </a:pPr>
+            <a:r>
+              <a:rPr lang="en-GB"/>
+              <a:t>https://cloud.google.com/artifact-registry/pricing</a:t>
+            </a:r>
+            <a:endParaRPr/>
+          </a:p>
+          <a:p>
+            <a:pPr indent="0" lvl="0" marL="0" rtl="0" algn="l">
+              <a:spcBef>
+                <a:spcPts val="0"/>
+              </a:spcBef>
+              <a:spcAft>
+                <a:spcPts val="0"/>
+              </a:spcAft>
+              <a:buNone/>
+            </a:pPr>
+            <a:r>
+              <a:rPr lang="en-GB"/>
+              <a:t>https://cloud.google.com/storage/pricing</a:t>
+            </a:r>
+            <a:endParaRPr/>
+          </a:p>
+          <a:p>
+            <a:pPr indent="0" lvl="0" marL="0" rtl="0" algn="l">
+              <a:spcBef>
+                <a:spcPts val="0"/>
+              </a:spcBef>
+              <a:spcAft>
+                <a:spcPts val="0"/>
+              </a:spcAft>
+              <a:buNone/>
+            </a:pPr>
+            <a:r>
+              <a:rPr lang="en-GB"/>
+              <a:t>https://cloud.google.com/build/pricing</a:t>
+            </a:r>
+            <a:endParaRPr/>
+          </a:p>
+          <a:p>
+            <a:pPr indent="0" lvl="0" marL="0" rtl="0" algn="l">
+              <a:spcBef>
+                <a:spcPts val="0"/>
+              </a:spcBef>
+              <a:spcAft>
+                <a:spcPts val="0"/>
+              </a:spcAft>
+              <a:buNone/>
+            </a:pPr>
+            <a:r>
+              <a:rPr lang="en-GB"/>
+              <a:t>Local measured evidence: research/BatchLens/cost-estimate/vertex-usage-2026-10-18.json</a:t>
             </a:r>
             <a:endParaRPr/>
           </a:p>
@@ -7057,7 +7483,7 @@
     </p:bg>
     <p:spTree>
       <p:nvGrpSpPr>
-        <p:cNvPr id="164" name="Shape 164"/>
+        <p:cNvPr id="183" name="Shape 183"/>
         <p:cNvGrpSpPr/>
         <p:nvPr/>
       </p:nvGrpSpPr>
@@ -7071,7 +7497,7 @@
       </p:grpSpPr>
       <p:pic>
         <p:nvPicPr>
-          <p:cNvPr id="165" name="Google Shape;165;p22" title="Frame 144.png"/>
+          <p:cNvPr id="184" name="Google Shape;184;p22" title="Frame 144.png"/>
           <p:cNvPicPr preferRelativeResize="0"/>
           <p:nvPr/>
         </p:nvPicPr>
@@ -7098,7 +7524,7 @@
       </p:pic>
       <p:pic>
         <p:nvPicPr>
-          <p:cNvPr id="166" name="Google Shape;166;p22" title="Group 427319979.png"/>
+          <p:cNvPr id="185" name="Google Shape;185;p22" title="Group 427319979.png"/>
           <p:cNvPicPr preferRelativeResize="0"/>
           <p:nvPr/>
         </p:nvPicPr>
@@ -7126,7 +7552,7 @@
       </p:pic>
       <p:sp>
         <p:nvSpPr>
-          <p:cNvPr id="167" name="Google Shape;167;p22"/>
+          <p:cNvPr id="186" name="Google Shape;186;p22"/>
           <p:cNvSpPr/>
           <p:nvPr/>
         </p:nvSpPr>
@@ -7169,7 +7595,7 @@
       </p:sp>
       <p:sp>
         <p:nvSpPr>
-          <p:cNvPr id="168" name="Google Shape;168;p22"/>
+          <p:cNvPr id="187" name="Google Shape;187;p22"/>
           <p:cNvSpPr txBox="1"/>
           <p:nvPr/>
         </p:nvSpPr>
@@ -7227,7 +7653,7 @@
       </p:sp>
       <p:sp>
         <p:nvSpPr>
-          <p:cNvPr id="169" name="Google Shape;169;p22"/>
+          <p:cNvPr id="188" name="Google Shape;188;p22"/>
           <p:cNvSpPr txBox="1"/>
           <p:nvPr/>
         </p:nvSpPr>
@@ -7288,7 +7714,7 @@
       </p:sp>
       <p:pic>
         <p:nvPicPr>
-          <p:cNvPr id="170" name="Google Shape;170;p22"/>
+          <p:cNvPr id="189" name="Google Shape;189;p22"/>
           <p:cNvPicPr preferRelativeResize="0"/>
           <p:nvPr/>
         </p:nvPicPr>
@@ -7316,7 +7742,7 @@
       </p:pic>
       <p:sp>
         <p:nvSpPr>
-          <p:cNvPr id="171" name="Google Shape;171;p22"/>
+          <p:cNvPr id="190" name="Google Shape;190;p22"/>
           <p:cNvSpPr txBox="1"/>
           <p:nvPr/>
         </p:nvSpPr>
@@ -7526,7 +7952,7 @@
     </p:bg>
     <p:spTree>
       <p:nvGrpSpPr>
-        <p:cNvPr id="175" name="Shape 175"/>
+        <p:cNvPr id="194" name="Shape 194"/>
         <p:cNvGrpSpPr/>
         <p:nvPr/>
       </p:nvGrpSpPr>
@@ -7540,7 +7966,7 @@
       </p:grpSpPr>
       <p:pic>
         <p:nvPicPr>
-          <p:cNvPr id="176" name="Google Shape;176;p23" title="Frame 144.png"/>
+          <p:cNvPr id="195" name="Google Shape;195;p23" title="Frame 144.png"/>
           <p:cNvPicPr preferRelativeResize="0"/>
           <p:nvPr/>
         </p:nvPicPr>
@@ -7567,7 +7993,7 @@
       </p:pic>
       <p:pic>
         <p:nvPicPr>
-          <p:cNvPr id="177" name="Google Shape;177;p23" title="Group 427319979.png"/>
+          <p:cNvPr id="196" name="Google Shape;196;p23" title="Group 427319979.png"/>
           <p:cNvPicPr preferRelativeResize="0"/>
           <p:nvPr/>
         </p:nvPicPr>
@@ -7595,7 +8021,7 @@
       </p:pic>
       <p:sp>
         <p:nvSpPr>
-          <p:cNvPr id="178" name="Google Shape;178;p23"/>
+          <p:cNvPr id="197" name="Google Shape;197;p23"/>
           <p:cNvSpPr/>
           <p:nvPr/>
         </p:nvSpPr>
@@ -7638,7 +8064,7 @@
       </p:sp>
       <p:sp>
         <p:nvSpPr>
-          <p:cNvPr id="179" name="Google Shape;179;p23"/>
+          <p:cNvPr id="198" name="Google Shape;198;p23"/>
           <p:cNvSpPr txBox="1"/>
           <p:nvPr/>
         </p:nvSpPr>
@@ -7696,7 +8122,7 @@
       </p:sp>
       <p:sp>
         <p:nvSpPr>
-          <p:cNvPr id="180" name="Google Shape;180;p23"/>
+          <p:cNvPr id="199" name="Google Shape;199;p23"/>
           <p:cNvSpPr txBox="1"/>
           <p:nvPr/>
         </p:nvSpPr>
@@ -7757,7 +8183,7 @@
       </p:sp>
       <p:sp>
         <p:nvSpPr>
-          <p:cNvPr id="181" name="Google Shape;181;p23"/>
+          <p:cNvPr id="200" name="Google Shape;200;p23"/>
           <p:cNvSpPr txBox="1"/>
           <p:nvPr/>
         </p:nvSpPr>
@@ -7853,7 +8279,7 @@
       </p:sp>
       <p:sp>
         <p:nvSpPr>
-          <p:cNvPr id="182" name="Google Shape;182;p23"/>
+          <p:cNvPr id="201" name="Google Shape;201;p23"/>
           <p:cNvSpPr txBox="1"/>
           <p:nvPr/>
         </p:nvSpPr>
@@ -8045,7 +8471,7 @@
       </p:sp>
       <p:sp>
         <p:nvSpPr>
-          <p:cNvPr id="183" name="Google Shape;183;p23"/>
+          <p:cNvPr id="202" name="Google Shape;202;p23"/>
           <p:cNvSpPr txBox="1"/>
           <p:nvPr/>
         </p:nvSpPr>
@@ -8159,7 +8585,7 @@
     </p:bg>
     <p:spTree>
       <p:nvGrpSpPr>
-        <p:cNvPr id="187" name="Shape 187"/>
+        <p:cNvPr id="206" name="Shape 206"/>
         <p:cNvGrpSpPr/>
         <p:nvPr/>
       </p:nvGrpSpPr>
@@ -8173,7 +8599,7 @@
       </p:grpSpPr>
       <p:pic>
         <p:nvPicPr>
-          <p:cNvPr id="188" name="Google Shape;188;p24" title="Frame 144.png"/>
+          <p:cNvPr id="207" name="Google Shape;207;p24" title="Frame 144.png"/>
           <p:cNvPicPr preferRelativeResize="0"/>
           <p:nvPr/>
         </p:nvPicPr>
@@ -8200,7 +8626,7 @@
       </p:pic>
       <p:pic>
         <p:nvPicPr>
-          <p:cNvPr id="189" name="Google Shape;189;p24" title="Group 427319979.png"/>
+          <p:cNvPr id="208" name="Google Shape;208;p24" title="Group 427319979.png"/>
           <p:cNvPicPr preferRelativeResize="0"/>
           <p:nvPr/>
         </p:nvPicPr>
@@ -8228,7 +8654,7 @@
       </p:pic>
       <p:sp>
         <p:nvSpPr>
-          <p:cNvPr id="190" name="Google Shape;190;p24"/>
+          <p:cNvPr id="209" name="Google Shape;209;p24"/>
           <p:cNvSpPr/>
           <p:nvPr/>
         </p:nvSpPr>
@@ -8271,7 +8697,7 @@
       </p:sp>
       <p:sp>
         <p:nvSpPr>
-          <p:cNvPr id="191" name="Google Shape;191;p24"/>
+          <p:cNvPr id="210" name="Google Shape;210;p24"/>
           <p:cNvSpPr txBox="1"/>
           <p:nvPr/>
         </p:nvSpPr>
@@ -8329,7 +8755,7 @@
       </p:sp>
       <p:sp>
         <p:nvSpPr>
-          <p:cNvPr id="192" name="Google Shape;192;p24"/>
+          <p:cNvPr id="211" name="Google Shape;211;p24"/>
           <p:cNvSpPr txBox="1"/>
           <p:nvPr/>
         </p:nvSpPr>
@@ -8390,7 +8816,7 @@
       </p:sp>
       <p:sp>
         <p:nvSpPr>
-          <p:cNvPr id="193" name="Google Shape;193;p24"/>
+          <p:cNvPr id="212" name="Google Shape;212;p24"/>
           <p:cNvSpPr txBox="1"/>
           <p:nvPr/>
         </p:nvSpPr>
@@ -8451,7 +8877,7 @@
       </p:sp>
       <p:sp>
         <p:nvSpPr>
-          <p:cNvPr id="194" name="Google Shape;194;p24"/>
+          <p:cNvPr id="213" name="Google Shape;213;p24"/>
           <p:cNvSpPr txBox="1"/>
           <p:nvPr/>
         </p:nvSpPr>
@@ -8591,7 +9017,7 @@
     </p:bg>
     <p:spTree>
       <p:nvGrpSpPr>
-        <p:cNvPr id="198" name="Shape 198"/>
+        <p:cNvPr id="217" name="Shape 217"/>
         <p:cNvGrpSpPr/>
         <p:nvPr/>
       </p:nvGrpSpPr>
@@ -8605,7 +9031,7 @@
       </p:grpSpPr>
       <p:pic>
         <p:nvPicPr>
-          <p:cNvPr id="199" name="Google Shape;199;p25" title="Frame 144.png"/>
+          <p:cNvPr id="218" name="Google Shape;218;p25" title="Frame 144.png"/>
           <p:cNvPicPr preferRelativeResize="0"/>
           <p:nvPr/>
         </p:nvPicPr>
@@ -8632,7 +9058,7 @@
       </p:pic>
       <p:pic>
         <p:nvPicPr>
-          <p:cNvPr id="200" name="Google Shape;200;p25" title="Group 427319979.png"/>
+          <p:cNvPr id="219" name="Google Shape;219;p25" title="Group 427319979.png"/>
           <p:cNvPicPr preferRelativeResize="0"/>
           <p:nvPr/>
         </p:nvPicPr>
@@ -8660,7 +9086,7 @@
       </p:pic>
       <p:sp>
         <p:nvSpPr>
-          <p:cNvPr id="201" name="Google Shape;201;p25"/>
+          <p:cNvPr id="220" name="Google Shape;220;p25"/>
           <p:cNvSpPr/>
           <p:nvPr/>
         </p:nvSpPr>
@@ -8703,7 +9129,7 @@
       </p:sp>
       <p:sp>
         <p:nvSpPr>
-          <p:cNvPr id="202" name="Google Shape;202;p25"/>
+          <p:cNvPr id="221" name="Google Shape;221;p25"/>
           <p:cNvSpPr txBox="1"/>
           <p:nvPr/>
         </p:nvSpPr>
@@ -8918,7 +9344,7 @@
       </p:sp>
       <p:sp>
         <p:nvSpPr>
-          <p:cNvPr id="203" name="Google Shape;203;p25"/>
+          <p:cNvPr id="222" name="Google Shape;222;p25"/>
           <p:cNvSpPr txBox="1"/>
           <p:nvPr/>
         </p:nvSpPr>
@@ -9060,7 +9486,7 @@
   <p:cSld>
     <p:spTree>
       <p:nvGrpSpPr>
-        <p:cNvPr id="207" name="Shape 207"/>
+        <p:cNvPr id="226" name="Shape 226"/>
         <p:cNvGrpSpPr/>
         <p:nvPr/>
       </p:nvGrpSpPr>
@@ -9074,7 +9500,7 @@
       </p:grpSpPr>
       <p:pic>
         <p:nvPicPr>
-          <p:cNvPr id="208" name="Google Shape;208;p26" title="Frame 144.png"/>
+          <p:cNvPr id="227" name="Google Shape;227;p26" title="Frame 144.png"/>
           <p:cNvPicPr preferRelativeResize="0"/>
           <p:nvPr/>
         </p:nvPicPr>
@@ -9101,7 +9527,7 @@
       </p:pic>
       <p:pic>
         <p:nvPicPr>
-          <p:cNvPr id="209" name="Google Shape;209;p26"/>
+          <p:cNvPr id="228" name="Google Shape;228;p26"/>
           <p:cNvPicPr preferRelativeResize="0"/>
           <p:nvPr/>
         </p:nvPicPr>
@@ -13631,227 +14057,102 @@
       <p:sp>
         <p:nvSpPr>
           <p:cNvPr id="158" name="Google Shape;158;p21"/>
-          <p:cNvSpPr txBox="1"/>
+          <p:cNvSpPr/>
           <p:nvPr/>
         </p:nvSpPr>
         <p:spPr>
           <a:xfrm>
-            <a:off x="381000" y="1422400"/>
-            <a:ext cx="4127400" cy="507900"/>
-          </a:xfrm>
-          <a:prstGeom prst="rect">
-            <a:avLst/>
+            <a:off x="457200" y="1097280"/>
+            <a:ext cx="5120700" cy="2148900"/>
+          </a:xfrm>
+          <a:prstGeom prst="roundRect">
+            <a:avLst>
+              <a:gd fmla="val 16667" name="adj"/>
+            </a:avLst>
           </a:prstGeom>
-          <a:noFill/>
-          <a:ln>
-            <a:noFill/>
+          <a:solidFill>
+            <a:srgbClr val="0F2B27"/>
+          </a:solidFill>
+          <a:ln cap="flat" cmpd="sng" w="12700">
+            <a:solidFill>
+              <a:srgbClr val="1F4A41"/>
+            </a:solidFill>
+            <a:prstDash val="solid"/>
+            <a:round/>
+            <a:headEnd len="sm" w="sm" type="none"/>
+            <a:tailEnd len="sm" w="sm" type="none"/>
           </a:ln>
         </p:spPr>
         <p:txBody>
-          <a:bodyPr anchorCtr="0" anchor="t" bIns="91425" lIns="91425" spcFirstLastPara="1" rIns="91425" wrap="square" tIns="91425">
+          <a:bodyPr anchorCtr="0" anchor="ctr" bIns="91425" lIns="91425" spcFirstLastPara="1" rIns="91425" wrap="square" tIns="91425">
             <a:noAutofit/>
           </a:bodyPr>
           <a:lstStyle/>
           <a:p>
-            <a:pPr indent="0" lvl="0" marL="0" rtl="0" algn="l">
-              <a:lnSpc>
-                <a:spcPct val="105000"/>
-              </a:lnSpc>
-              <a:spcBef>
-                <a:spcPts val="0"/>
-              </a:spcBef>
-              <a:spcAft>
-                <a:spcPts val="400"/>
-              </a:spcAft>
-              <a:buNone/>
-            </a:pPr>
-            <a:r>
-              <a:rPr b="1" lang="en-GB" sz="2200">
-                <a:solidFill>
-                  <a:srgbClr val="A6E4C6"/>
-                </a:solidFill>
-                <a:latin typeface="Google Sans Flex"/>
-                <a:ea typeface="Google Sans Flex"/>
-                <a:cs typeface="Google Sans Flex"/>
-                <a:sym typeface="Google Sans Flex"/>
-              </a:rPr>
-              <a:t>Pilot estimate: pending</a:t>
-            </a:r>
-            <a:endParaRPr b="1" sz="2200">
-              <a:solidFill>
-                <a:srgbClr val="A6E4C6"/>
-              </a:solidFill>
-              <a:latin typeface="Google Sans Flex"/>
-              <a:ea typeface="Google Sans Flex"/>
-              <a:cs typeface="Google Sans Flex"/>
-              <a:sym typeface="Google Sans Flex"/>
-            </a:endParaRPr>
+            <a:pPr indent="0" lvl="0" marL="0" rtl="0" algn="ctr">
+              <a:spcBef>
+                <a:spcPts val="0"/>
+              </a:spcBef>
+              <a:spcAft>
+                <a:spcPts val="0"/>
+              </a:spcAft>
+              <a:buNone/>
+            </a:pPr>
+            <a:r>
+              <a:t/>
+            </a:r>
+            <a:endParaRPr/>
           </a:p>
         </p:txBody>
       </p:sp>
       <p:sp>
         <p:nvSpPr>
           <p:cNvPr id="159" name="Google Shape;159;p21"/>
-          <p:cNvSpPr txBox="1"/>
+          <p:cNvSpPr/>
           <p:nvPr/>
         </p:nvSpPr>
         <p:spPr>
           <a:xfrm>
-            <a:off x="381000" y="2133600"/>
-            <a:ext cx="8255100" cy="1841400"/>
-          </a:xfrm>
-          <a:prstGeom prst="rect">
-            <a:avLst/>
+            <a:off x="5760720" y="1097280"/>
+            <a:ext cx="2926200" cy="2148900"/>
+          </a:xfrm>
+          <a:prstGeom prst="roundRect">
+            <a:avLst>
+              <a:gd fmla="val 16667" name="adj"/>
+            </a:avLst>
           </a:prstGeom>
-          <a:noFill/>
-          <a:ln>
-            <a:noFill/>
+          <a:solidFill>
+            <a:srgbClr val="A6E4C6"/>
+          </a:solidFill>
+          <a:ln cap="flat" cmpd="sng" w="12700">
+            <a:solidFill>
+              <a:srgbClr val="A6E4C6"/>
+            </a:solidFill>
+            <a:prstDash val="solid"/>
+            <a:round/>
+            <a:headEnd len="sm" w="sm" type="none"/>
+            <a:tailEnd len="sm" w="sm" type="none"/>
           </a:ln>
         </p:spPr>
         <p:txBody>
-          <a:bodyPr anchorCtr="0" anchor="t" bIns="91425" lIns="91425" spcFirstLastPara="1" rIns="91425" wrap="square" tIns="91425">
+          <a:bodyPr anchorCtr="0" anchor="ctr" bIns="91425" lIns="91425" spcFirstLastPara="1" rIns="91425" wrap="square" tIns="91425">
             <a:noAutofit/>
           </a:bodyPr>
           <a:lstStyle/>
           <a:p>
-            <a:pPr indent="0" lvl="0" marL="0" rtl="0" algn="l">
-              <a:lnSpc>
-                <a:spcPct val="110000"/>
-              </a:lnSpc>
-              <a:spcBef>
-                <a:spcPts val="0"/>
-              </a:spcBef>
-              <a:spcAft>
-                <a:spcPts val="0"/>
-              </a:spcAft>
-              <a:buNone/>
-            </a:pPr>
-            <a:r>
-              <a:rPr lang="en-GB" sz="2000">
-                <a:solidFill>
-                  <a:srgbClr val="EAF5E9"/>
-                </a:solidFill>
-                <a:latin typeface="Google Sans Flex"/>
-                <a:ea typeface="Google Sans Flex"/>
-                <a:cs typeface="Google Sans Flex"/>
-                <a:sym typeface="Google Sans Flex"/>
-              </a:rPr>
-              <a:t>0 minimum / 2 maximum Cloud Run instances</a:t>
-            </a:r>
-            <a:endParaRPr sz="2000">
-              <a:solidFill>
-                <a:srgbClr val="EAF5E9"/>
-              </a:solidFill>
-              <a:latin typeface="Google Sans Flex"/>
-              <a:ea typeface="Google Sans Flex"/>
-              <a:cs typeface="Google Sans Flex"/>
-              <a:sym typeface="Google Sans Flex"/>
-            </a:endParaRPr>
-          </a:p>
-          <a:p>
-            <a:pPr indent="0" lvl="0" marL="0" rtl="0" algn="l">
-              <a:lnSpc>
-                <a:spcPct val="110000"/>
-              </a:lnSpc>
-              <a:spcBef>
-                <a:spcPts val="800"/>
-              </a:spcBef>
-              <a:spcAft>
-                <a:spcPts val="0"/>
-              </a:spcAft>
-              <a:buNone/>
-            </a:pPr>
-            <a:r>
-              <a:rPr lang="en-GB" sz="2000">
-                <a:solidFill>
-                  <a:srgbClr val="EAF5E9"/>
-                </a:solidFill>
-                <a:latin typeface="Google Sans Flex"/>
-                <a:ea typeface="Google Sans Flex"/>
-                <a:cs typeface="Google Sans Flex"/>
-                <a:sym typeface="Google Sans Flex"/>
-              </a:rPr>
-              <a:t>100 model attempts/day across cases</a:t>
-            </a:r>
-            <a:endParaRPr sz="2000">
-              <a:solidFill>
-                <a:srgbClr val="EAF5E9"/>
-              </a:solidFill>
-              <a:latin typeface="Google Sans Flex"/>
-              <a:ea typeface="Google Sans Flex"/>
-              <a:cs typeface="Google Sans Flex"/>
-              <a:sym typeface="Google Sans Flex"/>
-            </a:endParaRPr>
-          </a:p>
-          <a:p>
-            <a:pPr indent="0" lvl="0" marL="0" rtl="0" algn="l">
-              <a:lnSpc>
-                <a:spcPct val="110000"/>
-              </a:lnSpc>
-              <a:spcBef>
-                <a:spcPts val="800"/>
-              </a:spcBef>
-              <a:spcAft>
-                <a:spcPts val="0"/>
-              </a:spcAft>
-              <a:buNone/>
-            </a:pPr>
-            <a:r>
-              <a:rPr lang="en-GB" sz="2000">
-                <a:solidFill>
-                  <a:srgbClr val="EAF5E9"/>
-                </a:solidFill>
-                <a:latin typeface="Google Sans Flex"/>
-                <a:ea typeface="Google Sans Flex"/>
-                <a:cs typeface="Google Sans Flex"/>
-                <a:sym typeface="Google Sans Flex"/>
-              </a:rPr>
-              <a:t>Per case: 12 investigator + 8 scans + 12 chat calls</a:t>
-            </a:r>
-            <a:endParaRPr sz="2000">
-              <a:solidFill>
-                <a:srgbClr val="EAF5E9"/>
-              </a:solidFill>
-              <a:latin typeface="Google Sans Flex"/>
-              <a:ea typeface="Google Sans Flex"/>
-              <a:cs typeface="Google Sans Flex"/>
-              <a:sym typeface="Google Sans Flex"/>
-            </a:endParaRPr>
-          </a:p>
-          <a:p>
-            <a:pPr indent="0" lvl="0" marL="0" rtl="0" algn="l">
-              <a:lnSpc>
-                <a:spcPct val="110000"/>
-              </a:lnSpc>
-              <a:spcBef>
-                <a:spcPts val="800"/>
-              </a:spcBef>
-              <a:spcAft>
-                <a:spcPts val="800"/>
-              </a:spcAft>
-              <a:buNone/>
-            </a:pPr>
-            <a:r>
-              <a:rPr lang="en-GB" sz="2000">
-                <a:solidFill>
-                  <a:srgbClr val="EAF5E9"/>
-                </a:solidFill>
-                <a:latin typeface="Google Sans Flex"/>
-                <a:ea typeface="Google Sans Flex"/>
-                <a:cs typeface="Google Sans Flex"/>
-                <a:sym typeface="Google Sans Flex"/>
-              </a:rPr>
-              <a:t>Per run: 6 turns / 24 tools / 95 seconds</a:t>
-            </a:r>
-            <a:endParaRPr sz="2000">
-              <a:solidFill>
-                <a:srgbClr val="EAF5E9"/>
-              </a:solidFill>
-              <a:latin typeface="Google Sans Flex"/>
-              <a:ea typeface="Google Sans Flex"/>
-              <a:cs typeface="Google Sans Flex"/>
-              <a:sym typeface="Google Sans Flex"/>
-            </a:endParaRPr>
+            <a:pPr indent="0" lvl="0" marL="0" rtl="0" algn="ctr">
+              <a:spcBef>
+                <a:spcPts val="0"/>
+              </a:spcBef>
+              <a:spcAft>
+                <a:spcPts val="0"/>
+              </a:spcAft>
+              <a:buNone/>
+            </a:pPr>
+            <a:r>
+              <a:t/>
+            </a:r>
+            <a:endParaRPr/>
           </a:p>
         </p:txBody>
       </p:sp>
@@ -13863,8 +14164,8 @@
         </p:nvSpPr>
         <p:spPr>
           <a:xfrm>
-            <a:off x="381000" y="4165600"/>
-            <a:ext cx="8255100" cy="698400"/>
+            <a:off x="571500" y="1168400"/>
+            <a:ext cx="4889400" cy="254100"/>
           </a:xfrm>
           <a:prstGeom prst="rect">
             <a:avLst/>
@@ -13875,14 +14176,14 @@
           </a:ln>
         </p:spPr>
         <p:txBody>
-          <a:bodyPr anchorCtr="0" anchor="t" bIns="91425" lIns="91425" spcFirstLastPara="1" rIns="91425" wrap="square" tIns="91425">
+          <a:bodyPr anchorCtr="0" anchor="ctr" bIns="91425" lIns="91425" spcFirstLastPara="1" rIns="91425" wrap="square" tIns="91425">
             <a:noAutofit/>
           </a:bodyPr>
           <a:lstStyle/>
           <a:p>
             <a:pPr indent="0" lvl="0" marL="0" rtl="0" algn="l">
               <a:lnSpc>
-                <a:spcPct val="105000"/>
+                <a:spcPct val="100000"/>
               </a:lnSpc>
               <a:spcBef>
                 <a:spcPts val="0"/>
@@ -13893,60 +14194,2433 @@
               <a:buNone/>
             </a:pPr>
             <a:r>
-              <a:rPr lang="en-GB" sz="1500">
+              <a:rPr b="1" lang="en-GB" sz="1000">
                 <a:solidFill>
                   <a:srgbClr val="9FB8AD"/>
                 </a:solidFill>
-                <a:latin typeface="Google Sans Flex"/>
-                <a:ea typeface="Google Sans Flex"/>
-                <a:cs typeface="Google Sans Flex"/>
-                <a:sym typeface="Google Sans Flex"/>
               </a:rPr>
-              <a:t>Optional estimate not yet measured. Cloud usage depends on tokens, requests and storage.</a:t>
-            </a:r>
-            <a:endParaRPr sz="1500">
+              <a:t>ONE MEASURED CASE</a:t>
+            </a:r>
+            <a:endParaRPr b="1" sz="1000">
               <a:solidFill>
                 <a:srgbClr val="9FB8AD"/>
               </a:solidFill>
-              <a:latin typeface="Google Sans Flex"/>
-              <a:ea typeface="Google Sans Flex"/>
-              <a:cs typeface="Google Sans Flex"/>
-              <a:sym typeface="Google Sans Flex"/>
             </a:endParaRPr>
           </a:p>
+        </p:txBody>
+      </p:sp>
+      <p:graphicFrame>
+        <p:nvGraphicFramePr>
+          <p:cNvPr id="161" name="Google Shape;161;p21"/>
+          <p:cNvGraphicFramePr/>
+          <p:nvPr/>
+        </p:nvGraphicFramePr>
+        <p:xfrm>
+          <a:off x="635000" y="1485900"/>
+          <a:ext cx="3000000" cy="3000000"/>
+        </p:xfrm>
+        <a:graphic>
+          <a:graphicData uri="http://schemas.openxmlformats.org/drawingml/2006/table">
+            <a:tbl>
+              <a:tblPr>
+                <a:noFill/>
+                <a:tableStyleId>{A81D6702-DE3E-4CE6-B1CF-562C7AAFA617}</a:tableStyleId>
+              </a:tblPr>
+              <a:tblGrid>
+                <a:gridCol w="1917700"/>
+                <a:gridCol w="965200"/>
+                <a:gridCol w="952500"/>
+                <a:gridCol w="914400"/>
+              </a:tblGrid>
+              <a:tr h="304800">
+                <a:tc>
+                  <a:txBody>
+                    <a:bodyPr/>
+                    <a:lstStyle/>
+                    <a:p>
+                      <a:pPr indent="0" lvl="0" marL="0" rtl="0" algn="l">
+                        <a:spcBef>
+                          <a:spcPts val="0"/>
+                        </a:spcBef>
+                        <a:spcAft>
+                          <a:spcPts val="0"/>
+                        </a:spcAft>
+                        <a:buNone/>
+                      </a:pPr>
+                      <a:r>
+                        <a:t/>
+                      </a:r>
+                      <a:endParaRPr/>
+                    </a:p>
+                  </a:txBody>
+                  <a:tcPr marT="91425" marB="91425" marR="91425" marL="91425" anchor="ctr">
+                    <a:lnL cap="flat" cmpd="sng" w="1275">
+                      <a:solidFill>
+                        <a:srgbClr val="0F2B27">
+                          <a:alpha val="0"/>
+                        </a:srgbClr>
+                      </a:solidFill>
+                      <a:prstDash val="solid"/>
+                      <a:round/>
+                      <a:headEnd len="sm" w="sm" type="none"/>
+                      <a:tailEnd len="sm" w="sm" type="none"/>
+                    </a:lnL>
+                    <a:lnR cap="flat" cmpd="sng" w="1275">
+                      <a:solidFill>
+                        <a:srgbClr val="0F2B27">
+                          <a:alpha val="0"/>
+                        </a:srgbClr>
+                      </a:solidFill>
+                      <a:prstDash val="solid"/>
+                      <a:round/>
+                      <a:headEnd len="sm" w="sm" type="none"/>
+                      <a:tailEnd len="sm" w="sm" type="none"/>
+                    </a:lnR>
+                    <a:lnT cap="flat" cmpd="sng" w="1275">
+                      <a:solidFill>
+                        <a:srgbClr val="0F2B27">
+                          <a:alpha val="0"/>
+                        </a:srgbClr>
+                      </a:solidFill>
+                      <a:prstDash val="solid"/>
+                      <a:round/>
+                      <a:headEnd len="sm" w="sm" type="none"/>
+                      <a:tailEnd len="sm" w="sm" type="none"/>
+                    </a:lnT>
+                    <a:lnB cap="flat" cmpd="sng" w="1275">
+                      <a:solidFill>
+                        <a:srgbClr val="0F2B27">
+                          <a:alpha val="0"/>
+                        </a:srgbClr>
+                      </a:solidFill>
+                      <a:prstDash val="solid"/>
+                      <a:round/>
+                      <a:headEnd len="sm" w="sm" type="none"/>
+                      <a:tailEnd len="sm" w="sm" type="none"/>
+                    </a:lnB>
+                    <a:solidFill>
+                      <a:srgbClr val="0F2B27"/>
+                    </a:solidFill>
+                  </a:tcPr>
+                </a:tc>
+                <a:tc>
+                  <a:txBody>
+                    <a:bodyPr/>
+                    <a:lstStyle/>
+                    <a:p>
+                      <a:pPr indent="0" lvl="0" marL="0" rtl="0" algn="r">
+                        <a:spcBef>
+                          <a:spcPts val="0"/>
+                        </a:spcBef>
+                        <a:spcAft>
+                          <a:spcPts val="0"/>
+                        </a:spcAft>
+                        <a:buNone/>
+                      </a:pPr>
+                      <a:r>
+                        <a:rPr b="1" lang="en-GB" sz="1000">
+                          <a:solidFill>
+                            <a:srgbClr val="9FB8AD"/>
+                          </a:solidFill>
+                        </a:rPr>
+                        <a:t>TOKENS</a:t>
+                      </a:r>
+                      <a:endParaRPr b="1" sz="1000">
+                        <a:solidFill>
+                          <a:srgbClr val="9FB8AD"/>
+                        </a:solidFill>
+                      </a:endParaRPr>
+                    </a:p>
+                  </a:txBody>
+                  <a:tcPr marT="91425" marB="91425" marR="91425" marL="91425" anchor="ctr">
+                    <a:lnL cap="flat" cmpd="sng" w="1275">
+                      <a:solidFill>
+                        <a:srgbClr val="0F2B27">
+                          <a:alpha val="0"/>
+                        </a:srgbClr>
+                      </a:solidFill>
+                      <a:prstDash val="solid"/>
+                      <a:round/>
+                      <a:headEnd len="sm" w="sm" type="none"/>
+                      <a:tailEnd len="sm" w="sm" type="none"/>
+                    </a:lnL>
+                    <a:lnR cap="flat" cmpd="sng" w="1275">
+                      <a:solidFill>
+                        <a:srgbClr val="0F2B27">
+                          <a:alpha val="0"/>
+                        </a:srgbClr>
+                      </a:solidFill>
+                      <a:prstDash val="solid"/>
+                      <a:round/>
+                      <a:headEnd len="sm" w="sm" type="none"/>
+                      <a:tailEnd len="sm" w="sm" type="none"/>
+                    </a:lnR>
+                    <a:lnT cap="flat" cmpd="sng" w="1275">
+                      <a:solidFill>
+                        <a:srgbClr val="0F2B27">
+                          <a:alpha val="0"/>
+                        </a:srgbClr>
+                      </a:solidFill>
+                      <a:prstDash val="solid"/>
+                      <a:round/>
+                      <a:headEnd len="sm" w="sm" type="none"/>
+                      <a:tailEnd len="sm" w="sm" type="none"/>
+                    </a:lnT>
+                    <a:lnB cap="flat" cmpd="sng" w="1275">
+                      <a:solidFill>
+                        <a:srgbClr val="0F2B27">
+                          <a:alpha val="0"/>
+                        </a:srgbClr>
+                      </a:solidFill>
+                      <a:prstDash val="solid"/>
+                      <a:round/>
+                      <a:headEnd len="sm" w="sm" type="none"/>
+                      <a:tailEnd len="sm" w="sm" type="none"/>
+                    </a:lnB>
+                    <a:solidFill>
+                      <a:srgbClr val="0F2B27"/>
+                    </a:solidFill>
+                  </a:tcPr>
+                </a:tc>
+                <a:tc>
+                  <a:txBody>
+                    <a:bodyPr/>
+                    <a:lstStyle/>
+                    <a:p>
+                      <a:pPr indent="0" lvl="0" marL="0" rtl="0" algn="r">
+                        <a:spcBef>
+                          <a:spcPts val="0"/>
+                        </a:spcBef>
+                        <a:spcAft>
+                          <a:spcPts val="0"/>
+                        </a:spcAft>
+                        <a:buNone/>
+                      </a:pPr>
+                      <a:r>
+                        <a:rPr b="1" lang="en-GB" sz="1000">
+                          <a:solidFill>
+                            <a:srgbClr val="9FB8AD"/>
+                          </a:solidFill>
+                        </a:rPr>
+                        <a:t>RATE / 1M</a:t>
+                      </a:r>
+                      <a:endParaRPr b="1" sz="1000">
+                        <a:solidFill>
+                          <a:srgbClr val="9FB8AD"/>
+                        </a:solidFill>
+                      </a:endParaRPr>
+                    </a:p>
+                  </a:txBody>
+                  <a:tcPr marT="91425" marB="91425" marR="91425" marL="91425" anchor="ctr">
+                    <a:lnL cap="flat" cmpd="sng" w="1275">
+                      <a:solidFill>
+                        <a:srgbClr val="0F2B27">
+                          <a:alpha val="0"/>
+                        </a:srgbClr>
+                      </a:solidFill>
+                      <a:prstDash val="solid"/>
+                      <a:round/>
+                      <a:headEnd len="sm" w="sm" type="none"/>
+                      <a:tailEnd len="sm" w="sm" type="none"/>
+                    </a:lnL>
+                    <a:lnR cap="flat" cmpd="sng" w="1275">
+                      <a:solidFill>
+                        <a:srgbClr val="0F2B27">
+                          <a:alpha val="0"/>
+                        </a:srgbClr>
+                      </a:solidFill>
+                      <a:prstDash val="solid"/>
+                      <a:round/>
+                      <a:headEnd len="sm" w="sm" type="none"/>
+                      <a:tailEnd len="sm" w="sm" type="none"/>
+                    </a:lnR>
+                    <a:lnT cap="flat" cmpd="sng" w="1275">
+                      <a:solidFill>
+                        <a:srgbClr val="0F2B27">
+                          <a:alpha val="0"/>
+                        </a:srgbClr>
+                      </a:solidFill>
+                      <a:prstDash val="solid"/>
+                      <a:round/>
+                      <a:headEnd len="sm" w="sm" type="none"/>
+                      <a:tailEnd len="sm" w="sm" type="none"/>
+                    </a:lnT>
+                    <a:lnB cap="flat" cmpd="sng" w="1275">
+                      <a:solidFill>
+                        <a:srgbClr val="0F2B27">
+                          <a:alpha val="0"/>
+                        </a:srgbClr>
+                      </a:solidFill>
+                      <a:prstDash val="solid"/>
+                      <a:round/>
+                      <a:headEnd len="sm" w="sm" type="none"/>
+                      <a:tailEnd len="sm" w="sm" type="none"/>
+                    </a:lnB>
+                    <a:solidFill>
+                      <a:srgbClr val="0F2B27"/>
+                    </a:solidFill>
+                  </a:tcPr>
+                </a:tc>
+                <a:tc>
+                  <a:txBody>
+                    <a:bodyPr/>
+                    <a:lstStyle/>
+                    <a:p>
+                      <a:pPr indent="0" lvl="0" marL="0" rtl="0" algn="r">
+                        <a:spcBef>
+                          <a:spcPts val="0"/>
+                        </a:spcBef>
+                        <a:spcAft>
+                          <a:spcPts val="0"/>
+                        </a:spcAft>
+                        <a:buNone/>
+                      </a:pPr>
+                      <a:r>
+                        <a:rPr b="1" lang="en-GB" sz="1000">
+                          <a:solidFill>
+                            <a:srgbClr val="9FB8AD"/>
+                          </a:solidFill>
+                        </a:rPr>
+                        <a:t>COST</a:t>
+                      </a:r>
+                      <a:endParaRPr b="1" sz="1000">
+                        <a:solidFill>
+                          <a:srgbClr val="9FB8AD"/>
+                        </a:solidFill>
+                      </a:endParaRPr>
+                    </a:p>
+                  </a:txBody>
+                  <a:tcPr marT="91425" marB="91425" marR="91425" marL="91425" anchor="ctr">
+                    <a:lnL cap="flat" cmpd="sng" w="1275">
+                      <a:solidFill>
+                        <a:srgbClr val="0F2B27">
+                          <a:alpha val="0"/>
+                        </a:srgbClr>
+                      </a:solidFill>
+                      <a:prstDash val="solid"/>
+                      <a:round/>
+                      <a:headEnd len="sm" w="sm" type="none"/>
+                      <a:tailEnd len="sm" w="sm" type="none"/>
+                    </a:lnL>
+                    <a:lnR cap="flat" cmpd="sng" w="1275">
+                      <a:solidFill>
+                        <a:srgbClr val="0F2B27">
+                          <a:alpha val="0"/>
+                        </a:srgbClr>
+                      </a:solidFill>
+                      <a:prstDash val="solid"/>
+                      <a:round/>
+                      <a:headEnd len="sm" w="sm" type="none"/>
+                      <a:tailEnd len="sm" w="sm" type="none"/>
+                    </a:lnR>
+                    <a:lnT cap="flat" cmpd="sng" w="1275">
+                      <a:solidFill>
+                        <a:srgbClr val="0F2B27">
+                          <a:alpha val="0"/>
+                        </a:srgbClr>
+                      </a:solidFill>
+                      <a:prstDash val="solid"/>
+                      <a:round/>
+                      <a:headEnd len="sm" w="sm" type="none"/>
+                      <a:tailEnd len="sm" w="sm" type="none"/>
+                    </a:lnT>
+                    <a:lnB cap="flat" cmpd="sng" w="1275">
+                      <a:solidFill>
+                        <a:srgbClr val="0F2B27">
+                          <a:alpha val="0"/>
+                        </a:srgbClr>
+                      </a:solidFill>
+                      <a:prstDash val="solid"/>
+                      <a:round/>
+                      <a:headEnd len="sm" w="sm" type="none"/>
+                      <a:tailEnd len="sm" w="sm" type="none"/>
+                    </a:lnB>
+                    <a:solidFill>
+                      <a:srgbClr val="0F2B27"/>
+                    </a:solidFill>
+                  </a:tcPr>
+                </a:tc>
+              </a:tr>
+              <a:tr h="304800">
+                <a:tc>
+                  <a:txBody>
+                    <a:bodyPr/>
+                    <a:lstStyle/>
+                    <a:p>
+                      <a:pPr indent="0" lvl="0" marL="0" rtl="0" algn="l">
+                        <a:spcBef>
+                          <a:spcPts val="0"/>
+                        </a:spcBef>
+                        <a:spcAft>
+                          <a:spcPts val="0"/>
+                        </a:spcAft>
+                        <a:buNone/>
+                      </a:pPr>
+                      <a:r>
+                        <a:rPr lang="en-GB" sz="1200">
+                          <a:solidFill>
+                            <a:srgbClr val="EAF5E9"/>
+                          </a:solidFill>
+                        </a:rPr>
+                        <a:t>Input</a:t>
+                      </a:r>
+                      <a:endParaRPr sz="1200">
+                        <a:solidFill>
+                          <a:srgbClr val="EAF5E9"/>
+                        </a:solidFill>
+                      </a:endParaRPr>
+                    </a:p>
+                  </a:txBody>
+                  <a:tcPr marT="91425" marB="91425" marR="91425" marL="91425" anchor="ctr">
+                    <a:lnL cap="flat" cmpd="sng" w="1275">
+                      <a:solidFill>
+                        <a:srgbClr val="0F2B27">
+                          <a:alpha val="0"/>
+                        </a:srgbClr>
+                      </a:solidFill>
+                      <a:prstDash val="solid"/>
+                      <a:round/>
+                      <a:headEnd len="sm" w="sm" type="none"/>
+                      <a:tailEnd len="sm" w="sm" type="none"/>
+                    </a:lnL>
+                    <a:lnR cap="flat" cmpd="sng" w="1275">
+                      <a:solidFill>
+                        <a:srgbClr val="0F2B27">
+                          <a:alpha val="0"/>
+                        </a:srgbClr>
+                      </a:solidFill>
+                      <a:prstDash val="solid"/>
+                      <a:round/>
+                      <a:headEnd len="sm" w="sm" type="none"/>
+                      <a:tailEnd len="sm" w="sm" type="none"/>
+                    </a:lnR>
+                    <a:lnT cap="flat" cmpd="sng" w="1275">
+                      <a:solidFill>
+                        <a:srgbClr val="0F2B27">
+                          <a:alpha val="0"/>
+                        </a:srgbClr>
+                      </a:solidFill>
+                      <a:prstDash val="solid"/>
+                      <a:round/>
+                      <a:headEnd len="sm" w="sm" type="none"/>
+                      <a:tailEnd len="sm" w="sm" type="none"/>
+                    </a:lnT>
+                    <a:lnB cap="flat" cmpd="sng" w="1275">
+                      <a:solidFill>
+                        <a:srgbClr val="0F2B27">
+                          <a:alpha val="0"/>
+                        </a:srgbClr>
+                      </a:solidFill>
+                      <a:prstDash val="solid"/>
+                      <a:round/>
+                      <a:headEnd len="sm" w="sm" type="none"/>
+                      <a:tailEnd len="sm" w="sm" type="none"/>
+                    </a:lnB>
+                    <a:solidFill>
+                      <a:srgbClr val="0F2B27"/>
+                    </a:solidFill>
+                  </a:tcPr>
+                </a:tc>
+                <a:tc>
+                  <a:txBody>
+                    <a:bodyPr/>
+                    <a:lstStyle/>
+                    <a:p>
+                      <a:pPr indent="0" lvl="0" marL="0" rtl="0" algn="r">
+                        <a:spcBef>
+                          <a:spcPts val="0"/>
+                        </a:spcBef>
+                        <a:spcAft>
+                          <a:spcPts val="0"/>
+                        </a:spcAft>
+                        <a:buNone/>
+                      </a:pPr>
+                      <a:r>
+                        <a:rPr lang="en-GB" sz="1200">
+                          <a:solidFill>
+                            <a:srgbClr val="EAF5E9"/>
+                          </a:solidFill>
+                        </a:rPr>
+                        <a:t>66,308</a:t>
+                      </a:r>
+                      <a:endParaRPr sz="1200">
+                        <a:solidFill>
+                          <a:srgbClr val="EAF5E9"/>
+                        </a:solidFill>
+                      </a:endParaRPr>
+                    </a:p>
+                  </a:txBody>
+                  <a:tcPr marT="91425" marB="91425" marR="91425" marL="91425" anchor="ctr">
+                    <a:lnL cap="flat" cmpd="sng" w="1275">
+                      <a:solidFill>
+                        <a:srgbClr val="0F2B27">
+                          <a:alpha val="0"/>
+                        </a:srgbClr>
+                      </a:solidFill>
+                      <a:prstDash val="solid"/>
+                      <a:round/>
+                      <a:headEnd len="sm" w="sm" type="none"/>
+                      <a:tailEnd len="sm" w="sm" type="none"/>
+                    </a:lnL>
+                    <a:lnR cap="flat" cmpd="sng" w="1275">
+                      <a:solidFill>
+                        <a:srgbClr val="0F2B27">
+                          <a:alpha val="0"/>
+                        </a:srgbClr>
+                      </a:solidFill>
+                      <a:prstDash val="solid"/>
+                      <a:round/>
+                      <a:headEnd len="sm" w="sm" type="none"/>
+                      <a:tailEnd len="sm" w="sm" type="none"/>
+                    </a:lnR>
+                    <a:lnT cap="flat" cmpd="sng" w="1275">
+                      <a:solidFill>
+                        <a:srgbClr val="0F2B27">
+                          <a:alpha val="0"/>
+                        </a:srgbClr>
+                      </a:solidFill>
+                      <a:prstDash val="solid"/>
+                      <a:round/>
+                      <a:headEnd len="sm" w="sm" type="none"/>
+                      <a:tailEnd len="sm" w="sm" type="none"/>
+                    </a:lnT>
+                    <a:lnB cap="flat" cmpd="sng" w="1275">
+                      <a:solidFill>
+                        <a:srgbClr val="0F2B27">
+                          <a:alpha val="0"/>
+                        </a:srgbClr>
+                      </a:solidFill>
+                      <a:prstDash val="solid"/>
+                      <a:round/>
+                      <a:headEnd len="sm" w="sm" type="none"/>
+                      <a:tailEnd len="sm" w="sm" type="none"/>
+                    </a:lnB>
+                    <a:solidFill>
+                      <a:srgbClr val="0F2B27"/>
+                    </a:solidFill>
+                  </a:tcPr>
+                </a:tc>
+                <a:tc>
+                  <a:txBody>
+                    <a:bodyPr/>
+                    <a:lstStyle/>
+                    <a:p>
+                      <a:pPr indent="0" lvl="0" marL="0" rtl="0" algn="r">
+                        <a:spcBef>
+                          <a:spcPts val="0"/>
+                        </a:spcBef>
+                        <a:spcAft>
+                          <a:spcPts val="0"/>
+                        </a:spcAft>
+                        <a:buNone/>
+                      </a:pPr>
+                      <a:r>
+                        <a:rPr lang="en-GB" sz="1200">
+                          <a:solidFill>
+                            <a:srgbClr val="EAF5E9"/>
+                          </a:solidFill>
+                        </a:rPr>
+                        <a:t>$0.30</a:t>
+                      </a:r>
+                      <a:endParaRPr sz="1200">
+                        <a:solidFill>
+                          <a:srgbClr val="EAF5E9"/>
+                        </a:solidFill>
+                      </a:endParaRPr>
+                    </a:p>
+                  </a:txBody>
+                  <a:tcPr marT="91425" marB="91425" marR="91425" marL="91425" anchor="ctr">
+                    <a:lnL cap="flat" cmpd="sng" w="1275">
+                      <a:solidFill>
+                        <a:srgbClr val="0F2B27">
+                          <a:alpha val="0"/>
+                        </a:srgbClr>
+                      </a:solidFill>
+                      <a:prstDash val="solid"/>
+                      <a:round/>
+                      <a:headEnd len="sm" w="sm" type="none"/>
+                      <a:tailEnd len="sm" w="sm" type="none"/>
+                    </a:lnL>
+                    <a:lnR cap="flat" cmpd="sng" w="1275">
+                      <a:solidFill>
+                        <a:srgbClr val="0F2B27">
+                          <a:alpha val="0"/>
+                        </a:srgbClr>
+                      </a:solidFill>
+                      <a:prstDash val="solid"/>
+                      <a:round/>
+                      <a:headEnd len="sm" w="sm" type="none"/>
+                      <a:tailEnd len="sm" w="sm" type="none"/>
+                    </a:lnR>
+                    <a:lnT cap="flat" cmpd="sng" w="1275">
+                      <a:solidFill>
+                        <a:srgbClr val="0F2B27">
+                          <a:alpha val="0"/>
+                        </a:srgbClr>
+                      </a:solidFill>
+                      <a:prstDash val="solid"/>
+                      <a:round/>
+                      <a:headEnd len="sm" w="sm" type="none"/>
+                      <a:tailEnd len="sm" w="sm" type="none"/>
+                    </a:lnT>
+                    <a:lnB cap="flat" cmpd="sng" w="1275">
+                      <a:solidFill>
+                        <a:srgbClr val="0F2B27">
+                          <a:alpha val="0"/>
+                        </a:srgbClr>
+                      </a:solidFill>
+                      <a:prstDash val="solid"/>
+                      <a:round/>
+                      <a:headEnd len="sm" w="sm" type="none"/>
+                      <a:tailEnd len="sm" w="sm" type="none"/>
+                    </a:lnB>
+                    <a:solidFill>
+                      <a:srgbClr val="0F2B27"/>
+                    </a:solidFill>
+                  </a:tcPr>
+                </a:tc>
+                <a:tc>
+                  <a:txBody>
+                    <a:bodyPr/>
+                    <a:lstStyle/>
+                    <a:p>
+                      <a:pPr indent="0" lvl="0" marL="0" rtl="0" algn="r">
+                        <a:spcBef>
+                          <a:spcPts val="0"/>
+                        </a:spcBef>
+                        <a:spcAft>
+                          <a:spcPts val="0"/>
+                        </a:spcAft>
+                        <a:buNone/>
+                      </a:pPr>
+                      <a:r>
+                        <a:rPr lang="en-GB" sz="1200">
+                          <a:solidFill>
+                            <a:srgbClr val="EAF5E9"/>
+                          </a:solidFill>
+                        </a:rPr>
+                        <a:t>$0.0199</a:t>
+                      </a:r>
+                      <a:endParaRPr sz="1200">
+                        <a:solidFill>
+                          <a:srgbClr val="EAF5E9"/>
+                        </a:solidFill>
+                      </a:endParaRPr>
+                    </a:p>
+                  </a:txBody>
+                  <a:tcPr marT="91425" marB="91425" marR="91425" marL="91425" anchor="ctr">
+                    <a:lnL cap="flat" cmpd="sng" w="1275">
+                      <a:solidFill>
+                        <a:srgbClr val="0F2B27">
+                          <a:alpha val="0"/>
+                        </a:srgbClr>
+                      </a:solidFill>
+                      <a:prstDash val="solid"/>
+                      <a:round/>
+                      <a:headEnd len="sm" w="sm" type="none"/>
+                      <a:tailEnd len="sm" w="sm" type="none"/>
+                    </a:lnL>
+                    <a:lnR cap="flat" cmpd="sng" w="1275">
+                      <a:solidFill>
+                        <a:srgbClr val="0F2B27">
+                          <a:alpha val="0"/>
+                        </a:srgbClr>
+                      </a:solidFill>
+                      <a:prstDash val="solid"/>
+                      <a:round/>
+                      <a:headEnd len="sm" w="sm" type="none"/>
+                      <a:tailEnd len="sm" w="sm" type="none"/>
+                    </a:lnR>
+                    <a:lnT cap="flat" cmpd="sng" w="1275">
+                      <a:solidFill>
+                        <a:srgbClr val="0F2B27">
+                          <a:alpha val="0"/>
+                        </a:srgbClr>
+                      </a:solidFill>
+                      <a:prstDash val="solid"/>
+                      <a:round/>
+                      <a:headEnd len="sm" w="sm" type="none"/>
+                      <a:tailEnd len="sm" w="sm" type="none"/>
+                    </a:lnT>
+                    <a:lnB cap="flat" cmpd="sng" w="1275">
+                      <a:solidFill>
+                        <a:srgbClr val="0F2B27">
+                          <a:alpha val="0"/>
+                        </a:srgbClr>
+                      </a:solidFill>
+                      <a:prstDash val="solid"/>
+                      <a:round/>
+                      <a:headEnd len="sm" w="sm" type="none"/>
+                      <a:tailEnd len="sm" w="sm" type="none"/>
+                    </a:lnB>
+                    <a:solidFill>
+                      <a:srgbClr val="0F2B27"/>
+                    </a:solidFill>
+                  </a:tcPr>
+                </a:tc>
+              </a:tr>
+              <a:tr h="304800">
+                <a:tc>
+                  <a:txBody>
+                    <a:bodyPr/>
+                    <a:lstStyle/>
+                    <a:p>
+                      <a:pPr indent="0" lvl="0" marL="0" rtl="0" algn="l">
+                        <a:spcBef>
+                          <a:spcPts val="0"/>
+                        </a:spcBef>
+                        <a:spcAft>
+                          <a:spcPts val="0"/>
+                        </a:spcAft>
+                        <a:buNone/>
+                      </a:pPr>
+                      <a:r>
+                        <a:rPr lang="en-GB" sz="1200">
+                          <a:solidFill>
+                            <a:srgbClr val="EAF5E9"/>
+                          </a:solidFill>
+                        </a:rPr>
+                        <a:t>Output</a:t>
+                      </a:r>
+                      <a:endParaRPr sz="1200">
+                        <a:solidFill>
+                          <a:srgbClr val="EAF5E9"/>
+                        </a:solidFill>
+                      </a:endParaRPr>
+                    </a:p>
+                  </a:txBody>
+                  <a:tcPr marT="91425" marB="91425" marR="91425" marL="91425" anchor="ctr">
+                    <a:lnL cap="flat" cmpd="sng" w="1275">
+                      <a:solidFill>
+                        <a:srgbClr val="0F2B27">
+                          <a:alpha val="0"/>
+                        </a:srgbClr>
+                      </a:solidFill>
+                      <a:prstDash val="solid"/>
+                      <a:round/>
+                      <a:headEnd len="sm" w="sm" type="none"/>
+                      <a:tailEnd len="sm" w="sm" type="none"/>
+                    </a:lnL>
+                    <a:lnR cap="flat" cmpd="sng" w="1275">
+                      <a:solidFill>
+                        <a:srgbClr val="0F2B27">
+                          <a:alpha val="0"/>
+                        </a:srgbClr>
+                      </a:solidFill>
+                      <a:prstDash val="solid"/>
+                      <a:round/>
+                      <a:headEnd len="sm" w="sm" type="none"/>
+                      <a:tailEnd len="sm" w="sm" type="none"/>
+                    </a:lnR>
+                    <a:lnT cap="flat" cmpd="sng" w="1275">
+                      <a:solidFill>
+                        <a:srgbClr val="0F2B27">
+                          <a:alpha val="0"/>
+                        </a:srgbClr>
+                      </a:solidFill>
+                      <a:prstDash val="solid"/>
+                      <a:round/>
+                      <a:headEnd len="sm" w="sm" type="none"/>
+                      <a:tailEnd len="sm" w="sm" type="none"/>
+                    </a:lnT>
+                    <a:lnB cap="flat" cmpd="sng" w="1275">
+                      <a:solidFill>
+                        <a:srgbClr val="0F2B27">
+                          <a:alpha val="0"/>
+                        </a:srgbClr>
+                      </a:solidFill>
+                      <a:prstDash val="solid"/>
+                      <a:round/>
+                      <a:headEnd len="sm" w="sm" type="none"/>
+                      <a:tailEnd len="sm" w="sm" type="none"/>
+                    </a:lnB>
+                    <a:solidFill>
+                      <a:srgbClr val="0F2B27"/>
+                    </a:solidFill>
+                  </a:tcPr>
+                </a:tc>
+                <a:tc>
+                  <a:txBody>
+                    <a:bodyPr/>
+                    <a:lstStyle/>
+                    <a:p>
+                      <a:pPr indent="0" lvl="0" marL="0" rtl="0" algn="r">
+                        <a:spcBef>
+                          <a:spcPts val="0"/>
+                        </a:spcBef>
+                        <a:spcAft>
+                          <a:spcPts val="0"/>
+                        </a:spcAft>
+                        <a:buNone/>
+                      </a:pPr>
+                      <a:r>
+                        <a:rPr lang="en-GB" sz="1200">
+                          <a:solidFill>
+                            <a:srgbClr val="EAF5E9"/>
+                          </a:solidFill>
+                        </a:rPr>
+                        <a:t>3,087</a:t>
+                      </a:r>
+                      <a:endParaRPr sz="1200">
+                        <a:solidFill>
+                          <a:srgbClr val="EAF5E9"/>
+                        </a:solidFill>
+                      </a:endParaRPr>
+                    </a:p>
+                  </a:txBody>
+                  <a:tcPr marT="91425" marB="91425" marR="91425" marL="91425" anchor="ctr">
+                    <a:lnL cap="flat" cmpd="sng" w="1275">
+                      <a:solidFill>
+                        <a:srgbClr val="0F2B27">
+                          <a:alpha val="0"/>
+                        </a:srgbClr>
+                      </a:solidFill>
+                      <a:prstDash val="solid"/>
+                      <a:round/>
+                      <a:headEnd len="sm" w="sm" type="none"/>
+                      <a:tailEnd len="sm" w="sm" type="none"/>
+                    </a:lnL>
+                    <a:lnR cap="flat" cmpd="sng" w="1275">
+                      <a:solidFill>
+                        <a:srgbClr val="0F2B27">
+                          <a:alpha val="0"/>
+                        </a:srgbClr>
+                      </a:solidFill>
+                      <a:prstDash val="solid"/>
+                      <a:round/>
+                      <a:headEnd len="sm" w="sm" type="none"/>
+                      <a:tailEnd len="sm" w="sm" type="none"/>
+                    </a:lnR>
+                    <a:lnT cap="flat" cmpd="sng" w="1275">
+                      <a:solidFill>
+                        <a:srgbClr val="0F2B27">
+                          <a:alpha val="0"/>
+                        </a:srgbClr>
+                      </a:solidFill>
+                      <a:prstDash val="solid"/>
+                      <a:round/>
+                      <a:headEnd len="sm" w="sm" type="none"/>
+                      <a:tailEnd len="sm" w="sm" type="none"/>
+                    </a:lnT>
+                    <a:lnB cap="flat" cmpd="sng" w="1275">
+                      <a:solidFill>
+                        <a:srgbClr val="0F2B27">
+                          <a:alpha val="0"/>
+                        </a:srgbClr>
+                      </a:solidFill>
+                      <a:prstDash val="solid"/>
+                      <a:round/>
+                      <a:headEnd len="sm" w="sm" type="none"/>
+                      <a:tailEnd len="sm" w="sm" type="none"/>
+                    </a:lnB>
+                    <a:solidFill>
+                      <a:srgbClr val="0F2B27"/>
+                    </a:solidFill>
+                  </a:tcPr>
+                </a:tc>
+                <a:tc>
+                  <a:txBody>
+                    <a:bodyPr/>
+                    <a:lstStyle/>
+                    <a:p>
+                      <a:pPr indent="0" lvl="0" marL="0" rtl="0" algn="r">
+                        <a:spcBef>
+                          <a:spcPts val="0"/>
+                        </a:spcBef>
+                        <a:spcAft>
+                          <a:spcPts val="0"/>
+                        </a:spcAft>
+                        <a:buNone/>
+                      </a:pPr>
+                      <a:r>
+                        <a:rPr lang="en-GB" sz="1200">
+                          <a:solidFill>
+                            <a:srgbClr val="EAF5E9"/>
+                          </a:solidFill>
+                        </a:rPr>
+                        <a:t>$2.50</a:t>
+                      </a:r>
+                      <a:endParaRPr sz="1200">
+                        <a:solidFill>
+                          <a:srgbClr val="EAF5E9"/>
+                        </a:solidFill>
+                      </a:endParaRPr>
+                    </a:p>
+                  </a:txBody>
+                  <a:tcPr marT="91425" marB="91425" marR="91425" marL="91425" anchor="ctr">
+                    <a:lnL cap="flat" cmpd="sng" w="1275">
+                      <a:solidFill>
+                        <a:srgbClr val="0F2B27">
+                          <a:alpha val="0"/>
+                        </a:srgbClr>
+                      </a:solidFill>
+                      <a:prstDash val="solid"/>
+                      <a:round/>
+                      <a:headEnd len="sm" w="sm" type="none"/>
+                      <a:tailEnd len="sm" w="sm" type="none"/>
+                    </a:lnL>
+                    <a:lnR cap="flat" cmpd="sng" w="1275">
+                      <a:solidFill>
+                        <a:srgbClr val="0F2B27">
+                          <a:alpha val="0"/>
+                        </a:srgbClr>
+                      </a:solidFill>
+                      <a:prstDash val="solid"/>
+                      <a:round/>
+                      <a:headEnd len="sm" w="sm" type="none"/>
+                      <a:tailEnd len="sm" w="sm" type="none"/>
+                    </a:lnR>
+                    <a:lnT cap="flat" cmpd="sng" w="1275">
+                      <a:solidFill>
+                        <a:srgbClr val="0F2B27">
+                          <a:alpha val="0"/>
+                        </a:srgbClr>
+                      </a:solidFill>
+                      <a:prstDash val="solid"/>
+                      <a:round/>
+                      <a:headEnd len="sm" w="sm" type="none"/>
+                      <a:tailEnd len="sm" w="sm" type="none"/>
+                    </a:lnT>
+                    <a:lnB cap="flat" cmpd="sng" w="1275">
+                      <a:solidFill>
+                        <a:srgbClr val="0F2B27">
+                          <a:alpha val="0"/>
+                        </a:srgbClr>
+                      </a:solidFill>
+                      <a:prstDash val="solid"/>
+                      <a:round/>
+                      <a:headEnd len="sm" w="sm" type="none"/>
+                      <a:tailEnd len="sm" w="sm" type="none"/>
+                    </a:lnB>
+                    <a:solidFill>
+                      <a:srgbClr val="0F2B27"/>
+                    </a:solidFill>
+                  </a:tcPr>
+                </a:tc>
+                <a:tc>
+                  <a:txBody>
+                    <a:bodyPr/>
+                    <a:lstStyle/>
+                    <a:p>
+                      <a:pPr indent="0" lvl="0" marL="0" rtl="0" algn="r">
+                        <a:spcBef>
+                          <a:spcPts val="0"/>
+                        </a:spcBef>
+                        <a:spcAft>
+                          <a:spcPts val="0"/>
+                        </a:spcAft>
+                        <a:buNone/>
+                      </a:pPr>
+                      <a:r>
+                        <a:rPr lang="en-GB" sz="1200">
+                          <a:solidFill>
+                            <a:srgbClr val="EAF5E9"/>
+                          </a:solidFill>
+                        </a:rPr>
+                        <a:t>$0.0077</a:t>
+                      </a:r>
+                      <a:endParaRPr sz="1200">
+                        <a:solidFill>
+                          <a:srgbClr val="EAF5E9"/>
+                        </a:solidFill>
+                      </a:endParaRPr>
+                    </a:p>
+                  </a:txBody>
+                  <a:tcPr marT="91425" marB="91425" marR="91425" marL="91425" anchor="ctr">
+                    <a:lnL cap="flat" cmpd="sng" w="1275">
+                      <a:solidFill>
+                        <a:srgbClr val="0F2B27">
+                          <a:alpha val="0"/>
+                        </a:srgbClr>
+                      </a:solidFill>
+                      <a:prstDash val="solid"/>
+                      <a:round/>
+                      <a:headEnd len="sm" w="sm" type="none"/>
+                      <a:tailEnd len="sm" w="sm" type="none"/>
+                    </a:lnL>
+                    <a:lnR cap="flat" cmpd="sng" w="1275">
+                      <a:solidFill>
+                        <a:srgbClr val="0F2B27">
+                          <a:alpha val="0"/>
+                        </a:srgbClr>
+                      </a:solidFill>
+                      <a:prstDash val="solid"/>
+                      <a:round/>
+                      <a:headEnd len="sm" w="sm" type="none"/>
+                      <a:tailEnd len="sm" w="sm" type="none"/>
+                    </a:lnR>
+                    <a:lnT cap="flat" cmpd="sng" w="1275">
+                      <a:solidFill>
+                        <a:srgbClr val="0F2B27">
+                          <a:alpha val="0"/>
+                        </a:srgbClr>
+                      </a:solidFill>
+                      <a:prstDash val="solid"/>
+                      <a:round/>
+                      <a:headEnd len="sm" w="sm" type="none"/>
+                      <a:tailEnd len="sm" w="sm" type="none"/>
+                    </a:lnT>
+                    <a:lnB cap="flat" cmpd="sng" w="1275">
+                      <a:solidFill>
+                        <a:srgbClr val="0F2B27">
+                          <a:alpha val="0"/>
+                        </a:srgbClr>
+                      </a:solidFill>
+                      <a:prstDash val="solid"/>
+                      <a:round/>
+                      <a:headEnd len="sm" w="sm" type="none"/>
+                      <a:tailEnd len="sm" w="sm" type="none"/>
+                    </a:lnB>
+                    <a:solidFill>
+                      <a:srgbClr val="0F2B27"/>
+                    </a:solidFill>
+                  </a:tcPr>
+                </a:tc>
+              </a:tr>
+              <a:tr h="304800">
+                <a:tc>
+                  <a:txBody>
+                    <a:bodyPr/>
+                    <a:lstStyle/>
+                    <a:p>
+                      <a:pPr indent="0" lvl="0" marL="0" rtl="0" algn="l">
+                        <a:spcBef>
+                          <a:spcPts val="0"/>
+                        </a:spcBef>
+                        <a:spcAft>
+                          <a:spcPts val="0"/>
+                        </a:spcAft>
+                        <a:buNone/>
+                      </a:pPr>
+                      <a:r>
+                        <a:rPr b="1" lang="en-GB" sz="1200">
+                          <a:solidFill>
+                            <a:srgbClr val="A6E4C6"/>
+                          </a:solidFill>
+                        </a:rPr>
+                        <a:t>Total (19 calls)</a:t>
+                      </a:r>
+                      <a:endParaRPr b="1" sz="1200">
+                        <a:solidFill>
+                          <a:srgbClr val="A6E4C6"/>
+                        </a:solidFill>
+                      </a:endParaRPr>
+                    </a:p>
+                  </a:txBody>
+                  <a:tcPr marT="91425" marB="91425" marR="91425" marL="91425" anchor="ctr">
+                    <a:lnL cap="flat" cmpd="sng" w="1275">
+                      <a:solidFill>
+                        <a:srgbClr val="0F2B27">
+                          <a:alpha val="0"/>
+                        </a:srgbClr>
+                      </a:solidFill>
+                      <a:prstDash val="solid"/>
+                      <a:round/>
+                      <a:headEnd len="sm" w="sm" type="none"/>
+                      <a:tailEnd len="sm" w="sm" type="none"/>
+                    </a:lnL>
+                    <a:lnR cap="flat" cmpd="sng" w="1275">
+                      <a:solidFill>
+                        <a:srgbClr val="0F2B27">
+                          <a:alpha val="0"/>
+                        </a:srgbClr>
+                      </a:solidFill>
+                      <a:prstDash val="solid"/>
+                      <a:round/>
+                      <a:headEnd len="sm" w="sm" type="none"/>
+                      <a:tailEnd len="sm" w="sm" type="none"/>
+                    </a:lnR>
+                    <a:lnT cap="flat" cmpd="sng" w="1275">
+                      <a:solidFill>
+                        <a:srgbClr val="0F2B27">
+                          <a:alpha val="0"/>
+                        </a:srgbClr>
+                      </a:solidFill>
+                      <a:prstDash val="solid"/>
+                      <a:round/>
+                      <a:headEnd len="sm" w="sm" type="none"/>
+                      <a:tailEnd len="sm" w="sm" type="none"/>
+                    </a:lnT>
+                    <a:lnB cap="flat" cmpd="sng" w="1275">
+                      <a:solidFill>
+                        <a:srgbClr val="0F2B27">
+                          <a:alpha val="0"/>
+                        </a:srgbClr>
+                      </a:solidFill>
+                      <a:prstDash val="solid"/>
+                      <a:round/>
+                      <a:headEnd len="sm" w="sm" type="none"/>
+                      <a:tailEnd len="sm" w="sm" type="none"/>
+                    </a:lnB>
+                    <a:solidFill>
+                      <a:srgbClr val="0F2B27"/>
+                    </a:solidFill>
+                  </a:tcPr>
+                </a:tc>
+                <a:tc>
+                  <a:txBody>
+                    <a:bodyPr/>
+                    <a:lstStyle/>
+                    <a:p>
+                      <a:pPr indent="0" lvl="0" marL="0" rtl="0" algn="r">
+                        <a:spcBef>
+                          <a:spcPts val="0"/>
+                        </a:spcBef>
+                        <a:spcAft>
+                          <a:spcPts val="0"/>
+                        </a:spcAft>
+                        <a:buNone/>
+                      </a:pPr>
+                      <a:r>
+                        <a:rPr b="1" lang="en-GB" sz="1200">
+                          <a:solidFill>
+                            <a:srgbClr val="A6E4C6"/>
+                          </a:solidFill>
+                        </a:rPr>
+                        <a:t>69,395</a:t>
+                      </a:r>
+                      <a:endParaRPr b="1" sz="1200">
+                        <a:solidFill>
+                          <a:srgbClr val="A6E4C6"/>
+                        </a:solidFill>
+                      </a:endParaRPr>
+                    </a:p>
+                  </a:txBody>
+                  <a:tcPr marT="91425" marB="91425" marR="91425" marL="91425" anchor="ctr">
+                    <a:lnL cap="flat" cmpd="sng" w="1275">
+                      <a:solidFill>
+                        <a:srgbClr val="0F2B27">
+                          <a:alpha val="0"/>
+                        </a:srgbClr>
+                      </a:solidFill>
+                      <a:prstDash val="solid"/>
+                      <a:round/>
+                      <a:headEnd len="sm" w="sm" type="none"/>
+                      <a:tailEnd len="sm" w="sm" type="none"/>
+                    </a:lnL>
+                    <a:lnR cap="flat" cmpd="sng" w="1275">
+                      <a:solidFill>
+                        <a:srgbClr val="0F2B27">
+                          <a:alpha val="0"/>
+                        </a:srgbClr>
+                      </a:solidFill>
+                      <a:prstDash val="solid"/>
+                      <a:round/>
+                      <a:headEnd len="sm" w="sm" type="none"/>
+                      <a:tailEnd len="sm" w="sm" type="none"/>
+                    </a:lnR>
+                    <a:lnT cap="flat" cmpd="sng" w="1275">
+                      <a:solidFill>
+                        <a:srgbClr val="0F2B27">
+                          <a:alpha val="0"/>
+                        </a:srgbClr>
+                      </a:solidFill>
+                      <a:prstDash val="solid"/>
+                      <a:round/>
+                      <a:headEnd len="sm" w="sm" type="none"/>
+                      <a:tailEnd len="sm" w="sm" type="none"/>
+                    </a:lnT>
+                    <a:lnB cap="flat" cmpd="sng" w="1275">
+                      <a:solidFill>
+                        <a:srgbClr val="0F2B27">
+                          <a:alpha val="0"/>
+                        </a:srgbClr>
+                      </a:solidFill>
+                      <a:prstDash val="solid"/>
+                      <a:round/>
+                      <a:headEnd len="sm" w="sm" type="none"/>
+                      <a:tailEnd len="sm" w="sm" type="none"/>
+                    </a:lnB>
+                    <a:solidFill>
+                      <a:srgbClr val="0F2B27"/>
+                    </a:solidFill>
+                  </a:tcPr>
+                </a:tc>
+                <a:tc>
+                  <a:txBody>
+                    <a:bodyPr/>
+                    <a:lstStyle/>
+                    <a:p>
+                      <a:pPr indent="0" lvl="0" marL="0" rtl="0" algn="l">
+                        <a:spcBef>
+                          <a:spcPts val="0"/>
+                        </a:spcBef>
+                        <a:spcAft>
+                          <a:spcPts val="0"/>
+                        </a:spcAft>
+                        <a:buNone/>
+                      </a:pPr>
+                      <a:r>
+                        <a:t/>
+                      </a:r>
+                      <a:endParaRPr/>
+                    </a:p>
+                  </a:txBody>
+                  <a:tcPr marT="91425" marB="91425" marR="91425" marL="91425" anchor="ctr">
+                    <a:lnL cap="flat" cmpd="sng" w="1275">
+                      <a:solidFill>
+                        <a:srgbClr val="0F2B27">
+                          <a:alpha val="0"/>
+                        </a:srgbClr>
+                      </a:solidFill>
+                      <a:prstDash val="solid"/>
+                      <a:round/>
+                      <a:headEnd len="sm" w="sm" type="none"/>
+                      <a:tailEnd len="sm" w="sm" type="none"/>
+                    </a:lnL>
+                    <a:lnR cap="flat" cmpd="sng" w="1275">
+                      <a:solidFill>
+                        <a:srgbClr val="0F2B27">
+                          <a:alpha val="0"/>
+                        </a:srgbClr>
+                      </a:solidFill>
+                      <a:prstDash val="solid"/>
+                      <a:round/>
+                      <a:headEnd len="sm" w="sm" type="none"/>
+                      <a:tailEnd len="sm" w="sm" type="none"/>
+                    </a:lnR>
+                    <a:lnT cap="flat" cmpd="sng" w="1275">
+                      <a:solidFill>
+                        <a:srgbClr val="0F2B27">
+                          <a:alpha val="0"/>
+                        </a:srgbClr>
+                      </a:solidFill>
+                      <a:prstDash val="solid"/>
+                      <a:round/>
+                      <a:headEnd len="sm" w="sm" type="none"/>
+                      <a:tailEnd len="sm" w="sm" type="none"/>
+                    </a:lnT>
+                    <a:lnB cap="flat" cmpd="sng" w="1275">
+                      <a:solidFill>
+                        <a:srgbClr val="0F2B27">
+                          <a:alpha val="0"/>
+                        </a:srgbClr>
+                      </a:solidFill>
+                      <a:prstDash val="solid"/>
+                      <a:round/>
+                      <a:headEnd len="sm" w="sm" type="none"/>
+                      <a:tailEnd len="sm" w="sm" type="none"/>
+                    </a:lnB>
+                    <a:solidFill>
+                      <a:srgbClr val="0F2B27"/>
+                    </a:solidFill>
+                  </a:tcPr>
+                </a:tc>
+                <a:tc>
+                  <a:txBody>
+                    <a:bodyPr/>
+                    <a:lstStyle/>
+                    <a:p>
+                      <a:pPr indent="0" lvl="0" marL="0" rtl="0" algn="r">
+                        <a:spcBef>
+                          <a:spcPts val="0"/>
+                        </a:spcBef>
+                        <a:spcAft>
+                          <a:spcPts val="0"/>
+                        </a:spcAft>
+                        <a:buNone/>
+                      </a:pPr>
+                      <a:r>
+                        <a:rPr b="1" lang="en-GB" sz="1200">
+                          <a:solidFill>
+                            <a:srgbClr val="F4B860"/>
+                          </a:solidFill>
+                        </a:rPr>
+                        <a:t>$0.0276</a:t>
+                      </a:r>
+                      <a:endParaRPr b="1" sz="1200">
+                        <a:solidFill>
+                          <a:srgbClr val="F4B860"/>
+                        </a:solidFill>
+                      </a:endParaRPr>
+                    </a:p>
+                  </a:txBody>
+                  <a:tcPr marT="91425" marB="91425" marR="91425" marL="91425" anchor="ctr">
+                    <a:lnL cap="flat" cmpd="sng" w="1275">
+                      <a:solidFill>
+                        <a:srgbClr val="0F2B27">
+                          <a:alpha val="0"/>
+                        </a:srgbClr>
+                      </a:solidFill>
+                      <a:prstDash val="solid"/>
+                      <a:round/>
+                      <a:headEnd len="sm" w="sm" type="none"/>
+                      <a:tailEnd len="sm" w="sm" type="none"/>
+                    </a:lnL>
+                    <a:lnR cap="flat" cmpd="sng" w="1275">
+                      <a:solidFill>
+                        <a:srgbClr val="0F2B27">
+                          <a:alpha val="0"/>
+                        </a:srgbClr>
+                      </a:solidFill>
+                      <a:prstDash val="solid"/>
+                      <a:round/>
+                      <a:headEnd len="sm" w="sm" type="none"/>
+                      <a:tailEnd len="sm" w="sm" type="none"/>
+                    </a:lnR>
+                    <a:lnT cap="flat" cmpd="sng" w="1275">
+                      <a:solidFill>
+                        <a:srgbClr val="0F2B27">
+                          <a:alpha val="0"/>
+                        </a:srgbClr>
+                      </a:solidFill>
+                      <a:prstDash val="solid"/>
+                      <a:round/>
+                      <a:headEnd len="sm" w="sm" type="none"/>
+                      <a:tailEnd len="sm" w="sm" type="none"/>
+                    </a:lnT>
+                    <a:lnB cap="flat" cmpd="sng" w="1275">
+                      <a:solidFill>
+                        <a:srgbClr val="0F2B27">
+                          <a:alpha val="0"/>
+                        </a:srgbClr>
+                      </a:solidFill>
+                      <a:prstDash val="solid"/>
+                      <a:round/>
+                      <a:headEnd len="sm" w="sm" type="none"/>
+                      <a:tailEnd len="sm" w="sm" type="none"/>
+                    </a:lnB>
+                    <a:solidFill>
+                      <a:srgbClr val="0F2B27"/>
+                    </a:solidFill>
+                  </a:tcPr>
+                </a:tc>
+              </a:tr>
+            </a:tbl>
+          </a:graphicData>
+        </a:graphic>
+      </p:graphicFrame>
+      <p:sp>
+        <p:nvSpPr>
+          <p:cNvPr id="162" name="Google Shape;162;p21"/>
+          <p:cNvSpPr txBox="1"/>
+          <p:nvPr/>
+        </p:nvSpPr>
+        <p:spPr>
+          <a:xfrm>
+            <a:off x="571500" y="2857500"/>
+            <a:ext cx="4889400" cy="317400"/>
+          </a:xfrm>
+          <a:prstGeom prst="rect">
+            <a:avLst/>
+          </a:prstGeom>
+          <a:noFill/>
+          <a:ln>
+            <a:noFill/>
+          </a:ln>
+        </p:spPr>
+        <p:txBody>
+          <a:bodyPr anchorCtr="0" anchor="ctr" bIns="91425" lIns="91425" spcFirstLastPara="1" rIns="91425" wrap="square" tIns="91425">
+            <a:noAutofit/>
+          </a:bodyPr>
+          <a:lstStyle/>
           <a:p>
             <a:pPr indent="0" lvl="0" marL="0" rtl="0" algn="l">
               <a:lnSpc>
-                <a:spcPct val="105000"/>
+                <a:spcPct val="100000"/>
               </a:lnSpc>
               <a:spcBef>
-                <a:spcPts val="400"/>
-              </a:spcBef>
-              <a:spcAft>
-                <a:spcPts val="400"/>
-              </a:spcAft>
-              <a:buNone/>
-            </a:pPr>
-            <a:r>
-              <a:rPr lang="en-GB" sz="1500">
+                <a:spcPts val="0"/>
+              </a:spcBef>
+              <a:spcAft>
+                <a:spcPts val="0"/>
+              </a:spcAft>
+              <a:buNone/>
+            </a:pPr>
+            <a:r>
+              <a:rPr lang="en-GB" sz="900">
                 <a:solidFill>
                   <a:srgbClr val="9FB8AD"/>
                 </a:solidFill>
-                <a:latin typeface="Google Sans Flex"/>
-                <a:ea typeface="Google Sans Flex"/>
-                <a:cs typeface="Google Sans Flex"/>
-                <a:sym typeface="Google Sans Flex"/>
               </a:rPr>
-              <a:t>These controls limit usage; they are not a monetary spending cap.</a:t>
-            </a:r>
-            <a:endParaRPr sz="1500">
+              <a:t>Gemini 3.5 Flash-Lite on Vertex AI</a:t>
+            </a:r>
+            <a:endParaRPr sz="900">
               <a:solidFill>
                 <a:srgbClr val="9FB8AD"/>
               </a:solidFill>
-              <a:latin typeface="Google Sans Flex"/>
-              <a:ea typeface="Google Sans Flex"/>
-              <a:cs typeface="Google Sans Flex"/>
-              <a:sym typeface="Google Sans Flex"/>
+            </a:endParaRPr>
+          </a:p>
+          <a:p>
+            <a:pPr indent="0" lvl="0" marL="0" rtl="0" algn="l">
+              <a:lnSpc>
+                <a:spcPct val="100000"/>
+              </a:lnSpc>
+              <a:spcBef>
+                <a:spcPts val="0"/>
+              </a:spcBef>
+              <a:spcAft>
+                <a:spcPts val="0"/>
+              </a:spcAft>
+              <a:buNone/>
+            </a:pPr>
+            <a:r>
+              <a:rPr lang="en-GB" sz="900">
+                <a:solidFill>
+                  <a:srgbClr val="9FB8AD"/>
+                </a:solidFill>
+              </a:rPr>
+              <a:t>Investigation, scans, reassessment and 3 chat questions</a:t>
+            </a:r>
+            <a:endParaRPr sz="900">
+              <a:solidFill>
+                <a:srgbClr val="9FB8AD"/>
+              </a:solidFill>
+            </a:endParaRPr>
+          </a:p>
+        </p:txBody>
+      </p:sp>
+      <p:sp>
+        <p:nvSpPr>
+          <p:cNvPr id="163" name="Google Shape;163;p21"/>
+          <p:cNvSpPr txBox="1"/>
+          <p:nvPr/>
+        </p:nvSpPr>
+        <p:spPr>
+          <a:xfrm>
+            <a:off x="5829300" y="1231900"/>
+            <a:ext cx="2781300" cy="254100"/>
+          </a:xfrm>
+          <a:prstGeom prst="rect">
+            <a:avLst/>
+          </a:prstGeom>
+          <a:noFill/>
+          <a:ln>
+            <a:noFill/>
+          </a:ln>
+        </p:spPr>
+        <p:txBody>
+          <a:bodyPr anchorCtr="0" anchor="ctr" bIns="91425" lIns="91425" spcFirstLastPara="1" rIns="91425" wrap="square" tIns="91425">
+            <a:noAutofit/>
+          </a:bodyPr>
+          <a:lstStyle/>
+          <a:p>
+            <a:pPr indent="0" lvl="0" marL="0" rtl="0" algn="ctr">
+              <a:lnSpc>
+                <a:spcPct val="100000"/>
+              </a:lnSpc>
+              <a:spcBef>
+                <a:spcPts val="0"/>
+              </a:spcBef>
+              <a:spcAft>
+                <a:spcPts val="0"/>
+              </a:spcAft>
+              <a:buNone/>
+            </a:pPr>
+            <a:r>
+              <a:rPr b="1" lang="en-GB" sz="1100">
+                <a:solidFill>
+                  <a:srgbClr val="091E1B"/>
+                </a:solidFill>
+              </a:rPr>
+              <a:t>AI COST PER CASE</a:t>
+            </a:r>
+            <a:endParaRPr b="1" sz="1100">
+              <a:solidFill>
+                <a:srgbClr val="091E1B"/>
+              </a:solidFill>
+            </a:endParaRPr>
+          </a:p>
+        </p:txBody>
+      </p:sp>
+      <p:sp>
+        <p:nvSpPr>
+          <p:cNvPr id="164" name="Google Shape;164;p21"/>
+          <p:cNvSpPr txBox="1"/>
+          <p:nvPr/>
+        </p:nvSpPr>
+        <p:spPr>
+          <a:xfrm>
+            <a:off x="5829300" y="1625600"/>
+            <a:ext cx="2781300" cy="825600"/>
+          </a:xfrm>
+          <a:prstGeom prst="rect">
+            <a:avLst/>
+          </a:prstGeom>
+          <a:noFill/>
+          <a:ln>
+            <a:noFill/>
+          </a:ln>
+        </p:spPr>
+        <p:txBody>
+          <a:bodyPr anchorCtr="0" anchor="ctr" bIns="91425" lIns="91425" spcFirstLastPara="1" rIns="91425" wrap="square" tIns="91425">
+            <a:noAutofit/>
+          </a:bodyPr>
+          <a:lstStyle/>
+          <a:p>
+            <a:pPr indent="0" lvl="0" marL="0" rtl="0" algn="ctr">
+              <a:lnSpc>
+                <a:spcPct val="100000"/>
+              </a:lnSpc>
+              <a:spcBef>
+                <a:spcPts val="0"/>
+              </a:spcBef>
+              <a:spcAft>
+                <a:spcPts val="0"/>
+              </a:spcAft>
+              <a:buNone/>
+            </a:pPr>
+            <a:r>
+              <a:rPr b="1" lang="en-GB" sz="4400">
+                <a:solidFill>
+                  <a:srgbClr val="091E1B"/>
+                </a:solidFill>
+              </a:rPr>
+              <a:t>≈ $0.03</a:t>
+            </a:r>
+            <a:endParaRPr b="1" sz="4400">
+              <a:solidFill>
+                <a:srgbClr val="091E1B"/>
+              </a:solidFill>
+            </a:endParaRPr>
+          </a:p>
+        </p:txBody>
+      </p:sp>
+      <p:sp>
+        <p:nvSpPr>
+          <p:cNvPr id="165" name="Google Shape;165;p21"/>
+          <p:cNvSpPr txBox="1"/>
+          <p:nvPr/>
+        </p:nvSpPr>
+        <p:spPr>
+          <a:xfrm>
+            <a:off x="5842000" y="2489200"/>
+            <a:ext cx="2755800" cy="469800"/>
+          </a:xfrm>
+          <a:prstGeom prst="rect">
+            <a:avLst/>
+          </a:prstGeom>
+          <a:noFill/>
+          <a:ln>
+            <a:noFill/>
+          </a:ln>
+        </p:spPr>
+        <p:txBody>
+          <a:bodyPr anchorCtr="0" anchor="ctr" bIns="91425" lIns="91425" spcFirstLastPara="1" rIns="91425" wrap="square" tIns="91425">
+            <a:noAutofit/>
+          </a:bodyPr>
+          <a:lstStyle/>
+          <a:p>
+            <a:pPr indent="0" lvl="0" marL="0" rtl="0" algn="ctr">
+              <a:lnSpc>
+                <a:spcPct val="100000"/>
+              </a:lnSpc>
+              <a:spcBef>
+                <a:spcPts val="0"/>
+              </a:spcBef>
+              <a:spcAft>
+                <a:spcPts val="0"/>
+              </a:spcAft>
+              <a:buNone/>
+            </a:pPr>
+            <a:r>
+              <a:rPr lang="en-GB" sz="1200">
+                <a:solidFill>
+                  <a:srgbClr val="091E1B"/>
+                </a:solidFill>
+              </a:rPr>
+              <a:t>AI inference per complete</a:t>
+            </a:r>
+            <a:endParaRPr sz="1200">
+              <a:solidFill>
+                <a:srgbClr val="091E1B"/>
+              </a:solidFill>
+            </a:endParaRPr>
+          </a:p>
+          <a:p>
+            <a:pPr indent="0" lvl="0" marL="0" rtl="0" algn="ctr">
+              <a:lnSpc>
+                <a:spcPct val="100000"/>
+              </a:lnSpc>
+              <a:spcBef>
+                <a:spcPts val="0"/>
+              </a:spcBef>
+              <a:spcAft>
+                <a:spcPts val="0"/>
+              </a:spcAft>
+              <a:buNone/>
+            </a:pPr>
+            <a:r>
+              <a:rPr lang="en-GB" sz="1200">
+                <a:solidFill>
+                  <a:srgbClr val="091E1B"/>
+                </a:solidFill>
+              </a:rPr>
+              <a:t>investigation</a:t>
+            </a:r>
+            <a:endParaRPr sz="1200">
+              <a:solidFill>
+                <a:srgbClr val="091E1B"/>
+              </a:solidFill>
+            </a:endParaRPr>
+          </a:p>
+        </p:txBody>
+      </p:sp>
+      <p:sp>
+        <p:nvSpPr>
+          <p:cNvPr id="166" name="Google Shape;166;p21"/>
+          <p:cNvSpPr txBox="1"/>
+          <p:nvPr/>
+        </p:nvSpPr>
+        <p:spPr>
+          <a:xfrm>
+            <a:off x="457200" y="3352800"/>
+            <a:ext cx="8229600" cy="228600"/>
+          </a:xfrm>
+          <a:prstGeom prst="rect">
+            <a:avLst/>
+          </a:prstGeom>
+          <a:noFill/>
+          <a:ln>
+            <a:noFill/>
+          </a:ln>
+        </p:spPr>
+        <p:txBody>
+          <a:bodyPr anchorCtr="0" anchor="ctr" bIns="91425" lIns="91425" spcFirstLastPara="1" rIns="91425" wrap="square" tIns="91425">
+            <a:noAutofit/>
+          </a:bodyPr>
+          <a:lstStyle/>
+          <a:p>
+            <a:pPr indent="0" lvl="0" marL="0" rtl="0" algn="l">
+              <a:lnSpc>
+                <a:spcPct val="100000"/>
+              </a:lnSpc>
+              <a:spcBef>
+                <a:spcPts val="0"/>
+              </a:spcBef>
+              <a:spcAft>
+                <a:spcPts val="0"/>
+              </a:spcAft>
+              <a:buNone/>
+            </a:pPr>
+            <a:r>
+              <a:rPr b="1" lang="en-GB" sz="1000">
+                <a:solidFill>
+                  <a:srgbClr val="9FB8AD"/>
+                </a:solidFill>
+              </a:rPr>
+              <a:t>MONTHLY COST: GEMINI AND TOTAL CLOUD BUDGET</a:t>
+            </a:r>
+            <a:endParaRPr b="1" sz="1000">
+              <a:solidFill>
+                <a:srgbClr val="9FB8AD"/>
+              </a:solidFill>
+            </a:endParaRPr>
+          </a:p>
+        </p:txBody>
+      </p:sp>
+      <p:sp>
+        <p:nvSpPr>
+          <p:cNvPr id="167" name="Google Shape;167;p21"/>
+          <p:cNvSpPr/>
+          <p:nvPr/>
+        </p:nvSpPr>
+        <p:spPr>
+          <a:xfrm>
+            <a:off x="457200" y="3657600"/>
+            <a:ext cx="1920300" cy="863700"/>
+          </a:xfrm>
+          <a:prstGeom prst="roundRect">
+            <a:avLst>
+              <a:gd fmla="val 16667" name="adj"/>
+            </a:avLst>
+          </a:prstGeom>
+          <a:solidFill>
+            <a:srgbClr val="0F2B27"/>
+          </a:solidFill>
+          <a:ln cap="flat" cmpd="sng" w="12700">
+            <a:solidFill>
+              <a:srgbClr val="1F4A41"/>
+            </a:solidFill>
+            <a:prstDash val="solid"/>
+            <a:round/>
+            <a:headEnd len="sm" w="sm" type="none"/>
+            <a:tailEnd len="sm" w="sm" type="none"/>
+          </a:ln>
+        </p:spPr>
+        <p:txBody>
+          <a:bodyPr anchorCtr="0" anchor="ctr" bIns="91425" lIns="91425" spcFirstLastPara="1" rIns="91425" wrap="square" tIns="91425">
+            <a:noAutofit/>
+          </a:bodyPr>
+          <a:lstStyle/>
+          <a:p>
+            <a:pPr indent="0" lvl="0" marL="0" rtl="0" algn="ctr">
+              <a:spcBef>
+                <a:spcPts val="0"/>
+              </a:spcBef>
+              <a:spcAft>
+                <a:spcPts val="0"/>
+              </a:spcAft>
+              <a:buNone/>
+            </a:pPr>
+            <a:r>
+              <a:t/>
+            </a:r>
+            <a:endParaRPr/>
+          </a:p>
+        </p:txBody>
+      </p:sp>
+      <p:sp>
+        <p:nvSpPr>
+          <p:cNvPr id="168" name="Google Shape;168;p21"/>
+          <p:cNvSpPr txBox="1"/>
+          <p:nvPr/>
+        </p:nvSpPr>
+        <p:spPr>
+          <a:xfrm>
+            <a:off x="495300" y="3695700"/>
+            <a:ext cx="1844100" cy="406500"/>
+          </a:xfrm>
+          <a:prstGeom prst="rect">
+            <a:avLst/>
+          </a:prstGeom>
+          <a:noFill/>
+          <a:ln>
+            <a:noFill/>
+          </a:ln>
+        </p:spPr>
+        <p:txBody>
+          <a:bodyPr anchorCtr="0" anchor="ctr" bIns="91425" lIns="91425" spcFirstLastPara="1" rIns="91425" wrap="square" tIns="91425">
+            <a:noAutofit/>
+          </a:bodyPr>
+          <a:lstStyle/>
+          <a:p>
+            <a:pPr indent="0" lvl="0" marL="0" rtl="0" algn="ctr">
+              <a:lnSpc>
+                <a:spcPct val="100000"/>
+              </a:lnSpc>
+              <a:spcBef>
+                <a:spcPts val="0"/>
+              </a:spcBef>
+              <a:spcAft>
+                <a:spcPts val="0"/>
+              </a:spcAft>
+              <a:buNone/>
+            </a:pPr>
+            <a:r>
+              <a:rPr b="1" lang="en-GB" sz="2200">
+                <a:solidFill>
+                  <a:srgbClr val="F4B860"/>
+                </a:solidFill>
+              </a:rPr>
+              <a:t>$2.76</a:t>
+            </a:r>
+            <a:endParaRPr b="1" sz="2200">
+              <a:solidFill>
+                <a:srgbClr val="F4B860"/>
+              </a:solidFill>
+            </a:endParaRPr>
+          </a:p>
+        </p:txBody>
+      </p:sp>
+      <p:sp>
+        <p:nvSpPr>
+          <p:cNvPr id="169" name="Google Shape;169;p21"/>
+          <p:cNvSpPr txBox="1"/>
+          <p:nvPr/>
+        </p:nvSpPr>
+        <p:spPr>
+          <a:xfrm>
+            <a:off x="495300" y="4102100"/>
+            <a:ext cx="1844100" cy="381000"/>
+          </a:xfrm>
+          <a:prstGeom prst="rect">
+            <a:avLst/>
+          </a:prstGeom>
+          <a:noFill/>
+          <a:ln>
+            <a:noFill/>
+          </a:ln>
+        </p:spPr>
+        <p:txBody>
+          <a:bodyPr anchorCtr="0" anchor="ctr" bIns="91425" lIns="91425" spcFirstLastPara="1" rIns="91425" wrap="square" tIns="91425">
+            <a:noAutofit/>
+          </a:bodyPr>
+          <a:lstStyle/>
+          <a:p>
+            <a:pPr indent="0" lvl="0" marL="0" rtl="0" algn="ctr">
+              <a:lnSpc>
+                <a:spcPct val="100000"/>
+              </a:lnSpc>
+              <a:spcBef>
+                <a:spcPts val="0"/>
+              </a:spcBef>
+              <a:spcAft>
+                <a:spcPts val="0"/>
+              </a:spcAft>
+              <a:buNone/>
+            </a:pPr>
+            <a:r>
+              <a:rPr lang="en-GB" sz="1100">
+                <a:solidFill>
+                  <a:srgbClr val="EAF5E9"/>
+                </a:solidFill>
+              </a:rPr>
+              <a:t>100 cases</a:t>
+            </a:r>
+            <a:endParaRPr sz="1100">
+              <a:solidFill>
+                <a:srgbClr val="EAF5E9"/>
+              </a:solidFill>
+            </a:endParaRPr>
+          </a:p>
+          <a:p>
+            <a:pPr indent="0" lvl="0" marL="0" rtl="0" algn="ctr">
+              <a:lnSpc>
+                <a:spcPct val="100000"/>
+              </a:lnSpc>
+              <a:spcBef>
+                <a:spcPts val="0"/>
+              </a:spcBef>
+              <a:spcAft>
+                <a:spcPts val="0"/>
+              </a:spcAft>
+              <a:buNone/>
+            </a:pPr>
+            <a:r>
+              <a:rPr lang="en-GB" sz="1100">
+                <a:solidFill>
+                  <a:srgbClr val="EAF5E9"/>
+                </a:solidFill>
+              </a:rPr>
+              <a:t>Gemini only</a:t>
+            </a:r>
+            <a:endParaRPr sz="1100">
+              <a:solidFill>
+                <a:srgbClr val="EAF5E9"/>
+              </a:solidFill>
+            </a:endParaRPr>
+          </a:p>
+        </p:txBody>
+      </p:sp>
+      <p:sp>
+        <p:nvSpPr>
+          <p:cNvPr id="170" name="Google Shape;170;p21"/>
+          <p:cNvSpPr/>
+          <p:nvPr/>
+        </p:nvSpPr>
+        <p:spPr>
+          <a:xfrm>
+            <a:off x="2560320" y="3657600"/>
+            <a:ext cx="1920300" cy="863700"/>
+          </a:xfrm>
+          <a:prstGeom prst="roundRect">
+            <a:avLst>
+              <a:gd fmla="val 16667" name="adj"/>
+            </a:avLst>
+          </a:prstGeom>
+          <a:solidFill>
+            <a:srgbClr val="0F2B27"/>
+          </a:solidFill>
+          <a:ln cap="flat" cmpd="sng" w="12700">
+            <a:solidFill>
+              <a:srgbClr val="1F4A41"/>
+            </a:solidFill>
+            <a:prstDash val="solid"/>
+            <a:round/>
+            <a:headEnd len="sm" w="sm" type="none"/>
+            <a:tailEnd len="sm" w="sm" type="none"/>
+          </a:ln>
+        </p:spPr>
+        <p:txBody>
+          <a:bodyPr anchorCtr="0" anchor="ctr" bIns="91425" lIns="91425" spcFirstLastPara="1" rIns="91425" wrap="square" tIns="91425">
+            <a:noAutofit/>
+          </a:bodyPr>
+          <a:lstStyle/>
+          <a:p>
+            <a:pPr indent="0" lvl="0" marL="0" rtl="0" algn="ctr">
+              <a:spcBef>
+                <a:spcPts val="0"/>
+              </a:spcBef>
+              <a:spcAft>
+                <a:spcPts val="0"/>
+              </a:spcAft>
+              <a:buNone/>
+            </a:pPr>
+            <a:r>
+              <a:t/>
+            </a:r>
+            <a:endParaRPr/>
+          </a:p>
+        </p:txBody>
+      </p:sp>
+      <p:sp>
+        <p:nvSpPr>
+          <p:cNvPr id="171" name="Google Shape;171;p21"/>
+          <p:cNvSpPr txBox="1"/>
+          <p:nvPr/>
+        </p:nvSpPr>
+        <p:spPr>
+          <a:xfrm>
+            <a:off x="2598420" y="3695700"/>
+            <a:ext cx="1844100" cy="406500"/>
+          </a:xfrm>
+          <a:prstGeom prst="rect">
+            <a:avLst/>
+          </a:prstGeom>
+          <a:noFill/>
+          <a:ln>
+            <a:noFill/>
+          </a:ln>
+        </p:spPr>
+        <p:txBody>
+          <a:bodyPr anchorCtr="0" anchor="ctr" bIns="91425" lIns="91425" spcFirstLastPara="1" rIns="91425" wrap="square" tIns="91425">
+            <a:noAutofit/>
+          </a:bodyPr>
+          <a:lstStyle/>
+          <a:p>
+            <a:pPr indent="0" lvl="0" marL="0" rtl="0" algn="ctr">
+              <a:lnSpc>
+                <a:spcPct val="100000"/>
+              </a:lnSpc>
+              <a:spcBef>
+                <a:spcPts val="0"/>
+              </a:spcBef>
+              <a:spcAft>
+                <a:spcPts val="0"/>
+              </a:spcAft>
+              <a:buNone/>
+            </a:pPr>
+            <a:r>
+              <a:rPr b="1" lang="en-GB" sz="2200">
+                <a:solidFill>
+                  <a:srgbClr val="F4B860"/>
+                </a:solidFill>
+              </a:rPr>
+              <a:t>$27.61</a:t>
+            </a:r>
+            <a:endParaRPr b="1" sz="2200">
+              <a:solidFill>
+                <a:srgbClr val="F4B860"/>
+              </a:solidFill>
+            </a:endParaRPr>
+          </a:p>
+        </p:txBody>
+      </p:sp>
+      <p:sp>
+        <p:nvSpPr>
+          <p:cNvPr id="172" name="Google Shape;172;p21"/>
+          <p:cNvSpPr txBox="1"/>
+          <p:nvPr/>
+        </p:nvSpPr>
+        <p:spPr>
+          <a:xfrm>
+            <a:off x="2598420" y="4102100"/>
+            <a:ext cx="1844100" cy="381000"/>
+          </a:xfrm>
+          <a:prstGeom prst="rect">
+            <a:avLst/>
+          </a:prstGeom>
+          <a:noFill/>
+          <a:ln>
+            <a:noFill/>
+          </a:ln>
+        </p:spPr>
+        <p:txBody>
+          <a:bodyPr anchorCtr="0" anchor="ctr" bIns="91425" lIns="91425" spcFirstLastPara="1" rIns="91425" wrap="square" tIns="91425">
+            <a:noAutofit/>
+          </a:bodyPr>
+          <a:lstStyle/>
+          <a:p>
+            <a:pPr indent="0" lvl="0" marL="0" rtl="0" algn="ctr">
+              <a:lnSpc>
+                <a:spcPct val="100000"/>
+              </a:lnSpc>
+              <a:spcBef>
+                <a:spcPts val="0"/>
+              </a:spcBef>
+              <a:spcAft>
+                <a:spcPts val="0"/>
+              </a:spcAft>
+              <a:buNone/>
+            </a:pPr>
+            <a:r>
+              <a:rPr lang="en-GB" sz="1100">
+                <a:solidFill>
+                  <a:srgbClr val="EAF5E9"/>
+                </a:solidFill>
+              </a:rPr>
+              <a:t>1,000 cases</a:t>
+            </a:r>
+            <a:endParaRPr sz="1100">
+              <a:solidFill>
+                <a:srgbClr val="EAF5E9"/>
+              </a:solidFill>
+            </a:endParaRPr>
+          </a:p>
+          <a:p>
+            <a:pPr indent="0" lvl="0" marL="0" rtl="0" algn="ctr">
+              <a:lnSpc>
+                <a:spcPct val="100000"/>
+              </a:lnSpc>
+              <a:spcBef>
+                <a:spcPts val="0"/>
+              </a:spcBef>
+              <a:spcAft>
+                <a:spcPts val="0"/>
+              </a:spcAft>
+              <a:buNone/>
+            </a:pPr>
+            <a:r>
+              <a:rPr lang="en-GB" sz="1100">
+                <a:solidFill>
+                  <a:srgbClr val="EAF5E9"/>
+                </a:solidFill>
+              </a:rPr>
+              <a:t>Gemini only</a:t>
+            </a:r>
+            <a:endParaRPr sz="1100">
+              <a:solidFill>
+                <a:srgbClr val="EAF5E9"/>
+              </a:solidFill>
+            </a:endParaRPr>
+          </a:p>
+        </p:txBody>
+      </p:sp>
+      <p:sp>
+        <p:nvSpPr>
+          <p:cNvPr id="173" name="Google Shape;173;p21"/>
+          <p:cNvSpPr/>
+          <p:nvPr/>
+        </p:nvSpPr>
+        <p:spPr>
+          <a:xfrm>
+            <a:off x="4663440" y="3657600"/>
+            <a:ext cx="1920300" cy="863700"/>
+          </a:xfrm>
+          <a:prstGeom prst="roundRect">
+            <a:avLst>
+              <a:gd fmla="val 16667" name="adj"/>
+            </a:avLst>
+          </a:prstGeom>
+          <a:solidFill>
+            <a:srgbClr val="0F2B27"/>
+          </a:solidFill>
+          <a:ln cap="flat" cmpd="sng" w="12700">
+            <a:solidFill>
+              <a:srgbClr val="1F4A41"/>
+            </a:solidFill>
+            <a:prstDash val="solid"/>
+            <a:round/>
+            <a:headEnd len="sm" w="sm" type="none"/>
+            <a:tailEnd len="sm" w="sm" type="none"/>
+          </a:ln>
+        </p:spPr>
+        <p:txBody>
+          <a:bodyPr anchorCtr="0" anchor="ctr" bIns="91425" lIns="91425" spcFirstLastPara="1" rIns="91425" wrap="square" tIns="91425">
+            <a:noAutofit/>
+          </a:bodyPr>
+          <a:lstStyle/>
+          <a:p>
+            <a:pPr indent="0" lvl="0" marL="0" rtl="0" algn="ctr">
+              <a:spcBef>
+                <a:spcPts val="0"/>
+              </a:spcBef>
+              <a:spcAft>
+                <a:spcPts val="0"/>
+              </a:spcAft>
+              <a:buNone/>
+            </a:pPr>
+            <a:r>
+              <a:t/>
+            </a:r>
+            <a:endParaRPr/>
+          </a:p>
+        </p:txBody>
+      </p:sp>
+      <p:sp>
+        <p:nvSpPr>
+          <p:cNvPr id="174" name="Google Shape;174;p21"/>
+          <p:cNvSpPr txBox="1"/>
+          <p:nvPr/>
+        </p:nvSpPr>
+        <p:spPr>
+          <a:xfrm>
+            <a:off x="4701540" y="3695700"/>
+            <a:ext cx="1844100" cy="406500"/>
+          </a:xfrm>
+          <a:prstGeom prst="rect">
+            <a:avLst/>
+          </a:prstGeom>
+          <a:noFill/>
+          <a:ln>
+            <a:noFill/>
+          </a:ln>
+        </p:spPr>
+        <p:txBody>
+          <a:bodyPr anchorCtr="0" anchor="ctr" bIns="91425" lIns="91425" spcFirstLastPara="1" rIns="91425" wrap="square" tIns="91425">
+            <a:noAutofit/>
+          </a:bodyPr>
+          <a:lstStyle/>
+          <a:p>
+            <a:pPr indent="0" lvl="0" marL="0" rtl="0" algn="ctr">
+              <a:lnSpc>
+                <a:spcPct val="100000"/>
+              </a:lnSpc>
+              <a:spcBef>
+                <a:spcPts val="0"/>
+              </a:spcBef>
+              <a:spcAft>
+                <a:spcPts val="0"/>
+              </a:spcAft>
+              <a:buNone/>
+            </a:pPr>
+            <a:r>
+              <a:rPr b="1" lang="en-GB" sz="2200">
+                <a:solidFill>
+                  <a:srgbClr val="F4B860"/>
+                </a:solidFill>
+              </a:rPr>
+              <a:t>$6</a:t>
+            </a:r>
+            <a:endParaRPr b="1" sz="2200">
+              <a:solidFill>
+                <a:srgbClr val="F4B860"/>
+              </a:solidFill>
+            </a:endParaRPr>
+          </a:p>
+        </p:txBody>
+      </p:sp>
+      <p:sp>
+        <p:nvSpPr>
+          <p:cNvPr id="175" name="Google Shape;175;p21"/>
+          <p:cNvSpPr txBox="1"/>
+          <p:nvPr/>
+        </p:nvSpPr>
+        <p:spPr>
+          <a:xfrm>
+            <a:off x="4701540" y="4102100"/>
+            <a:ext cx="1844100" cy="381000"/>
+          </a:xfrm>
+          <a:prstGeom prst="rect">
+            <a:avLst/>
+          </a:prstGeom>
+          <a:noFill/>
+          <a:ln>
+            <a:noFill/>
+          </a:ln>
+        </p:spPr>
+        <p:txBody>
+          <a:bodyPr anchorCtr="0" anchor="ctr" bIns="91425" lIns="91425" spcFirstLastPara="1" rIns="91425" wrap="square" tIns="91425">
+            <a:noAutofit/>
+          </a:bodyPr>
+          <a:lstStyle/>
+          <a:p>
+            <a:pPr indent="0" lvl="0" marL="0" rtl="0" algn="ctr">
+              <a:lnSpc>
+                <a:spcPct val="100000"/>
+              </a:lnSpc>
+              <a:spcBef>
+                <a:spcPts val="0"/>
+              </a:spcBef>
+              <a:spcAft>
+                <a:spcPts val="0"/>
+              </a:spcAft>
+              <a:buNone/>
+            </a:pPr>
+            <a:r>
+              <a:rPr lang="en-GB" sz="1100">
+                <a:solidFill>
+                  <a:srgbClr val="EAF5E9"/>
+                </a:solidFill>
+              </a:rPr>
+              <a:t>100 cases</a:t>
+            </a:r>
+            <a:endParaRPr sz="1100">
+              <a:solidFill>
+                <a:srgbClr val="EAF5E9"/>
+              </a:solidFill>
+            </a:endParaRPr>
+          </a:p>
+          <a:p>
+            <a:pPr indent="0" lvl="0" marL="0" rtl="0" algn="ctr">
+              <a:lnSpc>
+                <a:spcPct val="100000"/>
+              </a:lnSpc>
+              <a:spcBef>
+                <a:spcPts val="0"/>
+              </a:spcBef>
+              <a:spcAft>
+                <a:spcPts val="0"/>
+              </a:spcAft>
+              <a:buNone/>
+            </a:pPr>
+            <a:r>
+              <a:rPr lang="en-GB" sz="1100">
+                <a:solidFill>
+                  <a:srgbClr val="EAF5E9"/>
+                </a:solidFill>
+              </a:rPr>
+              <a:t>Total cloud budget</a:t>
+            </a:r>
+            <a:endParaRPr sz="1100">
+              <a:solidFill>
+                <a:srgbClr val="EAF5E9"/>
+              </a:solidFill>
+            </a:endParaRPr>
+          </a:p>
+        </p:txBody>
+      </p:sp>
+      <p:sp>
+        <p:nvSpPr>
+          <p:cNvPr id="176" name="Google Shape;176;p21"/>
+          <p:cNvSpPr/>
+          <p:nvPr/>
+        </p:nvSpPr>
+        <p:spPr>
+          <a:xfrm>
+            <a:off x="6766560" y="3657600"/>
+            <a:ext cx="1920300" cy="863700"/>
+          </a:xfrm>
+          <a:prstGeom prst="roundRect">
+            <a:avLst>
+              <a:gd fmla="val 16667" name="adj"/>
+            </a:avLst>
+          </a:prstGeom>
+          <a:solidFill>
+            <a:srgbClr val="0F2B27"/>
+          </a:solidFill>
+          <a:ln cap="flat" cmpd="sng" w="12700">
+            <a:solidFill>
+              <a:srgbClr val="1F4A41"/>
+            </a:solidFill>
+            <a:prstDash val="solid"/>
+            <a:round/>
+            <a:headEnd len="sm" w="sm" type="none"/>
+            <a:tailEnd len="sm" w="sm" type="none"/>
+          </a:ln>
+        </p:spPr>
+        <p:txBody>
+          <a:bodyPr anchorCtr="0" anchor="ctr" bIns="91425" lIns="91425" spcFirstLastPara="1" rIns="91425" wrap="square" tIns="91425">
+            <a:noAutofit/>
+          </a:bodyPr>
+          <a:lstStyle/>
+          <a:p>
+            <a:pPr indent="0" lvl="0" marL="0" rtl="0" algn="ctr">
+              <a:spcBef>
+                <a:spcPts val="0"/>
+              </a:spcBef>
+              <a:spcAft>
+                <a:spcPts val="0"/>
+              </a:spcAft>
+              <a:buNone/>
+            </a:pPr>
+            <a:r>
+              <a:t/>
+            </a:r>
+            <a:endParaRPr/>
+          </a:p>
+        </p:txBody>
+      </p:sp>
+      <p:sp>
+        <p:nvSpPr>
+          <p:cNvPr id="177" name="Google Shape;177;p21"/>
+          <p:cNvSpPr txBox="1"/>
+          <p:nvPr/>
+        </p:nvSpPr>
+        <p:spPr>
+          <a:xfrm>
+            <a:off x="6804660" y="3695700"/>
+            <a:ext cx="1844100" cy="406500"/>
+          </a:xfrm>
+          <a:prstGeom prst="rect">
+            <a:avLst/>
+          </a:prstGeom>
+          <a:noFill/>
+          <a:ln>
+            <a:noFill/>
+          </a:ln>
+        </p:spPr>
+        <p:txBody>
+          <a:bodyPr anchorCtr="0" anchor="ctr" bIns="91425" lIns="91425" spcFirstLastPara="1" rIns="91425" wrap="square" tIns="91425">
+            <a:noAutofit/>
+          </a:bodyPr>
+          <a:lstStyle/>
+          <a:p>
+            <a:pPr indent="0" lvl="0" marL="0" rtl="0" algn="ctr">
+              <a:lnSpc>
+                <a:spcPct val="100000"/>
+              </a:lnSpc>
+              <a:spcBef>
+                <a:spcPts val="0"/>
+              </a:spcBef>
+              <a:spcAft>
+                <a:spcPts val="0"/>
+              </a:spcAft>
+              <a:buNone/>
+            </a:pPr>
+            <a:r>
+              <a:rPr b="1" lang="en-GB" sz="2200">
+                <a:solidFill>
+                  <a:srgbClr val="F4B860"/>
+                </a:solidFill>
+              </a:rPr>
+              <a:t>$40</a:t>
+            </a:r>
+            <a:endParaRPr b="1" sz="2200">
+              <a:solidFill>
+                <a:srgbClr val="F4B860"/>
+              </a:solidFill>
+            </a:endParaRPr>
+          </a:p>
+        </p:txBody>
+      </p:sp>
+      <p:sp>
+        <p:nvSpPr>
+          <p:cNvPr id="178" name="Google Shape;178;p21"/>
+          <p:cNvSpPr txBox="1"/>
+          <p:nvPr/>
+        </p:nvSpPr>
+        <p:spPr>
+          <a:xfrm>
+            <a:off x="6804660" y="4102100"/>
+            <a:ext cx="1844100" cy="381000"/>
+          </a:xfrm>
+          <a:prstGeom prst="rect">
+            <a:avLst/>
+          </a:prstGeom>
+          <a:noFill/>
+          <a:ln>
+            <a:noFill/>
+          </a:ln>
+        </p:spPr>
+        <p:txBody>
+          <a:bodyPr anchorCtr="0" anchor="ctr" bIns="91425" lIns="91425" spcFirstLastPara="1" rIns="91425" wrap="square" tIns="91425">
+            <a:noAutofit/>
+          </a:bodyPr>
+          <a:lstStyle/>
+          <a:p>
+            <a:pPr indent="0" lvl="0" marL="0" rtl="0" algn="ctr">
+              <a:lnSpc>
+                <a:spcPct val="100000"/>
+              </a:lnSpc>
+              <a:spcBef>
+                <a:spcPts val="0"/>
+              </a:spcBef>
+              <a:spcAft>
+                <a:spcPts val="0"/>
+              </a:spcAft>
+              <a:buNone/>
+            </a:pPr>
+            <a:r>
+              <a:rPr lang="en-GB" sz="1100">
+                <a:solidFill>
+                  <a:srgbClr val="EAF5E9"/>
+                </a:solidFill>
+              </a:rPr>
+              <a:t>1,000 cases</a:t>
+            </a:r>
+            <a:endParaRPr sz="1100">
+              <a:solidFill>
+                <a:srgbClr val="EAF5E9"/>
+              </a:solidFill>
+            </a:endParaRPr>
+          </a:p>
+          <a:p>
+            <a:pPr indent="0" lvl="0" marL="0" rtl="0" algn="ctr">
+              <a:lnSpc>
+                <a:spcPct val="100000"/>
+              </a:lnSpc>
+              <a:spcBef>
+                <a:spcPts val="0"/>
+              </a:spcBef>
+              <a:spcAft>
+                <a:spcPts val="0"/>
+              </a:spcAft>
+              <a:buNone/>
+            </a:pPr>
+            <a:r>
+              <a:rPr lang="en-GB" sz="1100">
+                <a:solidFill>
+                  <a:srgbClr val="EAF5E9"/>
+                </a:solidFill>
+              </a:rPr>
+              <a:t>Total cloud budget</a:t>
+            </a:r>
+            <a:endParaRPr sz="1100">
+              <a:solidFill>
+                <a:srgbClr val="EAF5E9"/>
+              </a:solidFill>
+            </a:endParaRPr>
+          </a:p>
+        </p:txBody>
+      </p:sp>
+      <p:sp>
+        <p:nvSpPr>
+          <p:cNvPr id="179" name="Google Shape;179;p21"/>
+          <p:cNvSpPr txBox="1"/>
+          <p:nvPr/>
+        </p:nvSpPr>
+        <p:spPr>
+          <a:xfrm>
+            <a:off x="457200" y="4610100"/>
+            <a:ext cx="8229600" cy="406500"/>
+          </a:xfrm>
+          <a:prstGeom prst="rect">
+            <a:avLst/>
+          </a:prstGeom>
+          <a:noFill/>
+          <a:ln>
+            <a:noFill/>
+          </a:ln>
+        </p:spPr>
+        <p:txBody>
+          <a:bodyPr anchorCtr="0" anchor="ctr" bIns="91425" lIns="91425" spcFirstLastPara="1" rIns="91425" wrap="square" tIns="91425">
+            <a:noAutofit/>
+          </a:bodyPr>
+          <a:lstStyle/>
+          <a:p>
+            <a:pPr indent="0" lvl="0" marL="0" rtl="0" algn="l">
+              <a:lnSpc>
+                <a:spcPct val="100000"/>
+              </a:lnSpc>
+              <a:spcBef>
+                <a:spcPts val="0"/>
+              </a:spcBef>
+              <a:spcAft>
+                <a:spcPts val="0"/>
+              </a:spcAft>
+              <a:buNone/>
+            </a:pPr>
+            <a:r>
+              <a:rPr lang="en-GB" sz="900">
+                <a:solidFill>
+                  <a:srgbClr val="9FB8AD"/>
+                </a:solidFill>
+              </a:rPr>
+              <a:t>Measured synthetic case, 18 Oct 2026. USD before credits and taxes. Total cloud budgets include headroom.</a:t>
+            </a:r>
+            <a:endParaRPr sz="900">
+              <a:solidFill>
+                <a:srgbClr val="9FB8AD"/>
+              </a:solidFill>
+            </a:endParaRPr>
+          </a:p>
+          <a:p>
+            <a:pPr indent="0" lvl="0" marL="0" rtl="0" algn="l">
+              <a:lnSpc>
+                <a:spcPct val="100000"/>
+              </a:lnSpc>
+              <a:spcBef>
+                <a:spcPts val="0"/>
+              </a:spcBef>
+              <a:spcAft>
+                <a:spcPts val="0"/>
+              </a:spcAft>
+              <a:buNone/>
+            </a:pPr>
+            <a:r>
+              <a:rPr lang="en-GB" sz="900">
+                <a:solidFill>
+                  <a:srgbClr val="9FB8AD"/>
+                </a:solidFill>
+              </a:rPr>
+              <a:t>Infrastructure is estimated. 1,000 cases/month requires a higher daily model-call limit.</a:t>
+            </a:r>
+            <a:endParaRPr sz="900">
+              <a:solidFill>
+                <a:srgbClr val="9FB8AD"/>
+              </a:solidFill>
             </a:endParaRPr>
           </a:p>
         </p:txBody>
@@ -13960,6 +16634,285 @@
 </file>
 
 <file path=ppt/theme/theme1.xml><?xml version="1.0" encoding="utf-8"?>
+<a:theme xmlns:a="http://schemas.openxmlformats.org/drawingml/2006/main" xmlns:r="http://schemas.openxmlformats.org/officeDocument/2006/relationships" name="Simple Light">
+  <a:themeElements>
+    <a:clrScheme name="Simple Light">
+      <a:dk1>
+        <a:srgbClr val="000000"/>
+      </a:dk1>
+      <a:lt1>
+        <a:srgbClr val="FFFFFF"/>
+      </a:lt1>
+      <a:dk2>
+        <a:srgbClr val="595959"/>
+      </a:dk2>
+      <a:lt2>
+        <a:srgbClr val="EEEEEE"/>
+      </a:lt2>
+      <a:accent1>
+        <a:srgbClr val="4285F4"/>
+      </a:accent1>
+      <a:accent2>
+        <a:srgbClr val="212121"/>
+      </a:accent2>
+      <a:accent3>
+        <a:srgbClr val="78909C"/>
+      </a:accent3>
+      <a:accent4>
+        <a:srgbClr val="FFAB40"/>
+      </a:accent4>
+      <a:accent5>
+        <a:srgbClr val="0097A7"/>
+      </a:accent5>
+      <a:accent6>
+        <a:srgbClr val="EEFF41"/>
+      </a:accent6>
+      <a:hlink>
+        <a:srgbClr val="0097A7"/>
+      </a:hlink>
+      <a:folHlink>
+        <a:srgbClr val="0097A7"/>
+      </a:folHlink>
+    </a:clrScheme>
+    <a:fontScheme name="Office">
+      <a:majorFont>
+        <a:latin typeface="Arial"/>
+        <a:ea typeface=""/>
+        <a:cs typeface=""/>
+        <a:font script="Jpan" typeface="ＭＳ Ｐゴシック"/>
+        <a:font script="Hang" typeface="맑은 고딕"/>
+        <a:font script="Hans" typeface="宋体"/>
+        <a:font script="Hant" typeface="新細明體"/>
+        <a:font script="Arab" typeface="Times New Roman"/>
+        <a:font script="Hebr" typeface="Times New Roman"/>
+        <a:font script="Thai" typeface="Angsana New"/>
+        <a:font script="Ethi" typeface="Nyala"/>
+        <a:font script="Beng" typeface="Vrinda"/>
+        <a:font script="Gujr" typeface="Shruti"/>
+        <a:font script="Khmr" typeface="MoolBoran"/>
+        <a:font script="Knda" typeface="Tunga"/>
+        <a:font script="Guru" typeface="Raavi"/>
+        <a:font script="Cans" typeface="Euphemia"/>
+        <a:font script="Cher" typeface="Plantagenet Cherokee"/>
+        <a:font script="Yiii" typeface="Microsoft Yi Baiti"/>
+        <a:font script="Tibt" typeface="Microsoft Himalaya"/>
+        <a:font script="Thaa" typeface="MV Boli"/>
+        <a:font script="Deva" typeface="Mangal"/>
+        <a:font script="Telu" typeface="Gautami"/>
+        <a:font script="Taml" typeface="Latha"/>
+        <a:font script="Syrc" typeface="Estrangelo Edessa"/>
+        <a:font script="Orya" typeface="Kalinga"/>
+        <a:font script="Mlym" typeface="Kartika"/>
+        <a:font script="Laoo" typeface="DokChampa"/>
+        <a:font script="Sinh" typeface="Iskoola Pota"/>
+        <a:font script="Mong" typeface="Mongolian Baiti"/>
+        <a:font script="Viet" typeface="Times New Roman"/>
+        <a:font script="Uigh" typeface="Microsoft Uighur"/>
+        <a:font script="Geor" typeface="Sylfaen"/>
+      </a:majorFont>
+      <a:minorFont>
+        <a:latin typeface="Arial"/>
+        <a:ea typeface=""/>
+        <a:cs typeface=""/>
+        <a:font script="Jpan" typeface="ＭＳ Ｐゴシック"/>
+        <a:font script="Hang" typeface="맑은 고딕"/>
+        <a:font script="Hans" typeface="宋体"/>
+        <a:font script="Hant" typeface="新細明體"/>
+        <a:font script="Arab" typeface="Arial"/>
+        <a:font script="Hebr" typeface="Arial"/>
+        <a:font script="Thai" typeface="Cordia New"/>
+        <a:font script="Ethi" typeface="Nyala"/>
+        <a:font script="Beng" typeface="Vrinda"/>
+        <a:font script="Gujr" typeface="Shruti"/>
+        <a:font script="Khmr" typeface="DaunPenh"/>
+        <a:font script="Knda" typeface="Tunga"/>
+        <a:font script="Guru" typeface="Raavi"/>
+        <a:font script="Cans" typeface="Euphemia"/>
+        <a:font script="Cher" typeface="Plantagenet Cherokee"/>
+        <a:font script="Yiii" typeface="Microsoft Yi Baiti"/>
+        <a:font script="Tibt" typeface="Microsoft Himalaya"/>
+        <a:font script="Thaa" typeface="MV Boli"/>
+        <a:font script="Deva" typeface="Mangal"/>
+        <a:font script="Telu" typeface="Gautami"/>
+        <a:font script="Taml" typeface="Latha"/>
+        <a:font script="Syrc" typeface="Estrangelo Edessa"/>
+        <a:font script="Orya" typeface="Kalinga"/>
+        <a:font script="Mlym" typeface="Kartika"/>
+        <a:font script="Laoo" typeface="DokChampa"/>
+        <a:font script="Sinh" typeface="Iskoola Pota"/>
+        <a:font script="Mong" typeface="Mongolian Baiti"/>
+        <a:font script="Viet" typeface="Arial"/>
+        <a:font script="Uigh" typeface="Microsoft Uighur"/>
+        <a:font script="Geor" typeface="Sylfaen"/>
+      </a:minorFont>
+    </a:fontScheme>
+    <a:fmtScheme name="Office">
+      <a:fillStyleLst>
+        <a:solidFill>
+          <a:schemeClr val="phClr"/>
+        </a:solidFill>
+        <a:gradFill rotWithShape="1">
+          <a:gsLst>
+            <a:gs pos="0">
+              <a:schemeClr val="phClr">
+                <a:tint val="50000"/>
+                <a:satMod val="300000"/>
+              </a:schemeClr>
+            </a:gs>
+            <a:gs pos="35000">
+              <a:schemeClr val="phClr">
+                <a:tint val="37000"/>
+                <a:satMod val="300000"/>
+              </a:schemeClr>
+            </a:gs>
+            <a:gs pos="100000">
+              <a:schemeClr val="phClr">
+                <a:tint val="15000"/>
+                <a:satMod val="350000"/>
+              </a:schemeClr>
+            </a:gs>
+          </a:gsLst>
+          <a:lin ang="16200000" scaled="1"/>
+        </a:gradFill>
+        <a:gradFill rotWithShape="1">
+          <a:gsLst>
+            <a:gs pos="0">
+              <a:schemeClr val="phClr">
+                <a:tint val="100000"/>
+                <a:shade val="100000"/>
+                <a:satMod val="130000"/>
+              </a:schemeClr>
+            </a:gs>
+            <a:gs pos="100000">
+              <a:schemeClr val="phClr">
+                <a:tint val="50000"/>
+                <a:shade val="100000"/>
+                <a:satMod val="350000"/>
+              </a:schemeClr>
+            </a:gs>
+          </a:gsLst>
+          <a:lin ang="16200000" scaled="0"/>
+        </a:gradFill>
+      </a:fillStyleLst>
+      <a:lnStyleLst>
+        <a:ln w="9525" cap="flat" cmpd="sng" algn="ctr">
+          <a:solidFill>
+            <a:schemeClr val="phClr">
+              <a:shade val="95000"/>
+              <a:satMod val="105000"/>
+            </a:schemeClr>
+          </a:solidFill>
+          <a:prstDash val="solid"/>
+        </a:ln>
+        <a:ln w="25400" cap="flat" cmpd="sng" algn="ctr">
+          <a:solidFill>
+            <a:schemeClr val="phClr"/>
+          </a:solidFill>
+          <a:prstDash val="solid"/>
+        </a:ln>
+        <a:ln w="38100" cap="flat" cmpd="sng" algn="ctr">
+          <a:solidFill>
+            <a:schemeClr val="phClr"/>
+          </a:solidFill>
+          <a:prstDash val="solid"/>
+        </a:ln>
+      </a:lnStyleLst>
+      <a:effectStyleLst>
+        <a:effectStyle>
+          <a:effectLst>
+            <a:outerShdw blurRad="40000" dist="20000" dir="5400000" rotWithShape="0">
+              <a:srgbClr val="000000">
+                <a:alpha val="38000"/>
+              </a:srgbClr>
+            </a:outerShdw>
+          </a:effectLst>
+        </a:effectStyle>
+        <a:effectStyle>
+          <a:effectLst>
+            <a:outerShdw blurRad="40000" dist="23000" dir="5400000" rotWithShape="0">
+              <a:srgbClr val="000000">
+                <a:alpha val="35000"/>
+              </a:srgbClr>
+            </a:outerShdw>
+          </a:effectLst>
+        </a:effectStyle>
+        <a:effectStyle>
+          <a:effectLst>
+            <a:outerShdw blurRad="40000" dist="23000" dir="5400000" rotWithShape="0">
+              <a:srgbClr val="000000">
+                <a:alpha val="35000"/>
+              </a:srgbClr>
+            </a:outerShdw>
+          </a:effectLst>
+          <a:scene3d>
+            <a:camera prst="orthographicFront">
+              <a:rot lat="0" lon="0" rev="0"/>
+            </a:camera>
+            <a:lightRig rig="threePt" dir="t">
+              <a:rot lat="0" lon="0" rev="1200000"/>
+            </a:lightRig>
+          </a:scene3d>
+          <a:sp3d>
+            <a:bevelT w="63500" h="25400"/>
+          </a:sp3d>
+        </a:effectStyle>
+      </a:effectStyleLst>
+      <a:bgFillStyleLst>
+        <a:solidFill>
+          <a:schemeClr val="phClr"/>
+        </a:solidFill>
+        <a:gradFill rotWithShape="1">
+          <a:gsLst>
+            <a:gs pos="0">
+              <a:schemeClr val="phClr">
+                <a:tint val="40000"/>
+                <a:satMod val="350000"/>
+              </a:schemeClr>
+            </a:gs>
+            <a:gs pos="40000">
+              <a:schemeClr val="phClr">
+                <a:tint val="45000"/>
+                <a:shade val="99000"/>
+                <a:satMod val="350000"/>
+              </a:schemeClr>
+            </a:gs>
+            <a:gs pos="100000">
+              <a:schemeClr val="phClr">
+                <a:shade val="20000"/>
+                <a:satMod val="255000"/>
+              </a:schemeClr>
+            </a:gs>
+          </a:gsLst>
+          <a:path path="circle">
+            <a:fillToRect l="50000" t="-80000" r="50000" b="180000"/>
+          </a:path>
+        </a:gradFill>
+        <a:gradFill rotWithShape="1">
+          <a:gsLst>
+            <a:gs pos="0">
+              <a:schemeClr val="phClr">
+                <a:tint val="80000"/>
+                <a:satMod val="300000"/>
+              </a:schemeClr>
+            </a:gs>
+            <a:gs pos="100000">
+              <a:schemeClr val="phClr">
+                <a:shade val="30000"/>
+                <a:satMod val="200000"/>
+              </a:schemeClr>
+            </a:gs>
+          </a:gsLst>
+          <a:path path="circle">
+            <a:fillToRect l="50000" t="50000" r="50000" b="50000"/>
+          </a:path>
+        </a:gradFill>
+      </a:bgFillStyleLst>
+    </a:fmtScheme>
+  </a:themeElements>
+</a:theme>
+</file>
+
+<file path=ppt/theme/theme2.xml><?xml version="1.0" encoding="utf-8"?>
 <a:theme xmlns:a="http://schemas.openxmlformats.org/drawingml/2006/main" xmlns:r="http://schemas.openxmlformats.org/officeDocument/2006/relationships">
   <a:themeElements>
     <a:clrScheme name="Default">
@@ -14236,283 +17189,4 @@
     </a:fmtScheme>
   </a:themeElements>
 </a:theme>
-</file>
-
-<file path=ppt/theme/theme2.xml><?xml version="1.0" encoding="utf-8"?>
-<a:theme xmlns:a="http://schemas.openxmlformats.org/drawingml/2006/main" xmlns:r="http://schemas.openxmlformats.org/officeDocument/2006/relationships" name="Simple Light">
-  <a:themeElements>
-    <a:clrScheme name="Simple Light">
-      <a:dk1>
-        <a:srgbClr val="000000"/>
-      </a:dk1>
-      <a:lt1>
-        <a:srgbClr val="FFFFFF"/>
-      </a:lt1>
-      <a:dk2>
-        <a:srgbClr val="595959"/>
-      </a:dk2>
-      <a:lt2>
-        <a:srgbClr val="EEEEEE"/>
-      </a:lt2>
-      <a:accent1>
-        <a:srgbClr val="4285F4"/>
-      </a:accent1>
-      <a:accent2>
-        <a:srgbClr val="212121"/>
-      </a:accent2>
-      <a:accent3>
-        <a:srgbClr val="78909C"/>
-      </a:accent3>
-      <a:accent4>
-        <a:srgbClr val="FFAB40"/>
-      </a:accent4>
-      <a:accent5>
-        <a:srgbClr val="0097A7"/>
-      </a:accent5>
-      <a:accent6>
-        <a:srgbClr val="EEFF41"/>
-      </a:accent6>
-      <a:hlink>
-        <a:srgbClr val="0097A7"/>
-      </a:hlink>
-      <a:folHlink>
-        <a:srgbClr val="0097A7"/>
-      </a:folHlink>
-    </a:clrScheme>
-    <a:fontScheme name="Office">
-      <a:majorFont>
-        <a:latin typeface="Arial"/>
-        <a:ea typeface=""/>
-        <a:cs typeface=""/>
-        <a:font script="Jpan" typeface="ＭＳ Ｐゴシック"/>
-        <a:font script="Hang" typeface="맑은 고딕"/>
-        <a:font script="Hans" typeface="宋体"/>
-        <a:font script="Hant" typeface="新細明體"/>
-        <a:font script="Arab" typeface="Times New Roman"/>
-        <a:font script="Hebr" typeface="Times New Roman"/>
-        <a:font script="Thai" typeface="Angsana New"/>
-        <a:font script="Ethi" typeface="Nyala"/>
-        <a:font script="Beng" typeface="Vrinda"/>
-        <a:font script="Gujr" typeface="Shruti"/>
-        <a:font script="Khmr" typeface="MoolBoran"/>
-        <a:font script="Knda" typeface="Tunga"/>
-        <a:font script="Guru" typeface="Raavi"/>
-        <a:font script="Cans" typeface="Euphemia"/>
-        <a:font script="Cher" typeface="Plantagenet Cherokee"/>
-        <a:font script="Yiii" typeface="Microsoft Yi Baiti"/>
-        <a:font script="Tibt" typeface="Microsoft Himalaya"/>
-        <a:font script="Thaa" typeface="MV Boli"/>
-        <a:font script="Deva" typeface="Mangal"/>
-        <a:font script="Telu" typeface="Gautami"/>
-        <a:font script="Taml" typeface="Latha"/>
-        <a:font script="Syrc" typeface="Estrangelo Edessa"/>
-        <a:font script="Orya" typeface="Kalinga"/>
-        <a:font script="Mlym" typeface="Kartika"/>
-        <a:font script="Laoo" typeface="DokChampa"/>
-        <a:font script="Sinh" typeface="Iskoola Pota"/>
-        <a:font script="Mong" typeface="Mongolian Baiti"/>
-        <a:font script="Viet" typeface="Times New Roman"/>
-        <a:font script="Uigh" typeface="Microsoft Uighur"/>
-        <a:font script="Geor" typeface="Sylfaen"/>
-      </a:majorFont>
-      <a:minorFont>
-        <a:latin typeface="Arial"/>
-        <a:ea typeface=""/>
-        <a:cs typeface=""/>
-        <a:font script="Jpan" typeface="ＭＳ Ｐゴシック"/>
-        <a:font script="Hang" typeface="맑은 고딕"/>
-        <a:font script="Hans" typeface="宋体"/>
-        <a:font script="Hant" typeface="新細明體"/>
-        <a:font script="Arab" typeface="Arial"/>
-        <a:font script="Hebr" typeface="Arial"/>
-        <a:font script="Thai" typeface="Cordia New"/>
-        <a:font script="Ethi" typeface="Nyala"/>
-        <a:font script="Beng" typeface="Vrinda"/>
-        <a:font script="Gujr" typeface="Shruti"/>
-        <a:font script="Khmr" typeface="DaunPenh"/>
-        <a:font script="Knda" typeface="Tunga"/>
-        <a:font script="Guru" typeface="Raavi"/>
-        <a:font script="Cans" typeface="Euphemia"/>
-        <a:font script="Cher" typeface="Plantagenet Cherokee"/>
-        <a:font script="Yiii" typeface="Microsoft Yi Baiti"/>
-        <a:font script="Tibt" typeface="Microsoft Himalaya"/>
-        <a:font script="Thaa" typeface="MV Boli"/>
-        <a:font script="Deva" typeface="Mangal"/>
-        <a:font script="Telu" typeface="Gautami"/>
-        <a:font script="Taml" typeface="Latha"/>
-        <a:font script="Syrc" typeface="Estrangelo Edessa"/>
-        <a:font script="Orya" typeface="Kalinga"/>
-        <a:font script="Mlym" typeface="Kartika"/>
-        <a:font script="Laoo" typeface="DokChampa"/>
-        <a:font script="Sinh" typeface="Iskoola Pota"/>
-        <a:font script="Mong" typeface="Mongolian Baiti"/>
-        <a:font script="Viet" typeface="Arial"/>
-        <a:font script="Uigh" typeface="Microsoft Uighur"/>
-        <a:font script="Geor" typeface="Sylfaen"/>
-      </a:minorFont>
-    </a:fontScheme>
-    <a:fmtScheme name="Office">
-      <a:fillStyleLst>
-        <a:solidFill>
-          <a:schemeClr val="phClr"/>
-        </a:solidFill>
-        <a:gradFill rotWithShape="1">
-          <a:gsLst>
-            <a:gs pos="0">
-              <a:schemeClr val="phClr">
-                <a:tint val="50000"/>
-                <a:satMod val="300000"/>
-              </a:schemeClr>
-            </a:gs>
-            <a:gs pos="35000">
-              <a:schemeClr val="phClr">
-                <a:tint val="37000"/>
-                <a:satMod val="300000"/>
-              </a:schemeClr>
-            </a:gs>
-            <a:gs pos="100000">
-              <a:schemeClr val="phClr">
-                <a:tint val="15000"/>
-                <a:satMod val="350000"/>
-              </a:schemeClr>
-            </a:gs>
-          </a:gsLst>
-          <a:lin ang="16200000" scaled="1"/>
-        </a:gradFill>
-        <a:gradFill rotWithShape="1">
-          <a:gsLst>
-            <a:gs pos="0">
-              <a:schemeClr val="phClr">
-                <a:tint val="100000"/>
-                <a:shade val="100000"/>
-                <a:satMod val="130000"/>
-              </a:schemeClr>
-            </a:gs>
-            <a:gs pos="100000">
-              <a:schemeClr val="phClr">
-                <a:tint val="50000"/>
-                <a:shade val="100000"/>
-                <a:satMod val="350000"/>
-              </a:schemeClr>
-            </a:gs>
-          </a:gsLst>
-          <a:lin ang="16200000" scaled="0"/>
-        </a:gradFill>
-      </a:fillStyleLst>
-      <a:lnStyleLst>
-        <a:ln w="9525" cap="flat" cmpd="sng" algn="ctr">
-          <a:solidFill>
-            <a:schemeClr val="phClr">
-              <a:shade val="95000"/>
-              <a:satMod val="105000"/>
-            </a:schemeClr>
-          </a:solidFill>
-          <a:prstDash val="solid"/>
-        </a:ln>
-        <a:ln w="25400" cap="flat" cmpd="sng" algn="ctr">
-          <a:solidFill>
-            <a:schemeClr val="phClr"/>
-          </a:solidFill>
-          <a:prstDash val="solid"/>
-        </a:ln>
-        <a:ln w="38100" cap="flat" cmpd="sng" algn="ctr">
-          <a:solidFill>
-            <a:schemeClr val="phClr"/>
-          </a:solidFill>
-          <a:prstDash val="solid"/>
-        </a:ln>
-      </a:lnStyleLst>
-      <a:effectStyleLst>
-        <a:effectStyle>
-          <a:effectLst>
-            <a:outerShdw blurRad="40000" dist="20000" dir="5400000" rotWithShape="0">
-              <a:srgbClr val="000000">
-                <a:alpha val="38000"/>
-              </a:srgbClr>
-            </a:outerShdw>
-          </a:effectLst>
-        </a:effectStyle>
-        <a:effectStyle>
-          <a:effectLst>
-            <a:outerShdw blurRad="40000" dist="23000" dir="5400000" rotWithShape="0">
-              <a:srgbClr val="000000">
-                <a:alpha val="35000"/>
-              </a:srgbClr>
-            </a:outerShdw>
-          </a:effectLst>
-        </a:effectStyle>
-        <a:effectStyle>
-          <a:effectLst>
-            <a:outerShdw blurRad="40000" dist="23000" dir="5400000" rotWithShape="0">
-              <a:srgbClr val="000000">
-                <a:alpha val="35000"/>
-              </a:srgbClr>
-            </a:outerShdw>
-          </a:effectLst>
-          <a:scene3d>
-            <a:camera prst="orthographicFront">
-              <a:rot lat="0" lon="0" rev="0"/>
-            </a:camera>
-            <a:lightRig rig="threePt" dir="t">
-              <a:rot lat="0" lon="0" rev="1200000"/>
-            </a:lightRig>
-          </a:scene3d>
-          <a:sp3d>
-            <a:bevelT w="63500" h="25400"/>
-          </a:sp3d>
-        </a:effectStyle>
-      </a:effectStyleLst>
-      <a:bgFillStyleLst>
-        <a:solidFill>
-          <a:schemeClr val="phClr"/>
-        </a:solidFill>
-        <a:gradFill rotWithShape="1">
-          <a:gsLst>
-            <a:gs pos="0">
-              <a:schemeClr val="phClr">
-                <a:tint val="40000"/>
-                <a:satMod val="350000"/>
-              </a:schemeClr>
-            </a:gs>
-            <a:gs pos="40000">
-              <a:schemeClr val="phClr">
-                <a:tint val="45000"/>
-                <a:shade val="99000"/>
-                <a:satMod val="350000"/>
-              </a:schemeClr>
-            </a:gs>
-            <a:gs pos="100000">
-              <a:schemeClr val="phClr">
-                <a:shade val="20000"/>
-                <a:satMod val="255000"/>
-              </a:schemeClr>
-            </a:gs>
-          </a:gsLst>
-          <a:path path="circle">
-            <a:fillToRect l="50000" t="-80000" r="50000" b="180000"/>
-          </a:path>
-        </a:gradFill>
-        <a:gradFill rotWithShape="1">
-          <a:gsLst>
-            <a:gs pos="0">
-              <a:schemeClr val="phClr">
-                <a:tint val="80000"/>
-                <a:satMod val="300000"/>
-              </a:schemeClr>
-            </a:gs>
-            <a:gs pos="100000">
-              <a:schemeClr val="phClr">
-                <a:shade val="30000"/>
-                <a:satMod val="200000"/>
-              </a:schemeClr>
-            </a:gs>
-          </a:gsLst>
-          <a:path path="circle">
-            <a:fillToRect l="50000" t="50000" r="50000" b="50000"/>
-          </a:path>
-        </a:gradFill>
-      </a:bgFillStyleLst>
-    </a:fmtScheme>
-  </a:themeElements>
-</a:theme>
 </file>
</xml_diff>

<commit_message>
Publish YouTube demo link and final submission deck exports
</commit_message>
<xml_diff>
--- a/docs/submission/BatchLens-Pitch-Review.pptx
+++ b/docs/submission/BatchLens-Pitch-Review.pptx
@@ -9231,7 +9231,20 @@
                 <a:cs typeface="Google Sans Flex Medium"/>
                 <a:sym typeface="Google Sans Flex Medium"/>
               </a:rPr>
-              <a:t>GitHub: https://github.com/mk-tdev/BatchLens</a:t>
+              <a:t>GitHub: </a:t>
+            </a:r>
+            <a:r>
+              <a:rPr lang="en-GB" u="sng">
+                <a:solidFill>
+                  <a:schemeClr val="hlink"/>
+                </a:solidFill>
+                <a:latin typeface="Google Sans Flex Medium"/>
+                <a:ea typeface="Google Sans Flex Medium"/>
+                <a:cs typeface="Google Sans Flex Medium"/>
+                <a:sym typeface="Google Sans Flex Medium"/>
+                <a:hlinkClick r:id="rId5"/>
+              </a:rPr>
+              <a:t>https://github.com/mk-tdev/BatchLens</a:t>
             </a:r>
             <a:endParaRPr>
               <a:solidFill>
@@ -9268,7 +9281,20 @@
                 <a:cs typeface="Google Sans Flex Medium"/>
                 <a:sym typeface="Google Sans Flex Medium"/>
               </a:rPr>
-              <a:t>Demo video: recording link pending</a:t>
+              <a:t>Demo video: </a:t>
+            </a:r>
+            <a:r>
+              <a:rPr lang="en-GB" u="sng">
+                <a:solidFill>
+                  <a:schemeClr val="hlink"/>
+                </a:solidFill>
+                <a:latin typeface="Google Sans Flex Medium"/>
+                <a:ea typeface="Google Sans Flex Medium"/>
+                <a:cs typeface="Google Sans Flex Medium"/>
+                <a:sym typeface="Google Sans Flex Medium"/>
+                <a:hlinkClick r:id="rId6"/>
+              </a:rPr>
+              <a:t>https://youtu.be/aosveR1UzOM</a:t>
             </a:r>
             <a:endParaRPr>
               <a:solidFill>
@@ -9305,7 +9331,20 @@
                 <a:cs typeface="Google Sans Flex Medium"/>
                 <a:sym typeface="Google Sans Flex Medium"/>
               </a:rPr>
-              <a:t>Live: https://batchlens-hk3hxwi5na-as.a.run.app/</a:t>
+              <a:t>Live: </a:t>
+            </a:r>
+            <a:r>
+              <a:rPr lang="en-GB" u="sng">
+                <a:solidFill>
+                  <a:schemeClr val="hlink"/>
+                </a:solidFill>
+                <a:latin typeface="Google Sans Flex Medium"/>
+                <a:ea typeface="Google Sans Flex Medium"/>
+                <a:cs typeface="Google Sans Flex Medium"/>
+                <a:sym typeface="Google Sans Flex Medium"/>
+                <a:hlinkClick r:id="rId7"/>
+              </a:rPr>
+              <a:t>https://batchlens-hk3hxwi5na-as.a.run.app/</a:t>
             </a:r>
             <a:endParaRPr>
               <a:solidFill>
@@ -14224,7 +14263,7 @@
             <a:tbl>
               <a:tblPr>
                 <a:noFill/>
-                <a:tableStyleId>{A81D6702-DE3E-4CE6-B1CF-562C7AAFA617}</a:tableStyleId>
+                <a:tableStyleId>{16901800-F74E-40F8-9D84-CF7F7C739A23}</a:tableStyleId>
               </a:tblPr>
               <a:tblGrid>
                 <a:gridCol w="1917700"/>

</xml_diff>